<commit_message>
docs: resync figure numbering from Drive decks (2026-10-09)
Decks pulled from Drive and changed:
- Fig R2: 6 -> 8 slides. Old slide 1 split into slides 1 (CGI, with
  new CpG o/e decile panel and full caption), 2 (TATA) and 3 (CCAAT +
  GC-box); remaining slides shifted +2. Matches the numbering already
  committed in 6cbb133 (R2.1-R2.4, R2.6, R2.8), so no CSV changes.
- Fig MyM: slide 11 images (4 panels) replaced by a single composite
  image; text unchanged, numbering unchanged.
- Fig R1, Fig R3: slide text and embedded images identical; only
  export-level re-encoding of media/rels. No numbering changes.

No mapping_figuras.csv edits and no figures/ folder renames.

Co-Authored-By: Claude Opus 5.5 <noreply@anthropic.com>
</commit_message>
<xml_diff>
--- a/docs/Fig R1.pptx
+++ b/docs/Fig R1.pptx
@@ -7415,7 +7415,7 @@
         </p:blipFill>
         <p:spPr>
           <a:xfrm>
-            <a:off x="3495175" y="152400"/>
+            <a:off x="3438900" y="163655"/>
             <a:ext cx="1858876" cy="2461777"/>
           </a:xfrm>
           <a:prstGeom prst="rect">
@@ -7435,7 +7435,7 @@
         </p:nvSpPr>
         <p:spPr>
           <a:xfrm>
-            <a:off x="3217016" y="2598167"/>
+            <a:off x="3160742" y="2609422"/>
             <a:ext cx="2073000" cy="523200"/>
           </a:xfrm>
           <a:prstGeom prst="rect">
@@ -7509,7 +7509,7 @@
         </p:nvSpPr>
         <p:spPr>
           <a:xfrm>
-            <a:off x="4604304" y="2614179"/>
+            <a:off x="4548029" y="2625434"/>
             <a:ext cx="928500" cy="523200"/>
           </a:xfrm>
           <a:prstGeom prst="rect">

</xml_diff>

<commit_message>
docs: update figure decks (MyM, R1, R2, R3)
Co-Authored-By: Claude Opus 5.5 <noreply@anthropic.com>
</commit_message>
<xml_diff>
--- a/docs/Fig R1.pptx
+++ b/docs/Fig R1.pptx
@@ -9058,6 +9058,285 @@
 </file>
 
 <file path=ppt/theme/theme1.xml><?xml version="1.0" encoding="utf-8"?>
+<a:theme xmlns:a="http://schemas.openxmlformats.org/drawingml/2006/main" xmlns:r="http://schemas.openxmlformats.org/officeDocument/2006/relationships" name="Simple Light">
+  <a:themeElements>
+    <a:clrScheme name="Simple Light">
+      <a:dk1>
+        <a:srgbClr val="000000"/>
+      </a:dk1>
+      <a:lt1>
+        <a:srgbClr val="FFFFFF"/>
+      </a:lt1>
+      <a:dk2>
+        <a:srgbClr val="595959"/>
+      </a:dk2>
+      <a:lt2>
+        <a:srgbClr val="EEEEEE"/>
+      </a:lt2>
+      <a:accent1>
+        <a:srgbClr val="4285F4"/>
+      </a:accent1>
+      <a:accent2>
+        <a:srgbClr val="212121"/>
+      </a:accent2>
+      <a:accent3>
+        <a:srgbClr val="78909C"/>
+      </a:accent3>
+      <a:accent4>
+        <a:srgbClr val="FFAB40"/>
+      </a:accent4>
+      <a:accent5>
+        <a:srgbClr val="0097A7"/>
+      </a:accent5>
+      <a:accent6>
+        <a:srgbClr val="EEFF41"/>
+      </a:accent6>
+      <a:hlink>
+        <a:srgbClr val="0097A7"/>
+      </a:hlink>
+      <a:folHlink>
+        <a:srgbClr val="0097A7"/>
+      </a:folHlink>
+    </a:clrScheme>
+    <a:fontScheme name="Office">
+      <a:majorFont>
+        <a:latin typeface="Arial"/>
+        <a:ea typeface=""/>
+        <a:cs typeface=""/>
+        <a:font script="Jpan" typeface="ＭＳ Ｐゴシック"/>
+        <a:font script="Hang" typeface="맑은 고딕"/>
+        <a:font script="Hans" typeface="宋体"/>
+        <a:font script="Hant" typeface="新細明體"/>
+        <a:font script="Arab" typeface="Times New Roman"/>
+        <a:font script="Hebr" typeface="Times New Roman"/>
+        <a:font script="Thai" typeface="Angsana New"/>
+        <a:font script="Ethi" typeface="Nyala"/>
+        <a:font script="Beng" typeface="Vrinda"/>
+        <a:font script="Gujr" typeface="Shruti"/>
+        <a:font script="Khmr" typeface="MoolBoran"/>
+        <a:font script="Knda" typeface="Tunga"/>
+        <a:font script="Guru" typeface="Raavi"/>
+        <a:font script="Cans" typeface="Euphemia"/>
+        <a:font script="Cher" typeface="Plantagenet Cherokee"/>
+        <a:font script="Yiii" typeface="Microsoft Yi Baiti"/>
+        <a:font script="Tibt" typeface="Microsoft Himalaya"/>
+        <a:font script="Thaa" typeface="MV Boli"/>
+        <a:font script="Deva" typeface="Mangal"/>
+        <a:font script="Telu" typeface="Gautami"/>
+        <a:font script="Taml" typeface="Latha"/>
+        <a:font script="Syrc" typeface="Estrangelo Edessa"/>
+        <a:font script="Orya" typeface="Kalinga"/>
+        <a:font script="Mlym" typeface="Kartika"/>
+        <a:font script="Laoo" typeface="DokChampa"/>
+        <a:font script="Sinh" typeface="Iskoola Pota"/>
+        <a:font script="Mong" typeface="Mongolian Baiti"/>
+        <a:font script="Viet" typeface="Times New Roman"/>
+        <a:font script="Uigh" typeface="Microsoft Uighur"/>
+        <a:font script="Geor" typeface="Sylfaen"/>
+      </a:majorFont>
+      <a:minorFont>
+        <a:latin typeface="Arial"/>
+        <a:ea typeface=""/>
+        <a:cs typeface=""/>
+        <a:font script="Jpan" typeface="ＭＳ Ｐゴシック"/>
+        <a:font script="Hang" typeface="맑은 고딕"/>
+        <a:font script="Hans" typeface="宋体"/>
+        <a:font script="Hant" typeface="新細明體"/>
+        <a:font script="Arab" typeface="Arial"/>
+        <a:font script="Hebr" typeface="Arial"/>
+        <a:font script="Thai" typeface="Cordia New"/>
+        <a:font script="Ethi" typeface="Nyala"/>
+        <a:font script="Beng" typeface="Vrinda"/>
+        <a:font script="Gujr" typeface="Shruti"/>
+        <a:font script="Khmr" typeface="DaunPenh"/>
+        <a:font script="Knda" typeface="Tunga"/>
+        <a:font script="Guru" typeface="Raavi"/>
+        <a:font script="Cans" typeface="Euphemia"/>
+        <a:font script="Cher" typeface="Plantagenet Cherokee"/>
+        <a:font script="Yiii" typeface="Microsoft Yi Baiti"/>
+        <a:font script="Tibt" typeface="Microsoft Himalaya"/>
+        <a:font script="Thaa" typeface="MV Boli"/>
+        <a:font script="Deva" typeface="Mangal"/>
+        <a:font script="Telu" typeface="Gautami"/>
+        <a:font script="Taml" typeface="Latha"/>
+        <a:font script="Syrc" typeface="Estrangelo Edessa"/>
+        <a:font script="Orya" typeface="Kalinga"/>
+        <a:font script="Mlym" typeface="Kartika"/>
+        <a:font script="Laoo" typeface="DokChampa"/>
+        <a:font script="Sinh" typeface="Iskoola Pota"/>
+        <a:font script="Mong" typeface="Mongolian Baiti"/>
+        <a:font script="Viet" typeface="Arial"/>
+        <a:font script="Uigh" typeface="Microsoft Uighur"/>
+        <a:font script="Geor" typeface="Sylfaen"/>
+      </a:minorFont>
+    </a:fontScheme>
+    <a:fmtScheme name="Office">
+      <a:fillStyleLst>
+        <a:solidFill>
+          <a:schemeClr val="phClr"/>
+        </a:solidFill>
+        <a:gradFill rotWithShape="1">
+          <a:gsLst>
+            <a:gs pos="0">
+              <a:schemeClr val="phClr">
+                <a:tint val="50000"/>
+                <a:satMod val="300000"/>
+              </a:schemeClr>
+            </a:gs>
+            <a:gs pos="35000">
+              <a:schemeClr val="phClr">
+                <a:tint val="37000"/>
+                <a:satMod val="300000"/>
+              </a:schemeClr>
+            </a:gs>
+            <a:gs pos="100000">
+              <a:schemeClr val="phClr">
+                <a:tint val="15000"/>
+                <a:satMod val="350000"/>
+              </a:schemeClr>
+            </a:gs>
+          </a:gsLst>
+          <a:lin ang="16200000" scaled="1"/>
+        </a:gradFill>
+        <a:gradFill rotWithShape="1">
+          <a:gsLst>
+            <a:gs pos="0">
+              <a:schemeClr val="phClr">
+                <a:tint val="100000"/>
+                <a:shade val="100000"/>
+                <a:satMod val="130000"/>
+              </a:schemeClr>
+            </a:gs>
+            <a:gs pos="100000">
+              <a:schemeClr val="phClr">
+                <a:tint val="50000"/>
+                <a:shade val="100000"/>
+                <a:satMod val="350000"/>
+              </a:schemeClr>
+            </a:gs>
+          </a:gsLst>
+          <a:lin ang="16200000" scaled="0"/>
+        </a:gradFill>
+      </a:fillStyleLst>
+      <a:lnStyleLst>
+        <a:ln w="9525" cap="flat" cmpd="sng" algn="ctr">
+          <a:solidFill>
+            <a:schemeClr val="phClr">
+              <a:shade val="95000"/>
+              <a:satMod val="105000"/>
+            </a:schemeClr>
+          </a:solidFill>
+          <a:prstDash val="solid"/>
+        </a:ln>
+        <a:ln w="25400" cap="flat" cmpd="sng" algn="ctr">
+          <a:solidFill>
+            <a:schemeClr val="phClr"/>
+          </a:solidFill>
+          <a:prstDash val="solid"/>
+        </a:ln>
+        <a:ln w="38100" cap="flat" cmpd="sng" algn="ctr">
+          <a:solidFill>
+            <a:schemeClr val="phClr"/>
+          </a:solidFill>
+          <a:prstDash val="solid"/>
+        </a:ln>
+      </a:lnStyleLst>
+      <a:effectStyleLst>
+        <a:effectStyle>
+          <a:effectLst>
+            <a:outerShdw blurRad="40000" dist="20000" dir="5400000" rotWithShape="0">
+              <a:srgbClr val="000000">
+                <a:alpha val="38000"/>
+              </a:srgbClr>
+            </a:outerShdw>
+          </a:effectLst>
+        </a:effectStyle>
+        <a:effectStyle>
+          <a:effectLst>
+            <a:outerShdw blurRad="40000" dist="23000" dir="5400000" rotWithShape="0">
+              <a:srgbClr val="000000">
+                <a:alpha val="35000"/>
+              </a:srgbClr>
+            </a:outerShdw>
+          </a:effectLst>
+        </a:effectStyle>
+        <a:effectStyle>
+          <a:effectLst>
+            <a:outerShdw blurRad="40000" dist="23000" dir="5400000" rotWithShape="0">
+              <a:srgbClr val="000000">
+                <a:alpha val="35000"/>
+              </a:srgbClr>
+            </a:outerShdw>
+          </a:effectLst>
+          <a:scene3d>
+            <a:camera prst="orthographicFront">
+              <a:rot lat="0" lon="0" rev="0"/>
+            </a:camera>
+            <a:lightRig rig="threePt" dir="t">
+              <a:rot lat="0" lon="0" rev="1200000"/>
+            </a:lightRig>
+          </a:scene3d>
+          <a:sp3d>
+            <a:bevelT w="63500" h="25400"/>
+          </a:sp3d>
+        </a:effectStyle>
+      </a:effectStyleLst>
+      <a:bgFillStyleLst>
+        <a:solidFill>
+          <a:schemeClr val="phClr"/>
+        </a:solidFill>
+        <a:gradFill rotWithShape="1">
+          <a:gsLst>
+            <a:gs pos="0">
+              <a:schemeClr val="phClr">
+                <a:tint val="40000"/>
+                <a:satMod val="350000"/>
+              </a:schemeClr>
+            </a:gs>
+            <a:gs pos="40000">
+              <a:schemeClr val="phClr">
+                <a:tint val="45000"/>
+                <a:shade val="99000"/>
+                <a:satMod val="350000"/>
+              </a:schemeClr>
+            </a:gs>
+            <a:gs pos="100000">
+              <a:schemeClr val="phClr">
+                <a:shade val="20000"/>
+                <a:satMod val="255000"/>
+              </a:schemeClr>
+            </a:gs>
+          </a:gsLst>
+          <a:path path="circle">
+            <a:fillToRect l="50000" t="-80000" r="50000" b="180000"/>
+          </a:path>
+        </a:gradFill>
+        <a:gradFill rotWithShape="1">
+          <a:gsLst>
+            <a:gs pos="0">
+              <a:schemeClr val="phClr">
+                <a:tint val="80000"/>
+                <a:satMod val="300000"/>
+              </a:schemeClr>
+            </a:gs>
+            <a:gs pos="100000">
+              <a:schemeClr val="phClr">
+                <a:shade val="30000"/>
+                <a:satMod val="200000"/>
+              </a:schemeClr>
+            </a:gs>
+          </a:gsLst>
+          <a:path path="circle">
+            <a:fillToRect l="50000" t="50000" r="50000" b="50000"/>
+          </a:path>
+        </a:gradFill>
+      </a:bgFillStyleLst>
+    </a:fmtScheme>
+  </a:themeElements>
+</a:theme>
+</file>
+
+<file path=ppt/theme/theme2.xml><?xml version="1.0" encoding="utf-8"?>
 <a:theme xmlns:a="http://schemas.openxmlformats.org/drawingml/2006/main" xmlns:r="http://schemas.openxmlformats.org/officeDocument/2006/relationships">
   <a:themeElements>
     <a:clrScheme name="Default">
@@ -9334,283 +9613,4 @@
     </a:fmtScheme>
   </a:themeElements>
 </a:theme>
-</file>
-
-<file path=ppt/theme/theme2.xml><?xml version="1.0" encoding="utf-8"?>
-<a:theme xmlns:a="http://schemas.openxmlformats.org/drawingml/2006/main" xmlns:r="http://schemas.openxmlformats.org/officeDocument/2006/relationships" name="Simple Light">
-  <a:themeElements>
-    <a:clrScheme name="Simple Light">
-      <a:dk1>
-        <a:srgbClr val="000000"/>
-      </a:dk1>
-      <a:lt1>
-        <a:srgbClr val="FFFFFF"/>
-      </a:lt1>
-      <a:dk2>
-        <a:srgbClr val="595959"/>
-      </a:dk2>
-      <a:lt2>
-        <a:srgbClr val="EEEEEE"/>
-      </a:lt2>
-      <a:accent1>
-        <a:srgbClr val="4285F4"/>
-      </a:accent1>
-      <a:accent2>
-        <a:srgbClr val="212121"/>
-      </a:accent2>
-      <a:accent3>
-        <a:srgbClr val="78909C"/>
-      </a:accent3>
-      <a:accent4>
-        <a:srgbClr val="FFAB40"/>
-      </a:accent4>
-      <a:accent5>
-        <a:srgbClr val="0097A7"/>
-      </a:accent5>
-      <a:accent6>
-        <a:srgbClr val="EEFF41"/>
-      </a:accent6>
-      <a:hlink>
-        <a:srgbClr val="0097A7"/>
-      </a:hlink>
-      <a:folHlink>
-        <a:srgbClr val="0097A7"/>
-      </a:folHlink>
-    </a:clrScheme>
-    <a:fontScheme name="Office">
-      <a:majorFont>
-        <a:latin typeface="Arial"/>
-        <a:ea typeface=""/>
-        <a:cs typeface=""/>
-        <a:font script="Jpan" typeface="ＭＳ Ｐゴシック"/>
-        <a:font script="Hang" typeface="맑은 고딕"/>
-        <a:font script="Hans" typeface="宋体"/>
-        <a:font script="Hant" typeface="新細明體"/>
-        <a:font script="Arab" typeface="Times New Roman"/>
-        <a:font script="Hebr" typeface="Times New Roman"/>
-        <a:font script="Thai" typeface="Angsana New"/>
-        <a:font script="Ethi" typeface="Nyala"/>
-        <a:font script="Beng" typeface="Vrinda"/>
-        <a:font script="Gujr" typeface="Shruti"/>
-        <a:font script="Khmr" typeface="MoolBoran"/>
-        <a:font script="Knda" typeface="Tunga"/>
-        <a:font script="Guru" typeface="Raavi"/>
-        <a:font script="Cans" typeface="Euphemia"/>
-        <a:font script="Cher" typeface="Plantagenet Cherokee"/>
-        <a:font script="Yiii" typeface="Microsoft Yi Baiti"/>
-        <a:font script="Tibt" typeface="Microsoft Himalaya"/>
-        <a:font script="Thaa" typeface="MV Boli"/>
-        <a:font script="Deva" typeface="Mangal"/>
-        <a:font script="Telu" typeface="Gautami"/>
-        <a:font script="Taml" typeface="Latha"/>
-        <a:font script="Syrc" typeface="Estrangelo Edessa"/>
-        <a:font script="Orya" typeface="Kalinga"/>
-        <a:font script="Mlym" typeface="Kartika"/>
-        <a:font script="Laoo" typeface="DokChampa"/>
-        <a:font script="Sinh" typeface="Iskoola Pota"/>
-        <a:font script="Mong" typeface="Mongolian Baiti"/>
-        <a:font script="Viet" typeface="Times New Roman"/>
-        <a:font script="Uigh" typeface="Microsoft Uighur"/>
-        <a:font script="Geor" typeface="Sylfaen"/>
-      </a:majorFont>
-      <a:minorFont>
-        <a:latin typeface="Arial"/>
-        <a:ea typeface=""/>
-        <a:cs typeface=""/>
-        <a:font script="Jpan" typeface="ＭＳ Ｐゴシック"/>
-        <a:font script="Hang" typeface="맑은 고딕"/>
-        <a:font script="Hans" typeface="宋体"/>
-        <a:font script="Hant" typeface="新細明體"/>
-        <a:font script="Arab" typeface="Arial"/>
-        <a:font script="Hebr" typeface="Arial"/>
-        <a:font script="Thai" typeface="Cordia New"/>
-        <a:font script="Ethi" typeface="Nyala"/>
-        <a:font script="Beng" typeface="Vrinda"/>
-        <a:font script="Gujr" typeface="Shruti"/>
-        <a:font script="Khmr" typeface="DaunPenh"/>
-        <a:font script="Knda" typeface="Tunga"/>
-        <a:font script="Guru" typeface="Raavi"/>
-        <a:font script="Cans" typeface="Euphemia"/>
-        <a:font script="Cher" typeface="Plantagenet Cherokee"/>
-        <a:font script="Yiii" typeface="Microsoft Yi Baiti"/>
-        <a:font script="Tibt" typeface="Microsoft Himalaya"/>
-        <a:font script="Thaa" typeface="MV Boli"/>
-        <a:font script="Deva" typeface="Mangal"/>
-        <a:font script="Telu" typeface="Gautami"/>
-        <a:font script="Taml" typeface="Latha"/>
-        <a:font script="Syrc" typeface="Estrangelo Edessa"/>
-        <a:font script="Orya" typeface="Kalinga"/>
-        <a:font script="Mlym" typeface="Kartika"/>
-        <a:font script="Laoo" typeface="DokChampa"/>
-        <a:font script="Sinh" typeface="Iskoola Pota"/>
-        <a:font script="Mong" typeface="Mongolian Baiti"/>
-        <a:font script="Viet" typeface="Arial"/>
-        <a:font script="Uigh" typeface="Microsoft Uighur"/>
-        <a:font script="Geor" typeface="Sylfaen"/>
-      </a:minorFont>
-    </a:fontScheme>
-    <a:fmtScheme name="Office">
-      <a:fillStyleLst>
-        <a:solidFill>
-          <a:schemeClr val="phClr"/>
-        </a:solidFill>
-        <a:gradFill rotWithShape="1">
-          <a:gsLst>
-            <a:gs pos="0">
-              <a:schemeClr val="phClr">
-                <a:tint val="50000"/>
-                <a:satMod val="300000"/>
-              </a:schemeClr>
-            </a:gs>
-            <a:gs pos="35000">
-              <a:schemeClr val="phClr">
-                <a:tint val="37000"/>
-                <a:satMod val="300000"/>
-              </a:schemeClr>
-            </a:gs>
-            <a:gs pos="100000">
-              <a:schemeClr val="phClr">
-                <a:tint val="15000"/>
-                <a:satMod val="350000"/>
-              </a:schemeClr>
-            </a:gs>
-          </a:gsLst>
-          <a:lin ang="16200000" scaled="1"/>
-        </a:gradFill>
-        <a:gradFill rotWithShape="1">
-          <a:gsLst>
-            <a:gs pos="0">
-              <a:schemeClr val="phClr">
-                <a:tint val="100000"/>
-                <a:shade val="100000"/>
-                <a:satMod val="130000"/>
-              </a:schemeClr>
-            </a:gs>
-            <a:gs pos="100000">
-              <a:schemeClr val="phClr">
-                <a:tint val="50000"/>
-                <a:shade val="100000"/>
-                <a:satMod val="350000"/>
-              </a:schemeClr>
-            </a:gs>
-          </a:gsLst>
-          <a:lin ang="16200000" scaled="0"/>
-        </a:gradFill>
-      </a:fillStyleLst>
-      <a:lnStyleLst>
-        <a:ln w="9525" cap="flat" cmpd="sng" algn="ctr">
-          <a:solidFill>
-            <a:schemeClr val="phClr">
-              <a:shade val="95000"/>
-              <a:satMod val="105000"/>
-            </a:schemeClr>
-          </a:solidFill>
-          <a:prstDash val="solid"/>
-        </a:ln>
-        <a:ln w="25400" cap="flat" cmpd="sng" algn="ctr">
-          <a:solidFill>
-            <a:schemeClr val="phClr"/>
-          </a:solidFill>
-          <a:prstDash val="solid"/>
-        </a:ln>
-        <a:ln w="38100" cap="flat" cmpd="sng" algn="ctr">
-          <a:solidFill>
-            <a:schemeClr val="phClr"/>
-          </a:solidFill>
-          <a:prstDash val="solid"/>
-        </a:ln>
-      </a:lnStyleLst>
-      <a:effectStyleLst>
-        <a:effectStyle>
-          <a:effectLst>
-            <a:outerShdw blurRad="40000" dist="20000" dir="5400000" rotWithShape="0">
-              <a:srgbClr val="000000">
-                <a:alpha val="38000"/>
-              </a:srgbClr>
-            </a:outerShdw>
-          </a:effectLst>
-        </a:effectStyle>
-        <a:effectStyle>
-          <a:effectLst>
-            <a:outerShdw blurRad="40000" dist="23000" dir="5400000" rotWithShape="0">
-              <a:srgbClr val="000000">
-                <a:alpha val="35000"/>
-              </a:srgbClr>
-            </a:outerShdw>
-          </a:effectLst>
-        </a:effectStyle>
-        <a:effectStyle>
-          <a:effectLst>
-            <a:outerShdw blurRad="40000" dist="23000" dir="5400000" rotWithShape="0">
-              <a:srgbClr val="000000">
-                <a:alpha val="35000"/>
-              </a:srgbClr>
-            </a:outerShdw>
-          </a:effectLst>
-          <a:scene3d>
-            <a:camera prst="orthographicFront">
-              <a:rot lat="0" lon="0" rev="0"/>
-            </a:camera>
-            <a:lightRig rig="threePt" dir="t">
-              <a:rot lat="0" lon="0" rev="1200000"/>
-            </a:lightRig>
-          </a:scene3d>
-          <a:sp3d>
-            <a:bevelT w="63500" h="25400"/>
-          </a:sp3d>
-        </a:effectStyle>
-      </a:effectStyleLst>
-      <a:bgFillStyleLst>
-        <a:solidFill>
-          <a:schemeClr val="phClr"/>
-        </a:solidFill>
-        <a:gradFill rotWithShape="1">
-          <a:gsLst>
-            <a:gs pos="0">
-              <a:schemeClr val="phClr">
-                <a:tint val="40000"/>
-                <a:satMod val="350000"/>
-              </a:schemeClr>
-            </a:gs>
-            <a:gs pos="40000">
-              <a:schemeClr val="phClr">
-                <a:tint val="45000"/>
-                <a:shade val="99000"/>
-                <a:satMod val="350000"/>
-              </a:schemeClr>
-            </a:gs>
-            <a:gs pos="100000">
-              <a:schemeClr val="phClr">
-                <a:shade val="20000"/>
-                <a:satMod val="255000"/>
-              </a:schemeClr>
-            </a:gs>
-          </a:gsLst>
-          <a:path path="circle">
-            <a:fillToRect l="50000" t="-80000" r="50000" b="180000"/>
-          </a:path>
-        </a:gradFill>
-        <a:gradFill rotWithShape="1">
-          <a:gsLst>
-            <a:gs pos="0">
-              <a:schemeClr val="phClr">
-                <a:tint val="80000"/>
-                <a:satMod val="300000"/>
-              </a:schemeClr>
-            </a:gs>
-            <a:gs pos="100000">
-              <a:schemeClr val="phClr">
-                <a:shade val="30000"/>
-                <a:satMod val="200000"/>
-              </a:schemeClr>
-            </a:gs>
-          </a:gsLst>
-          <a:path path="circle">
-            <a:fillToRect l="50000" t="50000" r="50000" b="50000"/>
-          </a:path>
-        </a:gradFill>
-      </a:bgFillStyleLst>
-    </a:fmtScheme>
-  </a:themeElements>
-</a:theme>
 </file>
</xml_diff>

<commit_message>
docs: resync figure numbering from Drive decks (2026-10-19)
Changed decks: Fig MyM, Fig R1, Fig R2 (Fig R3: export noise only).
No slug number changes; no figure folders renamed.

mapping_figuras.csv:
- remap_tf_activity_gsea: leyenda_lista no -> si (legend added to slide)
- summary_features_endogeno: estado -> revisar (slide panel B is
  exploratorio_contexto_ajustado/secuencia_crudo_vs_ajustado.jpg, not
  summary_endo_ajustado_secuencia.jpg)
- tf_nfya_sp_contexto_endogeno / nfy_especificidad: slide legend now
  describes nfy_especificidad panels but images don't match exactly;
  both flagged revisar, number not reassigned

Co-Authored-By: Claude Opus 5.5 <noreply@anthropic.com>
</commit_message>
<xml_diff>
--- a/docs/Fig R1.pptx
+++ b/docs/Fig R1.pptx
@@ -15,16 +15,17 @@
     <p:sldId id="260" r:id="rId10"/>
     <p:sldId id="261" r:id="rId11"/>
     <p:sldId id="262" r:id="rId12"/>
+    <p:sldId id="263" r:id="rId13"/>
   </p:sldIdLst>
   <p:sldSz cy="5143500" cx="9144000"/>
   <p:notesSz cx="6858000" cy="9144000"/>
   <p:embeddedFontLst>
     <p:embeddedFont>
       <p:font typeface="Roboto"/>
-      <p:regular r:id="rId13"/>
-      <p:bold r:id="rId14"/>
-      <p:italic r:id="rId15"/>
-      <p:boldItalic r:id="rId16"/>
+      <p:regular r:id="rId14"/>
+      <p:bold r:id="rId15"/>
+      <p:italic r:id="rId16"/>
+      <p:boldItalic r:id="rId17"/>
     </p:embeddedFont>
   </p:embeddedFontLst>
   <p:defaultTextStyle>
@@ -720,7 +721,7 @@
       </p:grpSpPr>
       <p:sp>
         <p:nvSpPr>
-          <p:cNvPr id="51" name="Google Shape;51;g3d678bf7346_0_0:notes"/>
+          <p:cNvPr id="51" name="Google Shape;51;h8824fc79a96d018_0_0:notes"/>
           <p:cNvSpPr/>
           <p:nvPr>
             <p:ph idx="2" type="sldImg"/>
@@ -755,7 +756,7 @@
       </p:sp>
       <p:sp>
         <p:nvSpPr>
-          <p:cNvPr id="52" name="Google Shape;52;g3d678bf7346_0_0:notes"/>
+          <p:cNvPr id="52" name="Google Shape;52;h8824fc79a96d018_0_0:notes"/>
           <p:cNvSpPr txBox="1"/>
           <p:nvPr>
             <p:ph idx="1" type="body"/>
@@ -805,7 +806,7 @@
   <p:cSld>
     <p:spTree>
       <p:nvGrpSpPr>
-        <p:cNvPr id="66" name="Shape 66"/>
+        <p:cNvPr id="56" name="Shape 56"/>
         <p:cNvGrpSpPr/>
         <p:nvPr/>
       </p:nvGrpSpPr>
@@ -819,7 +820,7 @@
       </p:grpSpPr>
       <p:sp>
         <p:nvSpPr>
-          <p:cNvPr id="67" name="Google Shape;67;g3d678bf7346_0_8:notes"/>
+          <p:cNvPr id="57" name="Google Shape;57;g3d678bf7346_0_0:notes"/>
           <p:cNvSpPr/>
           <p:nvPr>
             <p:ph idx="2" type="sldImg"/>
@@ -854,7 +855,7 @@
       </p:sp>
       <p:sp>
         <p:nvSpPr>
-          <p:cNvPr id="68" name="Google Shape;68;g3d678bf7346_0_8:notes"/>
+          <p:cNvPr id="58" name="Google Shape;58;g3d678bf7346_0_0:notes"/>
           <p:cNvSpPr txBox="1"/>
           <p:nvPr>
             <p:ph idx="1" type="body"/>
@@ -904,7 +905,7 @@
   <p:cSld>
     <p:spTree>
       <p:nvGrpSpPr>
-        <p:cNvPr id="89" name="Shape 89"/>
+        <p:cNvPr id="72" name="Shape 72"/>
         <p:cNvGrpSpPr/>
         <p:nvPr/>
       </p:nvGrpSpPr>
@@ -918,7 +919,7 @@
       </p:grpSpPr>
       <p:sp>
         <p:nvSpPr>
-          <p:cNvPr id="90" name="Google Shape;90;g396169342f1_0_0:notes"/>
+          <p:cNvPr id="73" name="Google Shape;73;g3d678bf7346_0_8:notes"/>
           <p:cNvSpPr/>
           <p:nvPr>
             <p:ph idx="2" type="sldImg"/>
@@ -953,7 +954,7 @@
       </p:sp>
       <p:sp>
         <p:nvSpPr>
-          <p:cNvPr id="91" name="Google Shape;91;g396169342f1_0_0:notes"/>
+          <p:cNvPr id="74" name="Google Shape;74;g3d678bf7346_0_8:notes"/>
           <p:cNvSpPr txBox="1"/>
           <p:nvPr>
             <p:ph idx="1" type="body"/>
@@ -1017,7 +1018,7 @@
       </p:grpSpPr>
       <p:sp>
         <p:nvSpPr>
-          <p:cNvPr id="96" name="Google Shape;96;g3f5e045cd8f_0_8:notes"/>
+          <p:cNvPr id="96" name="Google Shape;96;g396169342f1_0_0:notes"/>
           <p:cNvSpPr/>
           <p:nvPr>
             <p:ph idx="2" type="sldImg"/>
@@ -1052,7 +1053,7 @@
       </p:sp>
       <p:sp>
         <p:nvSpPr>
-          <p:cNvPr id="97" name="Google Shape;97;g3f5e045cd8f_0_8:notes"/>
+          <p:cNvPr id="97" name="Google Shape;97;g396169342f1_0_0:notes"/>
           <p:cNvSpPr txBox="1"/>
           <p:nvPr>
             <p:ph idx="1" type="body"/>
@@ -1116,7 +1117,7 @@
       </p:grpSpPr>
       <p:sp>
         <p:nvSpPr>
-          <p:cNvPr id="102" name="Google Shape;102;g3f5e045cd8f_0_2:notes"/>
+          <p:cNvPr id="102" name="Google Shape;102;g3f5e045cd8f_0_8:notes"/>
           <p:cNvSpPr/>
           <p:nvPr>
             <p:ph idx="2" type="sldImg"/>
@@ -1151,7 +1152,7 @@
       </p:sp>
       <p:sp>
         <p:nvSpPr>
-          <p:cNvPr id="103" name="Google Shape;103;g3f5e045cd8f_0_2:notes"/>
+          <p:cNvPr id="103" name="Google Shape;103;g3f5e045cd8f_0_8:notes"/>
           <p:cNvSpPr txBox="1"/>
           <p:nvPr>
             <p:ph idx="1" type="body"/>
@@ -1215,7 +1216,7 @@
       </p:grpSpPr>
       <p:sp>
         <p:nvSpPr>
-          <p:cNvPr id="108" name="Google Shape;108;g3d678bf7346_0_23:notes"/>
+          <p:cNvPr id="108" name="Google Shape;108;g3f5e045cd8f_0_2:notes"/>
           <p:cNvSpPr/>
           <p:nvPr>
             <p:ph idx="2" type="sldImg"/>
@@ -1250,7 +1251,7 @@
       </p:sp>
       <p:sp>
         <p:nvSpPr>
-          <p:cNvPr id="109" name="Google Shape;109;g3d678bf7346_0_23:notes"/>
+          <p:cNvPr id="109" name="Google Shape;109;g3f5e045cd8f_0_2:notes"/>
           <p:cNvSpPr txBox="1"/>
           <p:nvPr>
             <p:ph idx="1" type="body"/>
@@ -1300,7 +1301,7 @@
   <p:cSld>
     <p:spTree>
       <p:nvGrpSpPr>
-        <p:cNvPr id="115" name="Shape 115"/>
+        <p:cNvPr id="113" name="Shape 113"/>
         <p:cNvGrpSpPr/>
         <p:nvPr/>
       </p:nvGrpSpPr>
@@ -1314,7 +1315,7 @@
       </p:grpSpPr>
       <p:sp>
         <p:nvSpPr>
-          <p:cNvPr id="116" name="Google Shape;116;g3d678bf7346_0_17:notes"/>
+          <p:cNvPr id="114" name="Google Shape;114;g3d678bf7346_0_23:notes"/>
           <p:cNvSpPr/>
           <p:nvPr>
             <p:ph idx="2" type="sldImg"/>
@@ -1349,7 +1350,106 @@
       </p:sp>
       <p:sp>
         <p:nvSpPr>
-          <p:cNvPr id="117" name="Google Shape;117;g3d678bf7346_0_17:notes"/>
+          <p:cNvPr id="115" name="Google Shape;115;g3d678bf7346_0_23:notes"/>
+          <p:cNvSpPr txBox="1"/>
+          <p:nvPr>
+            <p:ph idx="1" type="body"/>
+          </p:nvPr>
+        </p:nvSpPr>
+        <p:spPr>
+          <a:xfrm>
+            <a:off x="685800" y="4343400"/>
+            <a:ext cx="5486400" cy="4114800"/>
+          </a:xfrm>
+          <a:prstGeom prst="rect">
+            <a:avLst/>
+          </a:prstGeom>
+        </p:spPr>
+        <p:txBody>
+          <a:bodyPr anchorCtr="0" anchor="t" bIns="91425" lIns="91425" spcFirstLastPara="1" rIns="91425" wrap="square" tIns="91425">
+            <a:noAutofit/>
+          </a:bodyPr>
+          <a:lstStyle/>
+          <a:p>
+            <a:pPr indent="0" lvl="0" marL="0" rtl="0" algn="l">
+              <a:spcBef>
+                <a:spcPts val="0"/>
+              </a:spcBef>
+              <a:spcAft>
+                <a:spcPts val="0"/>
+              </a:spcAft>
+              <a:buNone/>
+            </a:pPr>
+            <a:r>
+              <a:t/>
+            </a:r>
+            <a:endParaRPr/>
+          </a:p>
+        </p:txBody>
+      </p:sp>
+    </p:spTree>
+  </p:cSld>
+  <p:clrMapOvr>
+    <a:masterClrMapping/>
+  </p:clrMapOvr>
+</p:notes>
+</file>
+
+<file path=ppt/notesSlides/notesSlide8.xml><?xml version="1.0" encoding="utf-8"?>
+<p:notes xmlns:a="http://schemas.openxmlformats.org/drawingml/2006/main" xmlns:r="http://schemas.openxmlformats.org/officeDocument/2006/relationships" xmlns:mc="http://schemas.openxmlformats.org/markup-compatibility/2006" xmlns:mv="urn:schemas-microsoft-com:mac:vml" xmlns:p="http://schemas.openxmlformats.org/presentationml/2006/main" xmlns:c="http://schemas.openxmlformats.org/drawingml/2006/chart" xmlns:dgm="http://schemas.openxmlformats.org/drawingml/2006/diagram" xmlns:o="urn:schemas-microsoft-com:office:office" xmlns:v="urn:schemas-microsoft-com:vml" xmlns:pvml="urn:schemas-microsoft-com:office:powerpoint" xmlns:com="http://schemas.openxmlformats.org/drawingml/2006/compatibility" xmlns:p14="http://schemas.microsoft.com/office/powerpoint/2010/main" xmlns:p15="http://schemas.microsoft.com/office/powerpoint/2012/main" xmlns:ahyp="http://schemas.microsoft.com/office/drawing/2018/hyperlinkcolor" showMasterPhAnim="0" showMasterSp="0">
+  <p:cSld>
+    <p:spTree>
+      <p:nvGrpSpPr>
+        <p:cNvPr id="121" name="Shape 121"/>
+        <p:cNvGrpSpPr/>
+        <p:nvPr/>
+      </p:nvGrpSpPr>
+      <p:grpSpPr>
+        <a:xfrm>
+          <a:off x="0" y="0"/>
+          <a:ext cx="0" cy="0"/>
+          <a:chOff x="0" y="0"/>
+          <a:chExt cx="0" cy="0"/>
+        </a:xfrm>
+      </p:grpSpPr>
+      <p:sp>
+        <p:nvSpPr>
+          <p:cNvPr id="122" name="Google Shape;122;g3d678bf7346_0_17:notes"/>
+          <p:cNvSpPr/>
+          <p:nvPr>
+            <p:ph idx="2" type="sldImg"/>
+          </p:nvPr>
+        </p:nvSpPr>
+        <p:spPr>
+          <a:xfrm>
+            <a:off x="381300" y="685800"/>
+            <a:ext cx="6096000" cy="3429000"/>
+          </a:xfrm>
+          <a:custGeom>
+            <a:rect b="b" l="l" r="r" t="t"/>
+            <a:pathLst>
+              <a:path extrusionOk="0" h="120000" w="120000">
+                <a:moveTo>
+                  <a:pt x="0" y="0"/>
+                </a:moveTo>
+                <a:lnTo>
+                  <a:pt x="120000" y="0"/>
+                </a:lnTo>
+                <a:lnTo>
+                  <a:pt x="120000" y="120000"/>
+                </a:lnTo>
+                <a:lnTo>
+                  <a:pt x="0" y="120000"/>
+                </a:lnTo>
+                <a:close/>
+              </a:path>
+            </a:pathLst>
+          </a:custGeom>
+        </p:spPr>
+      </p:sp>
+      <p:sp>
+        <p:nvSpPr>
+          <p:cNvPr id="123" name="Google Shape;123;g3d678bf7346_0_17:notes"/>
           <p:cNvSpPr txBox="1"/>
           <p:nvPr>
             <p:ph idx="1" type="body"/>
@@ -6060,9 +6160,147 @@
           <a:chExt cx="0" cy="0"/>
         </a:xfrm>
       </p:grpSpPr>
+      <p:sp>
+        <p:nvSpPr>
+          <p:cNvPr id="54" name="Google Shape;54;p13"/>
+          <p:cNvSpPr txBox="1"/>
+          <p:nvPr/>
+        </p:nvSpPr>
+        <p:spPr>
+          <a:xfrm>
+            <a:off x="242725" y="4444225"/>
+            <a:ext cx="8832600" cy="1040400"/>
+          </a:xfrm>
+          <a:prstGeom prst="rect">
+            <a:avLst/>
+          </a:prstGeom>
+          <a:noFill/>
+          <a:ln>
+            <a:noFill/>
+          </a:ln>
+        </p:spPr>
+        <p:txBody>
+          <a:bodyPr anchorCtr="0" anchor="t" bIns="91425" lIns="91425" spcFirstLastPara="1" rIns="91425" wrap="square" tIns="91425">
+            <a:spAutoFit/>
+          </a:bodyPr>
+          <a:lstStyle/>
+          <a:p>
+            <a:pPr indent="0" lvl="0" marL="0" rtl="0" algn="l">
+              <a:lnSpc>
+                <a:spcPct val="115000"/>
+              </a:lnSpc>
+              <a:spcBef>
+                <a:spcPts val="0"/>
+              </a:spcBef>
+              <a:spcAft>
+                <a:spcPts val="0"/>
+              </a:spcAft>
+              <a:buClr>
+                <a:srgbClr val="000000"/>
+              </a:buClr>
+              <a:buSzPts val="1100"/>
+              <a:buFont typeface="Arial"/>
+              <a:buNone/>
+            </a:pPr>
+            <a:r>
+              <a:rPr b="1" lang="es-419" sz="1200">
+                <a:solidFill>
+                  <a:srgbClr val="595959"/>
+                </a:solidFill>
+              </a:rPr>
+              <a:t>Los niveles de ARN del reportero son consistentes con la fluorescencia de EGFP</a:t>
+            </a:r>
+            <a:r>
+              <a:rPr lang="es-419" sz="1200">
+                <a:solidFill>
+                  <a:srgbClr val="595959"/>
+                </a:solidFill>
+              </a:rPr>
+              <a:t>. Cuantificación por RT-qPCR del ARNm de EGFP en cada réplica. Cada punto representa una réplica técnica de la qPCR. </a:t>
+            </a:r>
+            <a:endParaRPr sz="1800">
+              <a:solidFill>
+                <a:srgbClr val="595959"/>
+              </a:solidFill>
+            </a:endParaRPr>
+          </a:p>
+          <a:p>
+            <a:pPr indent="0" lvl="0" marL="0" rtl="0" algn="l">
+              <a:spcBef>
+                <a:spcPts val="1200"/>
+              </a:spcBef>
+              <a:spcAft>
+                <a:spcPts val="0"/>
+              </a:spcAft>
+              <a:buNone/>
+            </a:pPr>
+            <a:r>
+              <a:t/>
+            </a:r>
+            <a:endParaRPr sz="1800">
+              <a:solidFill>
+                <a:srgbClr val="595959"/>
+              </a:solidFill>
+            </a:endParaRPr>
+          </a:p>
+        </p:txBody>
+      </p:sp>
       <p:pic>
         <p:nvPicPr>
-          <p:cNvPr id="54" name="Google Shape;54;p13" title="n_per_rep.jpg"/>
+          <p:cNvPr id="55" name="Google Shape;55;p13"/>
+          <p:cNvPicPr preferRelativeResize="0"/>
+          <p:nvPr/>
+        </p:nvPicPr>
+        <p:blipFill>
+          <a:blip r:embed="rId3">
+            <a:alphaModFix/>
+          </a:blip>
+          <a:stretch>
+            <a:fillRect/>
+          </a:stretch>
+        </p:blipFill>
+        <p:spPr>
+          <a:xfrm>
+            <a:off x="152400" y="152400"/>
+            <a:ext cx="7473959" cy="4139424"/>
+          </a:xfrm>
+          <a:prstGeom prst="rect">
+            <a:avLst/>
+          </a:prstGeom>
+          <a:noFill/>
+          <a:ln>
+            <a:noFill/>
+          </a:ln>
+        </p:spPr>
+      </p:pic>
+    </p:spTree>
+  </p:cSld>
+  <p:clrMapOvr>
+    <a:masterClrMapping/>
+  </p:clrMapOvr>
+</p:sld>
+</file>
+
+<file path=ppt/slides/slide2.xml><?xml version="1.0" encoding="utf-8"?>
+<p:sld xmlns:a="http://schemas.openxmlformats.org/drawingml/2006/main" xmlns:r="http://schemas.openxmlformats.org/officeDocument/2006/relationships" xmlns:mc="http://schemas.openxmlformats.org/markup-compatibility/2006" xmlns:mv="urn:schemas-microsoft-com:mac:vml" xmlns:p="http://schemas.openxmlformats.org/presentationml/2006/main" xmlns:c="http://schemas.openxmlformats.org/drawingml/2006/chart" xmlns:dgm="http://schemas.openxmlformats.org/drawingml/2006/diagram" xmlns:o="urn:schemas-microsoft-com:office:office" xmlns:v="urn:schemas-microsoft-com:vml" xmlns:pvml="urn:schemas-microsoft-com:office:powerpoint" xmlns:com="http://schemas.openxmlformats.org/drawingml/2006/compatibility" xmlns:p14="http://schemas.microsoft.com/office/powerpoint/2010/main" xmlns:p15="http://schemas.microsoft.com/office/powerpoint/2012/main" xmlns:ahyp="http://schemas.microsoft.com/office/drawing/2018/hyperlinkcolor">
+  <p:cSld>
+    <p:spTree>
+      <p:nvGrpSpPr>
+        <p:cNvPr id="59" name="Shape 59"/>
+        <p:cNvGrpSpPr/>
+        <p:nvPr/>
+      </p:nvGrpSpPr>
+      <p:grpSpPr>
+        <a:xfrm>
+          <a:off x="0" y="0"/>
+          <a:ext cx="0" cy="0"/>
+          <a:chOff x="0" y="0"/>
+          <a:chExt cx="0" cy="0"/>
+        </a:xfrm>
+      </p:grpSpPr>
+      <p:pic>
+        <p:nvPicPr>
+          <p:cNvPr id="60" name="Google Shape;60;p14" title="n_per_rep.jpg"/>
           <p:cNvPicPr preferRelativeResize="0"/>
           <p:nvPr/>
         </p:nvPicPr>
@@ -6090,7 +6328,7 @@
       </p:pic>
       <p:sp>
         <p:nvSpPr>
-          <p:cNvPr id="55" name="Google Shape;55;p13"/>
+          <p:cNvPr id="61" name="Google Shape;61;p14"/>
           <p:cNvSpPr txBox="1"/>
           <p:nvPr/>
         </p:nvSpPr>
@@ -6140,7 +6378,7 @@
       </p:sp>
       <p:sp>
         <p:nvSpPr>
-          <p:cNvPr id="56" name="Google Shape;56;p13"/>
+          <p:cNvPr id="62" name="Google Shape;62;p14"/>
           <p:cNvSpPr txBox="1"/>
           <p:nvPr/>
         </p:nvSpPr>
@@ -6246,7 +6484,7 @@
       </p:sp>
       <p:grpSp>
         <p:nvGrpSpPr>
-          <p:cNvPr id="57" name="Google Shape;57;p13"/>
+          <p:cNvPr id="63" name="Google Shape;63;p14"/>
           <p:cNvGrpSpPr/>
           <p:nvPr/>
         </p:nvGrpSpPr>
@@ -6260,7 +6498,7 @@
         </p:grpSpPr>
         <p:pic>
           <p:nvPicPr>
-            <p:cNvPr id="58" name="Google Shape;58;p13"/>
+            <p:cNvPr id="64" name="Google Shape;64;p14"/>
             <p:cNvPicPr preferRelativeResize="0"/>
             <p:nvPr/>
           </p:nvPicPr>
@@ -6287,7 +6525,7 @@
         </p:pic>
         <p:sp>
           <p:nvSpPr>
-            <p:cNvPr id="59" name="Google Shape;59;p13"/>
+            <p:cNvPr id="65" name="Google Shape;65;p14"/>
             <p:cNvSpPr txBox="1"/>
             <p:nvPr/>
           </p:nvSpPr>
@@ -6339,7 +6577,7 @@
         </p:sp>
         <p:sp>
           <p:nvSpPr>
-            <p:cNvPr id="60" name="Google Shape;60;p13"/>
+            <p:cNvPr id="66" name="Google Shape;66;p14"/>
             <p:cNvSpPr txBox="1"/>
             <p:nvPr/>
           </p:nvSpPr>
@@ -6389,7 +6627,7 @@
         </p:sp>
         <p:sp>
           <p:nvSpPr>
-            <p:cNvPr id="61" name="Google Shape;61;p13"/>
+            <p:cNvPr id="67" name="Google Shape;67;p14"/>
             <p:cNvSpPr txBox="1"/>
             <p:nvPr/>
           </p:nvSpPr>
@@ -6439,7 +6677,7 @@
         </p:sp>
         <p:sp>
           <p:nvSpPr>
-            <p:cNvPr id="62" name="Google Shape;62;p13"/>
+            <p:cNvPr id="68" name="Google Shape;68;p14"/>
             <p:cNvSpPr txBox="1"/>
             <p:nvPr/>
           </p:nvSpPr>
@@ -6489,7 +6727,7 @@
         </p:sp>
         <p:sp>
           <p:nvSpPr>
-            <p:cNvPr id="63" name="Google Shape;63;p13"/>
+            <p:cNvPr id="69" name="Google Shape;69;p14"/>
             <p:cNvSpPr txBox="1"/>
             <p:nvPr/>
           </p:nvSpPr>
@@ -6541,7 +6779,7 @@
         </p:sp>
         <p:sp>
           <p:nvSpPr>
-            <p:cNvPr id="64" name="Google Shape;64;p13"/>
+            <p:cNvPr id="70" name="Google Shape;70;p14"/>
             <p:cNvSpPr txBox="1"/>
             <p:nvPr/>
           </p:nvSpPr>
@@ -6593,7 +6831,7 @@
         </p:sp>
         <p:sp>
           <p:nvSpPr>
-            <p:cNvPr id="65" name="Google Shape;65;p13"/>
+            <p:cNvPr id="71" name="Google Shape;71;p14"/>
             <p:cNvSpPr txBox="1"/>
             <p:nvPr/>
           </p:nvSpPr>
@@ -6652,12 +6890,12 @@
 </p:sld>
 </file>
 
-<file path=ppt/slides/slide2.xml><?xml version="1.0" encoding="utf-8"?>
+<file path=ppt/slides/slide3.xml><?xml version="1.0" encoding="utf-8"?>
 <p:sld xmlns:a="http://schemas.openxmlformats.org/drawingml/2006/main" xmlns:r="http://schemas.openxmlformats.org/officeDocument/2006/relationships" xmlns:mc="http://schemas.openxmlformats.org/markup-compatibility/2006" xmlns:mv="urn:schemas-microsoft-com:mac:vml" xmlns:p="http://schemas.openxmlformats.org/presentationml/2006/main" xmlns:c="http://schemas.openxmlformats.org/drawingml/2006/chart" xmlns:dgm="http://schemas.openxmlformats.org/drawingml/2006/diagram" xmlns:o="urn:schemas-microsoft-com:office:office" xmlns:v="urn:schemas-microsoft-com:vml" xmlns:pvml="urn:schemas-microsoft-com:office:powerpoint" xmlns:com="http://schemas.openxmlformats.org/drawingml/2006/compatibility" xmlns:p14="http://schemas.microsoft.com/office/powerpoint/2010/main" xmlns:p15="http://schemas.microsoft.com/office/powerpoint/2012/main" xmlns:ahyp="http://schemas.microsoft.com/office/drawing/2018/hyperlinkcolor">
   <p:cSld>
     <p:spTree>
       <p:nvGrpSpPr>
-        <p:cNvPr id="69" name="Shape 69"/>
+        <p:cNvPr id="75" name="Shape 75"/>
         <p:cNvGrpSpPr/>
         <p:nvPr/>
       </p:nvGrpSpPr>
@@ -6671,7 +6909,7 @@
       </p:grpSpPr>
       <p:sp>
         <p:nvSpPr>
-          <p:cNvPr id="70" name="Google Shape;70;p14"/>
+          <p:cNvPr id="76" name="Google Shape;76;p15"/>
           <p:cNvSpPr txBox="1"/>
           <p:nvPr/>
         </p:nvSpPr>
@@ -6753,7 +6991,7 @@
       </p:sp>
       <p:pic>
         <p:nvPicPr>
-          <p:cNvPr id="71" name="Google Shape;71;p14"/>
+          <p:cNvPr id="77" name="Google Shape;77;p15"/>
           <p:cNvPicPr preferRelativeResize="0"/>
           <p:nvPr/>
         </p:nvPicPr>
@@ -6780,7 +7018,7 @@
       </p:pic>
       <p:sp>
         <p:nvSpPr>
-          <p:cNvPr id="72" name="Google Shape;72;p14"/>
+          <p:cNvPr id="78" name="Google Shape;78;p15"/>
           <p:cNvSpPr txBox="1"/>
           <p:nvPr/>
         </p:nvSpPr>
@@ -6832,7 +7070,7 @@
       </p:sp>
       <p:sp>
         <p:nvSpPr>
-          <p:cNvPr id="73" name="Google Shape;73;p14"/>
+          <p:cNvPr id="79" name="Google Shape;79;p15"/>
           <p:cNvSpPr txBox="1"/>
           <p:nvPr/>
         </p:nvSpPr>
@@ -6882,7 +7120,7 @@
       </p:sp>
       <p:sp>
         <p:nvSpPr>
-          <p:cNvPr id="74" name="Google Shape;74;p14"/>
+          <p:cNvPr id="80" name="Google Shape;80;p15"/>
           <p:cNvSpPr txBox="1"/>
           <p:nvPr/>
         </p:nvSpPr>
@@ -6934,7 +7172,7 @@
       </p:sp>
       <p:sp>
         <p:nvSpPr>
-          <p:cNvPr id="75" name="Google Shape;75;p14"/>
+          <p:cNvPr id="81" name="Google Shape;81;p15"/>
           <p:cNvSpPr txBox="1"/>
           <p:nvPr/>
         </p:nvSpPr>
@@ -6986,7 +7224,7 @@
       </p:sp>
       <p:sp>
         <p:nvSpPr>
-          <p:cNvPr id="76" name="Google Shape;76;p14"/>
+          <p:cNvPr id="82" name="Google Shape;82;p15"/>
           <p:cNvSpPr txBox="1"/>
           <p:nvPr/>
         </p:nvSpPr>
@@ -7038,7 +7276,7 @@
       </p:sp>
       <p:sp>
         <p:nvSpPr>
-          <p:cNvPr id="77" name="Google Shape;77;p14"/>
+          <p:cNvPr id="83" name="Google Shape;83;p15"/>
           <p:cNvSpPr txBox="1"/>
           <p:nvPr/>
         </p:nvSpPr>
@@ -7096,7 +7334,7 @@
       </p:sp>
       <p:sp>
         <p:nvSpPr>
-          <p:cNvPr id="78" name="Google Shape;78;p14"/>
+          <p:cNvPr id="84" name="Google Shape;84;p15"/>
           <p:cNvSpPr txBox="1"/>
           <p:nvPr/>
         </p:nvSpPr>
@@ -7146,7 +7384,7 @@
       </p:sp>
       <p:grpSp>
         <p:nvGrpSpPr>
-          <p:cNvPr id="79" name="Google Shape;79;p14"/>
+          <p:cNvPr id="85" name="Google Shape;85;p15"/>
           <p:cNvGrpSpPr/>
           <p:nvPr/>
         </p:nvGrpSpPr>
@@ -7160,7 +7398,7 @@
         </p:grpSpPr>
         <p:grpSp>
           <p:nvGrpSpPr>
-            <p:cNvPr id="80" name="Google Shape;80;p14"/>
+            <p:cNvPr id="86" name="Google Shape;86;p15"/>
             <p:cNvGrpSpPr/>
             <p:nvPr/>
           </p:nvGrpSpPr>
@@ -7174,7 +7412,7 @@
           </p:grpSpPr>
           <p:pic>
             <p:nvPicPr>
-              <p:cNvPr id="81" name="Google Shape;81;p14" title="gc_bias_bars.jpg"/>
+              <p:cNvPr id="87" name="Google Shape;87;p15" title="gc_bias_bars.jpg"/>
               <p:cNvPicPr preferRelativeResize="0"/>
               <p:nvPr/>
             </p:nvPicPr>
@@ -7202,7 +7440,7 @@
           </p:pic>
           <p:sp>
             <p:nvSpPr>
-              <p:cNvPr id="82" name="Google Shape;82;p14"/>
+              <p:cNvPr id="88" name="Google Shape;88;p15"/>
               <p:cNvSpPr txBox="1"/>
               <p:nvPr/>
             </p:nvSpPr>
@@ -7252,7 +7490,7 @@
           </p:sp>
           <p:sp>
             <p:nvSpPr>
-              <p:cNvPr id="83" name="Google Shape;83;p14"/>
+              <p:cNvPr id="89" name="Google Shape;89;p15"/>
               <p:cNvSpPr txBox="1"/>
               <p:nvPr/>
             </p:nvSpPr>
@@ -7303,7 +7541,7 @@
         </p:grpSp>
         <p:sp>
           <p:nvSpPr>
-            <p:cNvPr id="84" name="Google Shape;84;p14"/>
+            <p:cNvPr id="90" name="Google Shape;90;p15"/>
             <p:cNvSpPr/>
             <p:nvPr/>
           </p:nvSpPr>
@@ -7352,7 +7590,7 @@
         </p:sp>
         <p:sp>
           <p:nvSpPr>
-            <p:cNvPr id="85" name="Google Shape;85;p14"/>
+            <p:cNvPr id="91" name="Google Shape;91;p15"/>
             <p:cNvSpPr/>
             <p:nvPr/>
           </p:nvSpPr>
@@ -7402,7 +7640,7 @@
       </p:grpSp>
       <p:pic>
         <p:nvPicPr>
-          <p:cNvPr id="86" name="Google Shape;86;p14" title="gc_bias_violin.jpg"/>
+          <p:cNvPr id="92" name="Google Shape;92;p15" title="gc_bias_violin.jpg"/>
           <p:cNvPicPr preferRelativeResize="0"/>
           <p:nvPr/>
         </p:nvPicPr>
@@ -7429,7 +7667,7 @@
       </p:pic>
       <p:sp>
         <p:nvSpPr>
-          <p:cNvPr id="87" name="Google Shape;87;p14"/>
+          <p:cNvPr id="93" name="Google Shape;93;p15"/>
           <p:cNvSpPr txBox="1"/>
           <p:nvPr/>
         </p:nvSpPr>
@@ -7503,7 +7741,7 @@
       </p:sp>
       <p:sp>
         <p:nvSpPr>
-          <p:cNvPr id="88" name="Google Shape;88;p14"/>
+          <p:cNvPr id="94" name="Google Shape;94;p15"/>
           <p:cNvSpPr txBox="1"/>
           <p:nvPr/>
         </p:nvSpPr>
@@ -7552,200 +7790,6 @@
               <a:t>etectados</a:t>
             </a:r>
             <a:endParaRPr sz="1100">
-              <a:solidFill>
-                <a:schemeClr val="dk2"/>
-              </a:solidFill>
-            </a:endParaRPr>
-          </a:p>
-        </p:txBody>
-      </p:sp>
-    </p:spTree>
-  </p:cSld>
-  <p:clrMapOvr>
-    <a:masterClrMapping/>
-  </p:clrMapOvr>
-</p:sld>
-</file>
-
-<file path=ppt/slides/slide3.xml><?xml version="1.0" encoding="utf-8"?>
-<p:sld xmlns:a="http://schemas.openxmlformats.org/drawingml/2006/main" xmlns:r="http://schemas.openxmlformats.org/officeDocument/2006/relationships" xmlns:mc="http://schemas.openxmlformats.org/markup-compatibility/2006" xmlns:mv="urn:schemas-microsoft-com:mac:vml" xmlns:p="http://schemas.openxmlformats.org/presentationml/2006/main" xmlns:c="http://schemas.openxmlformats.org/drawingml/2006/chart" xmlns:dgm="http://schemas.openxmlformats.org/drawingml/2006/diagram" xmlns:o="urn:schemas-microsoft-com:office:office" xmlns:v="urn:schemas-microsoft-com:vml" xmlns:pvml="urn:schemas-microsoft-com:office:powerpoint" xmlns:com="http://schemas.openxmlformats.org/drawingml/2006/compatibility" xmlns:p14="http://schemas.microsoft.com/office/powerpoint/2010/main" xmlns:p15="http://schemas.microsoft.com/office/powerpoint/2012/main" xmlns:ahyp="http://schemas.microsoft.com/office/drawing/2018/hyperlinkcolor">
-  <p:cSld>
-    <p:spTree>
-      <p:nvGrpSpPr>
-        <p:cNvPr id="92" name="Shape 92"/>
-        <p:cNvGrpSpPr/>
-        <p:nvPr/>
-      </p:nvGrpSpPr>
-      <p:grpSpPr>
-        <a:xfrm>
-          <a:off x="0" y="0"/>
-          <a:ext cx="0" cy="0"/>
-          <a:chOff x="0" y="0"/>
-          <a:chExt cx="0" cy="0"/>
-        </a:xfrm>
-      </p:grpSpPr>
-      <p:pic>
-        <p:nvPicPr>
-          <p:cNvPr id="93" name="Google Shape;93;p15"/>
-          <p:cNvPicPr preferRelativeResize="0"/>
-          <p:nvPr/>
-        </p:nvPicPr>
-        <p:blipFill>
-          <a:blip r:embed="rId3">
-            <a:alphaModFix/>
-          </a:blip>
-          <a:stretch>
-            <a:fillRect/>
-          </a:stretch>
-        </p:blipFill>
-        <p:spPr>
-          <a:xfrm>
-            <a:off x="884425" y="152400"/>
-            <a:ext cx="5012300" cy="3762750"/>
-          </a:xfrm>
-          <a:prstGeom prst="rect">
-            <a:avLst/>
-          </a:prstGeom>
-          <a:noFill/>
-          <a:ln>
-            <a:noFill/>
-          </a:ln>
-        </p:spPr>
-      </p:pic>
-      <p:sp>
-        <p:nvSpPr>
-          <p:cNvPr id="94" name="Google Shape;94;p15"/>
-          <p:cNvSpPr txBox="1"/>
-          <p:nvPr/>
-        </p:nvSpPr>
-        <p:spPr>
-          <a:xfrm>
-            <a:off x="242725" y="4030035"/>
-            <a:ext cx="9044400" cy="1006500"/>
-          </a:xfrm>
-          <a:prstGeom prst="rect">
-            <a:avLst/>
-          </a:prstGeom>
-          <a:noFill/>
-          <a:ln>
-            <a:noFill/>
-          </a:ln>
-        </p:spPr>
-        <p:txBody>
-          <a:bodyPr anchorCtr="0" anchor="t" bIns="91425" lIns="91425" spcFirstLastPara="1" rIns="91425" wrap="square" tIns="91425">
-            <a:spAutoFit/>
-          </a:bodyPr>
-          <a:lstStyle/>
-          <a:p>
-            <a:pPr indent="0" lvl="0" marL="0" rtl="0" algn="l">
-              <a:lnSpc>
-                <a:spcPct val="115000"/>
-              </a:lnSpc>
-              <a:spcBef>
-                <a:spcPts val="0"/>
-              </a:spcBef>
-              <a:spcAft>
-                <a:spcPts val="1200"/>
-              </a:spcAft>
-              <a:buNone/>
-            </a:pPr>
-            <a:r>
-              <a:rPr b="1" lang="es-419" sz="1200">
-                <a:solidFill>
-                  <a:schemeClr val="dk2"/>
-                </a:solidFill>
-              </a:rPr>
-              <a:t>Robustez de los controles celulares internos de spike-in.</a:t>
-            </a:r>
-            <a:r>
-              <a:rPr lang="es-419" sz="1200">
-                <a:solidFill>
-                  <a:schemeClr val="dk2"/>
-                </a:solidFill>
-              </a:rPr>
-              <a:t> 30, 300 o 3000 células fueron añadidas en forma de </a:t>
-            </a:r>
-            <a:r>
-              <a:rPr lang="es-419" sz="1200">
-                <a:solidFill>
-                  <a:schemeClr val="dk2"/>
-                </a:solidFill>
-              </a:rPr>
-              <a:t>estándar</a:t>
-            </a:r>
-            <a:r>
-              <a:rPr lang="es-419" sz="1200">
-                <a:solidFill>
-                  <a:schemeClr val="dk2"/>
-                </a:solidFill>
-              </a:rPr>
-              <a:t> interno a cada muestra. Los counts corregidos de cada una de las tres líneas celulares usadas como </a:t>
-            </a:r>
-            <a:r>
-              <a:rPr lang="es-419" sz="1200">
-                <a:solidFill>
-                  <a:schemeClr val="dk2"/>
-                </a:solidFill>
-              </a:rPr>
-              <a:t>estándar</a:t>
-            </a:r>
-            <a:r>
-              <a:rPr lang="es-419" sz="1200">
-                <a:solidFill>
-                  <a:schemeClr val="dk2"/>
-                </a:solidFill>
-              </a:rPr>
-              <a:t> fueron normalizadas al de aquella con representación intermedia (Spike-in 2). Los valores para cada fracción de </a:t>
-            </a:r>
-            <a:r>
-              <a:rPr lang="es-419" sz="1200">
-                <a:solidFill>
-                  <a:schemeClr val="dk2"/>
-                </a:solidFill>
-              </a:rPr>
-              <a:t>células</a:t>
-            </a:r>
-            <a:r>
-              <a:rPr lang="es-419" sz="1200">
-                <a:solidFill>
-                  <a:schemeClr val="dk2"/>
-                </a:solidFill>
-              </a:rPr>
-              <a:t> se muestran para ambas </a:t>
-            </a:r>
-            <a:r>
-              <a:rPr lang="es-419" sz="1200">
-                <a:solidFill>
-                  <a:schemeClr val="dk2"/>
-                </a:solidFill>
-              </a:rPr>
-              <a:t>réplicas</a:t>
-            </a:r>
-            <a:r>
-              <a:rPr lang="es-419" sz="1200">
-                <a:solidFill>
-                  <a:schemeClr val="dk2"/>
-                </a:solidFill>
-              </a:rPr>
-              <a:t>, y muestran la ausencia de sesgos técnicos relevantes entre las muestras en la </a:t>
-            </a:r>
-            <a:r>
-              <a:rPr lang="es-419" sz="1200">
-                <a:solidFill>
-                  <a:schemeClr val="dk2"/>
-                </a:solidFill>
-              </a:rPr>
-              <a:t>cuantificación</a:t>
-            </a:r>
-            <a:r>
-              <a:rPr lang="es-419" sz="1200">
-                <a:solidFill>
-                  <a:schemeClr val="dk2"/>
-                </a:solidFill>
-              </a:rPr>
-              <a:t> en escala masiva.</a:t>
-            </a:r>
-            <a:endParaRPr sz="1800">
               <a:solidFill>
                 <a:schemeClr val="dk2"/>
               </a:solidFill>
@@ -7778,9 +7822,203 @@
           <a:chExt cx="0" cy="0"/>
         </a:xfrm>
       </p:grpSpPr>
+      <p:pic>
+        <p:nvPicPr>
+          <p:cNvPr id="99" name="Google Shape;99;p16"/>
+          <p:cNvPicPr preferRelativeResize="0"/>
+          <p:nvPr/>
+        </p:nvPicPr>
+        <p:blipFill>
+          <a:blip r:embed="rId3">
+            <a:alphaModFix/>
+          </a:blip>
+          <a:stretch>
+            <a:fillRect/>
+          </a:stretch>
+        </p:blipFill>
+        <p:spPr>
+          <a:xfrm>
+            <a:off x="884425" y="152400"/>
+            <a:ext cx="5012300" cy="3762750"/>
+          </a:xfrm>
+          <a:prstGeom prst="rect">
+            <a:avLst/>
+          </a:prstGeom>
+          <a:noFill/>
+          <a:ln>
+            <a:noFill/>
+          </a:ln>
+        </p:spPr>
+      </p:pic>
       <p:sp>
         <p:nvSpPr>
-          <p:cNvPr id="99" name="Google Shape;99;p16"/>
+          <p:cNvPr id="100" name="Google Shape;100;p16"/>
+          <p:cNvSpPr txBox="1"/>
+          <p:nvPr/>
+        </p:nvSpPr>
+        <p:spPr>
+          <a:xfrm>
+            <a:off x="242725" y="4030035"/>
+            <a:ext cx="9044400" cy="1006500"/>
+          </a:xfrm>
+          <a:prstGeom prst="rect">
+            <a:avLst/>
+          </a:prstGeom>
+          <a:noFill/>
+          <a:ln>
+            <a:noFill/>
+          </a:ln>
+        </p:spPr>
+        <p:txBody>
+          <a:bodyPr anchorCtr="0" anchor="t" bIns="91425" lIns="91425" spcFirstLastPara="1" rIns="91425" wrap="square" tIns="91425">
+            <a:spAutoFit/>
+          </a:bodyPr>
+          <a:lstStyle/>
+          <a:p>
+            <a:pPr indent="0" lvl="0" marL="0" rtl="0" algn="l">
+              <a:lnSpc>
+                <a:spcPct val="115000"/>
+              </a:lnSpc>
+              <a:spcBef>
+                <a:spcPts val="0"/>
+              </a:spcBef>
+              <a:spcAft>
+                <a:spcPts val="1200"/>
+              </a:spcAft>
+              <a:buNone/>
+            </a:pPr>
+            <a:r>
+              <a:rPr b="1" lang="es-419" sz="1200">
+                <a:solidFill>
+                  <a:schemeClr val="dk2"/>
+                </a:solidFill>
+              </a:rPr>
+              <a:t>Robustez de los controles celulares internos de spike-in.</a:t>
+            </a:r>
+            <a:r>
+              <a:rPr lang="es-419" sz="1200">
+                <a:solidFill>
+                  <a:schemeClr val="dk2"/>
+                </a:solidFill>
+              </a:rPr>
+              <a:t> 30, 300 o 3000 células fueron añadidas en forma de </a:t>
+            </a:r>
+            <a:r>
+              <a:rPr lang="es-419" sz="1200">
+                <a:solidFill>
+                  <a:schemeClr val="dk2"/>
+                </a:solidFill>
+              </a:rPr>
+              <a:t>estándar</a:t>
+            </a:r>
+            <a:r>
+              <a:rPr lang="es-419" sz="1200">
+                <a:solidFill>
+                  <a:schemeClr val="dk2"/>
+                </a:solidFill>
+              </a:rPr>
+              <a:t> interno a cada muestra. Los counts corregidos de cada una de las tres líneas celulares usadas como </a:t>
+            </a:r>
+            <a:r>
+              <a:rPr lang="es-419" sz="1200">
+                <a:solidFill>
+                  <a:schemeClr val="dk2"/>
+                </a:solidFill>
+              </a:rPr>
+              <a:t>estándar</a:t>
+            </a:r>
+            <a:r>
+              <a:rPr lang="es-419" sz="1200">
+                <a:solidFill>
+                  <a:schemeClr val="dk2"/>
+                </a:solidFill>
+              </a:rPr>
+              <a:t> fueron normalizadas al de aquella con representación intermedia (Spike-in 2). Los valores para cada fracción de </a:t>
+            </a:r>
+            <a:r>
+              <a:rPr lang="es-419" sz="1200">
+                <a:solidFill>
+                  <a:schemeClr val="dk2"/>
+                </a:solidFill>
+              </a:rPr>
+              <a:t>células</a:t>
+            </a:r>
+            <a:r>
+              <a:rPr lang="es-419" sz="1200">
+                <a:solidFill>
+                  <a:schemeClr val="dk2"/>
+                </a:solidFill>
+              </a:rPr>
+              <a:t> se muestran para ambas </a:t>
+            </a:r>
+            <a:r>
+              <a:rPr lang="es-419" sz="1200">
+                <a:solidFill>
+                  <a:schemeClr val="dk2"/>
+                </a:solidFill>
+              </a:rPr>
+              <a:t>réplicas</a:t>
+            </a:r>
+            <a:r>
+              <a:rPr lang="es-419" sz="1200">
+                <a:solidFill>
+                  <a:schemeClr val="dk2"/>
+                </a:solidFill>
+              </a:rPr>
+              <a:t>, y muestran la ausencia de sesgos técnicos relevantes entre las muestras en la </a:t>
+            </a:r>
+            <a:r>
+              <a:rPr lang="es-419" sz="1200">
+                <a:solidFill>
+                  <a:schemeClr val="dk2"/>
+                </a:solidFill>
+              </a:rPr>
+              <a:t>cuantificación</a:t>
+            </a:r>
+            <a:r>
+              <a:rPr lang="es-419" sz="1200">
+                <a:solidFill>
+                  <a:schemeClr val="dk2"/>
+                </a:solidFill>
+              </a:rPr>
+              <a:t> en escala masiva.</a:t>
+            </a:r>
+            <a:endParaRPr sz="1800">
+              <a:solidFill>
+                <a:schemeClr val="dk2"/>
+              </a:solidFill>
+            </a:endParaRPr>
+          </a:p>
+        </p:txBody>
+      </p:sp>
+    </p:spTree>
+  </p:cSld>
+  <p:clrMapOvr>
+    <a:masterClrMapping/>
+  </p:clrMapOvr>
+</p:sld>
+</file>
+
+<file path=ppt/slides/slide5.xml><?xml version="1.0" encoding="utf-8"?>
+<p:sld xmlns:a="http://schemas.openxmlformats.org/drawingml/2006/main" xmlns:r="http://schemas.openxmlformats.org/officeDocument/2006/relationships" xmlns:mc="http://schemas.openxmlformats.org/markup-compatibility/2006" xmlns:mv="urn:schemas-microsoft-com:mac:vml" xmlns:p="http://schemas.openxmlformats.org/presentationml/2006/main" xmlns:c="http://schemas.openxmlformats.org/drawingml/2006/chart" xmlns:dgm="http://schemas.openxmlformats.org/drawingml/2006/diagram" xmlns:o="urn:schemas-microsoft-com:office:office" xmlns:v="urn:schemas-microsoft-com:vml" xmlns:pvml="urn:schemas-microsoft-com:office:powerpoint" xmlns:com="http://schemas.openxmlformats.org/drawingml/2006/compatibility" xmlns:p14="http://schemas.microsoft.com/office/powerpoint/2010/main" xmlns:p15="http://schemas.microsoft.com/office/powerpoint/2012/main" xmlns:ahyp="http://schemas.microsoft.com/office/drawing/2018/hyperlinkcolor">
+  <p:cSld>
+    <p:spTree>
+      <p:nvGrpSpPr>
+        <p:cNvPr id="104" name="Shape 104"/>
+        <p:cNvGrpSpPr/>
+        <p:nvPr/>
+      </p:nvGrpSpPr>
+      <p:grpSpPr>
+        <a:xfrm>
+          <a:off x="0" y="0"/>
+          <a:ext cx="0" cy="0"/>
+          <a:chOff x="0" y="0"/>
+          <a:chExt cx="0" cy="0"/>
+        </a:xfrm>
+      </p:grpSpPr>
+      <p:sp>
+        <p:nvSpPr>
+          <p:cNvPr id="105" name="Google Shape;105;p17"/>
           <p:cNvSpPr txBox="1"/>
           <p:nvPr/>
         </p:nvSpPr>
@@ -7886,7 +8124,7 @@
       </p:sp>
       <p:pic>
         <p:nvPicPr>
-          <p:cNvPr id="100" name="Google Shape;100;p16" title="histograma_gates_KIAA0753.jpg"/>
+          <p:cNvPr id="106" name="Google Shape;106;p17" title="histograma_gates_KIAA0753.jpg"/>
           <p:cNvPicPr preferRelativeResize="0"/>
           <p:nvPr/>
         </p:nvPicPr>
@@ -7920,12 +8158,12 @@
 </p:sld>
 </file>
 
-<file path=ppt/slides/slide5.xml><?xml version="1.0" encoding="utf-8"?>
+<file path=ppt/slides/slide6.xml><?xml version="1.0" encoding="utf-8"?>
 <p:sld xmlns:a="http://schemas.openxmlformats.org/drawingml/2006/main" xmlns:r="http://schemas.openxmlformats.org/officeDocument/2006/relationships" xmlns:mc="http://schemas.openxmlformats.org/markup-compatibility/2006" xmlns:mv="urn:schemas-microsoft-com:mac:vml" xmlns:p="http://schemas.openxmlformats.org/presentationml/2006/main" xmlns:c="http://schemas.openxmlformats.org/drawingml/2006/chart" xmlns:dgm="http://schemas.openxmlformats.org/drawingml/2006/diagram" xmlns:o="urn:schemas-microsoft-com:office:office" xmlns:v="urn:schemas-microsoft-com:vml" xmlns:pvml="urn:schemas-microsoft-com:office:powerpoint" xmlns:com="http://schemas.openxmlformats.org/drawingml/2006/compatibility" xmlns:p14="http://schemas.microsoft.com/office/powerpoint/2010/main" xmlns:p15="http://schemas.microsoft.com/office/powerpoint/2012/main" xmlns:ahyp="http://schemas.microsoft.com/office/drawing/2018/hyperlinkcolor">
   <p:cSld>
     <p:spTree>
       <p:nvGrpSpPr>
-        <p:cNvPr id="104" name="Shape 104"/>
+        <p:cNvPr id="110" name="Shape 110"/>
         <p:cNvGrpSpPr/>
         <p:nvPr/>
       </p:nvGrpSpPr>
@@ -7939,7 +8177,7 @@
       </p:grpSpPr>
       <p:pic>
         <p:nvPicPr>
-          <p:cNvPr id="105" name="Google Shape;105;p17" title="extra_densidad_individual.jpg"/>
+          <p:cNvPr id="111" name="Google Shape;111;p18" title="extra_densidad_individual.jpg"/>
           <p:cNvPicPr preferRelativeResize="0"/>
           <p:nvPr/>
         </p:nvPicPr>
@@ -7967,7 +8205,7 @@
       </p:pic>
       <p:sp>
         <p:nvSpPr>
-          <p:cNvPr id="106" name="Google Shape;106;p17"/>
+          <p:cNvPr id="112" name="Google Shape;112;p18"/>
           <p:cNvSpPr txBox="1"/>
           <p:nvPr/>
         </p:nvSpPr>
@@ -8083,12 +8321,12 @@
 </p:sld>
 </file>
 
-<file path=ppt/slides/slide6.xml><?xml version="1.0" encoding="utf-8"?>
+<file path=ppt/slides/slide7.xml><?xml version="1.0" encoding="utf-8"?>
 <p:sld xmlns:a="http://schemas.openxmlformats.org/drawingml/2006/main" xmlns:r="http://schemas.openxmlformats.org/officeDocument/2006/relationships" xmlns:mc="http://schemas.openxmlformats.org/markup-compatibility/2006" xmlns:mv="urn:schemas-microsoft-com:mac:vml" xmlns:p="http://schemas.openxmlformats.org/presentationml/2006/main" xmlns:c="http://schemas.openxmlformats.org/drawingml/2006/chart" xmlns:dgm="http://schemas.openxmlformats.org/drawingml/2006/diagram" xmlns:o="urn:schemas-microsoft-com:office:office" xmlns:v="urn:schemas-microsoft-com:vml" xmlns:pvml="urn:schemas-microsoft-com:office:powerpoint" xmlns:com="http://schemas.openxmlformats.org/drawingml/2006/compatibility" xmlns:p14="http://schemas.microsoft.com/office/powerpoint/2010/main" xmlns:p15="http://schemas.microsoft.com/office/powerpoint/2012/main" xmlns:ahyp="http://schemas.microsoft.com/office/drawing/2018/hyperlinkcolor">
   <p:cSld>
     <p:spTree>
       <p:nvGrpSpPr>
-        <p:cNvPr id="110" name="Shape 110"/>
+        <p:cNvPr id="116" name="Shape 116"/>
         <p:cNvGrpSpPr/>
         <p:nvPr/>
       </p:nvGrpSpPr>
@@ -8102,7 +8340,7 @@
       </p:grpSpPr>
       <p:pic>
         <p:nvPicPr>
-          <p:cNvPr id="111" name="Google Shape;111;p18"/>
+          <p:cNvPr id="117" name="Google Shape;117;p19"/>
           <p:cNvPicPr preferRelativeResize="0"/>
           <p:nvPr/>
         </p:nvPicPr>
@@ -8130,7 +8368,7 @@
       </p:pic>
       <p:pic>
         <p:nvPicPr>
-          <p:cNvPr id="112" name="Google Shape;112;p18"/>
+          <p:cNvPr id="118" name="Google Shape;118;p19"/>
           <p:cNvPicPr preferRelativeResize="0"/>
           <p:nvPr/>
         </p:nvPicPr>
@@ -8158,7 +8396,7 @@
       </p:pic>
       <p:sp>
         <p:nvSpPr>
-          <p:cNvPr id="113" name="Google Shape;113;p18"/>
+          <p:cNvPr id="119" name="Google Shape;119;p19"/>
           <p:cNvSpPr txBox="1"/>
           <p:nvPr/>
         </p:nvSpPr>
@@ -8264,7 +8502,7 @@
       </p:sp>
       <p:pic>
         <p:nvPicPr>
-          <p:cNvPr id="114" name="Google Shape;114;p18" title="panel_b_histograma_gates_ejemplo.jpg"/>
+          <p:cNvPr id="120" name="Google Shape;120;p19" title="panel_b_histograma_gates_ejemplo.jpg"/>
           <p:cNvPicPr preferRelativeResize="0"/>
           <p:nvPr/>
         </p:nvPicPr>
@@ -8298,12 +8536,12 @@
 </p:sld>
 </file>
 
-<file path=ppt/slides/slide7.xml><?xml version="1.0" encoding="utf-8"?>
+<file path=ppt/slides/slide8.xml><?xml version="1.0" encoding="utf-8"?>
 <p:sld xmlns:a="http://schemas.openxmlformats.org/drawingml/2006/main" xmlns:r="http://schemas.openxmlformats.org/officeDocument/2006/relationships" xmlns:mc="http://schemas.openxmlformats.org/markup-compatibility/2006" xmlns:mv="urn:schemas-microsoft-com:mac:vml" xmlns:p="http://schemas.openxmlformats.org/presentationml/2006/main" xmlns:c="http://schemas.openxmlformats.org/drawingml/2006/chart" xmlns:dgm="http://schemas.openxmlformats.org/drawingml/2006/diagram" xmlns:o="urn:schemas-microsoft-com:office:office" xmlns:v="urn:schemas-microsoft-com:vml" xmlns:pvml="urn:schemas-microsoft-com:office:powerpoint" xmlns:com="http://schemas.openxmlformats.org/drawingml/2006/compatibility" xmlns:p14="http://schemas.microsoft.com/office/powerpoint/2010/main" xmlns:p15="http://schemas.microsoft.com/office/powerpoint/2012/main" xmlns:ahyp="http://schemas.microsoft.com/office/drawing/2018/hyperlinkcolor">
   <p:cSld>
     <p:spTree>
       <p:nvGrpSpPr>
-        <p:cNvPr id="118" name="Shape 118"/>
+        <p:cNvPr id="124" name="Shape 124"/>
         <p:cNvGrpSpPr/>
         <p:nvPr/>
       </p:nvGrpSpPr>
@@ -8317,7 +8555,7 @@
       </p:grpSpPr>
       <p:grpSp>
         <p:nvGrpSpPr>
-          <p:cNvPr id="119" name="Google Shape;119;p19"/>
+          <p:cNvPr id="125" name="Google Shape;125;p20"/>
           <p:cNvGrpSpPr/>
           <p:nvPr/>
         </p:nvGrpSpPr>
@@ -8331,7 +8569,7 @@
         </p:grpSpPr>
         <p:pic>
           <p:nvPicPr>
-            <p:cNvPr id="120" name="Google Shape;120;p19"/>
+            <p:cNvPr id="126" name="Google Shape;126;p20"/>
             <p:cNvPicPr preferRelativeResize="0"/>
             <p:nvPr/>
           </p:nvPicPr>
@@ -8358,7 +8596,7 @@
         </p:pic>
         <p:sp>
           <p:nvSpPr>
-            <p:cNvPr id="121" name="Google Shape;121;p19"/>
+            <p:cNvPr id="127" name="Google Shape;127;p20"/>
             <p:cNvSpPr txBox="1"/>
             <p:nvPr/>
           </p:nvSpPr>
@@ -8410,7 +8648,7 @@
         </p:sp>
         <p:sp>
           <p:nvSpPr>
-            <p:cNvPr id="122" name="Google Shape;122;p19"/>
+            <p:cNvPr id="128" name="Google Shape;128;p20"/>
             <p:cNvSpPr txBox="1"/>
             <p:nvPr/>
           </p:nvSpPr>
@@ -8460,7 +8698,7 @@
         </p:sp>
         <p:sp>
           <p:nvSpPr>
-            <p:cNvPr id="123" name="Google Shape;123;p19"/>
+            <p:cNvPr id="129" name="Google Shape;129;p20"/>
             <p:cNvSpPr txBox="1"/>
             <p:nvPr/>
           </p:nvSpPr>
@@ -8510,7 +8748,7 @@
         </p:sp>
         <p:sp>
           <p:nvSpPr>
-            <p:cNvPr id="124" name="Google Shape;124;p19"/>
+            <p:cNvPr id="130" name="Google Shape;130;p20"/>
             <p:cNvSpPr txBox="1"/>
             <p:nvPr/>
           </p:nvSpPr>
@@ -8560,7 +8798,7 @@
         </p:sp>
         <p:sp>
           <p:nvSpPr>
-            <p:cNvPr id="125" name="Google Shape;125;p19"/>
+            <p:cNvPr id="131" name="Google Shape;131;p20"/>
             <p:cNvSpPr txBox="1"/>
             <p:nvPr/>
           </p:nvSpPr>
@@ -8612,7 +8850,7 @@
         </p:sp>
         <p:sp>
           <p:nvSpPr>
-            <p:cNvPr id="126" name="Google Shape;126;p19"/>
+            <p:cNvPr id="132" name="Google Shape;132;p20"/>
             <p:cNvSpPr txBox="1"/>
             <p:nvPr/>
           </p:nvSpPr>
@@ -8664,7 +8902,7 @@
         </p:sp>
         <p:sp>
           <p:nvSpPr>
-            <p:cNvPr id="127" name="Google Shape;127;p19"/>
+            <p:cNvPr id="133" name="Google Shape;133;p20"/>
             <p:cNvSpPr txBox="1"/>
             <p:nvPr/>
           </p:nvSpPr>
@@ -8722,7 +8960,7 @@
       </p:grpSp>
       <p:sp>
         <p:nvSpPr>
-          <p:cNvPr id="128" name="Google Shape;128;p19"/>
+          <p:cNvPr id="134" name="Google Shape;134;p20"/>
           <p:cNvSpPr txBox="1"/>
           <p:nvPr/>
         </p:nvSpPr>
@@ -8899,7 +9137,7 @@
       </p:sp>
       <p:grpSp>
         <p:nvGrpSpPr>
-          <p:cNvPr id="129" name="Google Shape;129;p19"/>
+          <p:cNvPr id="135" name="Google Shape;135;p20"/>
           <p:cNvGrpSpPr/>
           <p:nvPr/>
         </p:nvGrpSpPr>
@@ -8913,7 +9151,7 @@
         </p:grpSpPr>
         <p:pic>
           <p:nvPicPr>
-            <p:cNvPr id="130" name="Google Shape;130;p19" title="mean_replicates_prefilter.jpg"/>
+            <p:cNvPr id="136" name="Google Shape;136;p20" title="mean_replicates_prefilter.jpg"/>
             <p:cNvPicPr preferRelativeResize="0"/>
             <p:nvPr/>
           </p:nvPicPr>
@@ -8940,7 +9178,7 @@
         </p:pic>
         <p:pic>
           <p:nvPicPr>
-            <p:cNvPr id="131" name="Google Shape;131;p19" title="mean_replicates_prefilter.jpg"/>
+            <p:cNvPr id="137" name="Google Shape;137;p20" title="mean_replicates_prefilter.jpg"/>
             <p:cNvPicPr preferRelativeResize="0"/>
             <p:nvPr/>
           </p:nvPicPr>
@@ -8967,7 +9205,7 @@
         </p:pic>
         <p:pic>
           <p:nvPicPr>
-            <p:cNvPr id="132" name="Google Shape;132;p19" title="mean_replicates_prefilter.jpg"/>
+            <p:cNvPr id="138" name="Google Shape;138;p20" title="mean_replicates_prefilter.jpg"/>
             <p:cNvPicPr preferRelativeResize="0"/>
             <p:nvPr/>
           </p:nvPicPr>
@@ -8995,7 +9233,7 @@
       </p:grpSp>
       <p:pic>
         <p:nvPicPr>
-          <p:cNvPr id="133" name="Google Shape;133;p19" title="mean_replicates_postfilter.jpg"/>
+          <p:cNvPr id="139" name="Google Shape;139;p20" title="mean_replicates_postfilter.jpg"/>
           <p:cNvPicPr preferRelativeResize="0"/>
           <p:nvPr/>
         </p:nvPicPr>
@@ -9023,7 +9261,7 @@
       </p:pic>
       <p:pic>
         <p:nvPicPr>
-          <p:cNvPr id="134" name="Google Shape;134;p19" title="panel_d_var_replicates.jpg"/>
+          <p:cNvPr id="140" name="Google Shape;140;p20" title="panel_d_var_replicates.jpg"/>
           <p:cNvPicPr preferRelativeResize="0"/>
           <p:nvPr/>
         </p:nvPicPr>

</xml_diff>

<commit_message>
docs: resync figure numbering from Drive decks (2026-10-20)
Changed decks: Fig R1 (Fig MyM, Fig R2, Fig R3: export noise only).
No numero_actual changes.
sesgo_representatividad -> estado revisar: slide now has a panel D (G4 retention by GC) matching figures/exploratorio_g4_representatividad/g4_retencion_por_gc.jpg, not produced by its script.

Co-Authored-By: Claude Opus 5.5 <noreply@anthropic.com>
</commit_message>
<xml_diff>
--- a/docs/Fig R1.pptx
+++ b/docs/Fig R1.pptx
@@ -1004,7 +1004,7 @@
   <p:cSld>
     <p:spTree>
       <p:nvGrpSpPr>
-        <p:cNvPr id="95" name="Shape 95"/>
+        <p:cNvPr id="99" name="Shape 99"/>
         <p:cNvGrpSpPr/>
         <p:nvPr/>
       </p:nvGrpSpPr>
@@ -1018,7 +1018,7 @@
       </p:grpSpPr>
       <p:sp>
         <p:nvSpPr>
-          <p:cNvPr id="96" name="Google Shape;96;g396169342f1_0_0:notes"/>
+          <p:cNvPr id="100" name="Google Shape;100;g396169342f1_0_0:notes"/>
           <p:cNvSpPr/>
           <p:nvPr>
             <p:ph idx="2" type="sldImg"/>
@@ -1053,7 +1053,7 @@
       </p:sp>
       <p:sp>
         <p:nvSpPr>
-          <p:cNvPr id="97" name="Google Shape;97;g396169342f1_0_0:notes"/>
+          <p:cNvPr id="101" name="Google Shape;101;g396169342f1_0_0:notes"/>
           <p:cNvSpPr txBox="1"/>
           <p:nvPr>
             <p:ph idx="1" type="body"/>
@@ -1103,7 +1103,7 @@
   <p:cSld>
     <p:spTree>
       <p:nvGrpSpPr>
-        <p:cNvPr id="101" name="Shape 101"/>
+        <p:cNvPr id="105" name="Shape 105"/>
         <p:cNvGrpSpPr/>
         <p:nvPr/>
       </p:nvGrpSpPr>
@@ -1117,7 +1117,7 @@
       </p:grpSpPr>
       <p:sp>
         <p:nvSpPr>
-          <p:cNvPr id="102" name="Google Shape;102;g3f5e045cd8f_0_8:notes"/>
+          <p:cNvPr id="106" name="Google Shape;106;g3f5e045cd8f_0_8:notes"/>
           <p:cNvSpPr/>
           <p:nvPr>
             <p:ph idx="2" type="sldImg"/>
@@ -1152,7 +1152,7 @@
       </p:sp>
       <p:sp>
         <p:nvSpPr>
-          <p:cNvPr id="103" name="Google Shape;103;g3f5e045cd8f_0_8:notes"/>
+          <p:cNvPr id="107" name="Google Shape;107;g3f5e045cd8f_0_8:notes"/>
           <p:cNvSpPr txBox="1"/>
           <p:nvPr>
             <p:ph idx="1" type="body"/>
@@ -1202,7 +1202,7 @@
   <p:cSld>
     <p:spTree>
       <p:nvGrpSpPr>
-        <p:cNvPr id="107" name="Shape 107"/>
+        <p:cNvPr id="111" name="Shape 111"/>
         <p:cNvGrpSpPr/>
         <p:nvPr/>
       </p:nvGrpSpPr>
@@ -1216,7 +1216,7 @@
       </p:grpSpPr>
       <p:sp>
         <p:nvSpPr>
-          <p:cNvPr id="108" name="Google Shape;108;g3f5e045cd8f_0_2:notes"/>
+          <p:cNvPr id="112" name="Google Shape;112;g3f5e045cd8f_0_2:notes"/>
           <p:cNvSpPr/>
           <p:nvPr>
             <p:ph idx="2" type="sldImg"/>
@@ -1251,7 +1251,7 @@
       </p:sp>
       <p:sp>
         <p:nvSpPr>
-          <p:cNvPr id="109" name="Google Shape;109;g3f5e045cd8f_0_2:notes"/>
+          <p:cNvPr id="113" name="Google Shape;113;g3f5e045cd8f_0_2:notes"/>
           <p:cNvSpPr txBox="1"/>
           <p:nvPr>
             <p:ph idx="1" type="body"/>
@@ -1301,7 +1301,7 @@
   <p:cSld>
     <p:spTree>
       <p:nvGrpSpPr>
-        <p:cNvPr id="113" name="Shape 113"/>
+        <p:cNvPr id="117" name="Shape 117"/>
         <p:cNvGrpSpPr/>
         <p:nvPr/>
       </p:nvGrpSpPr>
@@ -1315,7 +1315,7 @@
       </p:grpSpPr>
       <p:sp>
         <p:nvSpPr>
-          <p:cNvPr id="114" name="Google Shape;114;g3d678bf7346_0_23:notes"/>
+          <p:cNvPr id="118" name="Google Shape;118;g3d678bf7346_0_23:notes"/>
           <p:cNvSpPr/>
           <p:nvPr>
             <p:ph idx="2" type="sldImg"/>
@@ -1350,7 +1350,7 @@
       </p:sp>
       <p:sp>
         <p:nvSpPr>
-          <p:cNvPr id="115" name="Google Shape;115;g3d678bf7346_0_23:notes"/>
+          <p:cNvPr id="119" name="Google Shape;119;g3d678bf7346_0_23:notes"/>
           <p:cNvSpPr txBox="1"/>
           <p:nvPr>
             <p:ph idx="1" type="body"/>
@@ -1400,7 +1400,7 @@
   <p:cSld>
     <p:spTree>
       <p:nvGrpSpPr>
-        <p:cNvPr id="121" name="Shape 121"/>
+        <p:cNvPr id="125" name="Shape 125"/>
         <p:cNvGrpSpPr/>
         <p:nvPr/>
       </p:nvGrpSpPr>
@@ -1414,7 +1414,7 @@
       </p:grpSpPr>
       <p:sp>
         <p:nvSpPr>
-          <p:cNvPr id="122" name="Google Shape;122;g3d678bf7346_0_17:notes"/>
+          <p:cNvPr id="126" name="Google Shape;126;g3d678bf7346_0_17:notes"/>
           <p:cNvSpPr/>
           <p:nvPr>
             <p:ph idx="2" type="sldImg"/>
@@ -1449,7 +1449,7 @@
       </p:sp>
       <p:sp>
         <p:nvSpPr>
-          <p:cNvPr id="123" name="Google Shape;123;g3d678bf7346_0_17:notes"/>
+          <p:cNvPr id="127" name="Google Shape;127;g3d678bf7346_0_17:notes"/>
           <p:cNvSpPr txBox="1"/>
           <p:nvPr>
             <p:ph idx="1" type="body"/>
@@ -6915,8 +6915,8 @@
         </p:nvSpPr>
         <p:spPr>
           <a:xfrm>
-            <a:off x="2314025" y="3568500"/>
-            <a:ext cx="5866500" cy="1554600"/>
+            <a:off x="0" y="2505952"/>
+            <a:ext cx="4275600" cy="1133100"/>
           </a:xfrm>
           <a:prstGeom prst="rect">
             <a:avLst/>
@@ -6927,7 +6927,7 @@
           </a:ln>
         </p:spPr>
         <p:txBody>
-          <a:bodyPr anchorCtr="0" anchor="t" bIns="91425" lIns="91425" spcFirstLastPara="1" rIns="91425" wrap="square" tIns="91425">
+          <a:bodyPr anchorCtr="0" anchor="t" bIns="66625" lIns="66625" spcFirstLastPara="1" rIns="66625" wrap="square" tIns="66625">
             <a:spAutoFit/>
           </a:bodyPr>
           <a:lstStyle/>
@@ -6942,7 +6942,7 @@
               <a:buNone/>
             </a:pPr>
             <a:r>
-              <a:rPr b="1" lang="es-419" sz="1200">
+              <a:rPr b="1" lang="es-419" sz="875">
                 <a:solidFill>
                   <a:schemeClr val="dk2"/>
                 </a:solidFill>
@@ -6950,7 +6950,7 @@
               <a:t>Análisis de sesgos sistemáticos en la representatividad de la library.</a:t>
             </a:r>
             <a:r>
-              <a:rPr lang="es-419" sz="1200">
+              <a:rPr lang="es-419" sz="875">
                 <a:solidFill>
                   <a:schemeClr val="dk2"/>
                 </a:solidFill>
@@ -6958,7 +6958,7 @@
               <a:t> A) </a:t>
             </a:r>
             <a:r>
-              <a:rPr lang="es-419" sz="1100">
+              <a:rPr lang="es-419" sz="802">
                 <a:solidFill>
                   <a:schemeClr val="dk1"/>
                 </a:solidFill>
@@ -6966,7 +6966,7 @@
               <a:t>Diagrama de </a:t>
             </a:r>
             <a:r>
-              <a:rPr i="1" lang="es-419" sz="1100">
+              <a:rPr i="1" lang="es-419" sz="802">
                 <a:solidFill>
                   <a:schemeClr val="dk1"/>
                 </a:solidFill>
@@ -6974,407 +6974,14 @@
               <a:t>Venn</a:t>
             </a:r>
             <a:r>
-              <a:rPr lang="es-419" sz="1100">
+              <a:rPr lang="es-419" sz="802">
                 <a:solidFill>
                   <a:schemeClr val="dk1"/>
                 </a:solidFill>
               </a:rPr>
               <a:t> indicando el número de secuencias detectadas en la secuenciación de células integradas con el reportero para el proyecto de splicing (previo a cualquier selección por expresión), en comparación con la secuenciación del proyecto actual, en al menos una réplica. B) Gráfico de violin representando el contenido de GC de los promotores detectados y en los no detectados durante el presente ensayo reportero. C) Distribución del contenido del contenido de GC de las lecturas obtenidas, en ambas réplicas.</a:t>
             </a:r>
-            <a:endParaRPr sz="1200">
-              <a:solidFill>
-                <a:schemeClr val="dk2"/>
-              </a:solidFill>
-            </a:endParaRPr>
-          </a:p>
-        </p:txBody>
-      </p:sp>
-      <p:pic>
-        <p:nvPicPr>
-          <p:cNvPr id="77" name="Google Shape;77;p15"/>
-          <p:cNvPicPr preferRelativeResize="0"/>
-          <p:nvPr/>
-        </p:nvPicPr>
-        <p:blipFill rotWithShape="1">
-          <a:blip r:embed="rId3">
-            <a:alphaModFix/>
-          </a:blip>
-          <a:srcRect b="0" l="744" r="0" t="970"/>
-          <a:stretch/>
-        </p:blipFill>
-        <p:spPr>
-          <a:xfrm>
-            <a:off x="86225" y="82225"/>
-            <a:ext cx="3256551" cy="3242825"/>
-          </a:xfrm>
-          <a:prstGeom prst="rect">
-            <a:avLst/>
-          </a:prstGeom>
-          <a:noFill/>
-          <a:ln>
-            <a:noFill/>
-          </a:ln>
-        </p:spPr>
-      </p:pic>
-      <p:sp>
-        <p:nvSpPr>
-          <p:cNvPr id="78" name="Google Shape;78;p15"/>
-          <p:cNvSpPr txBox="1"/>
-          <p:nvPr/>
-        </p:nvSpPr>
-        <p:spPr>
-          <a:xfrm>
-            <a:off x="1446789" y="374911"/>
-            <a:ext cx="721500" cy="354000"/>
-          </a:xfrm>
-          <a:prstGeom prst="rect">
-            <a:avLst/>
-          </a:prstGeom>
-          <a:solidFill>
-            <a:srgbClr val="EFF6FB"/>
-          </a:solidFill>
-          <a:ln>
-            <a:noFill/>
-          </a:ln>
-        </p:spPr>
-        <p:txBody>
-          <a:bodyPr anchorCtr="0" anchor="t" bIns="91425" lIns="91425" spcFirstLastPara="1" rIns="91425" wrap="square" tIns="91425">
-            <a:spAutoFit/>
-          </a:bodyPr>
-          <a:lstStyle/>
-          <a:p>
-            <a:pPr indent="0" lvl="0" marL="0" rtl="0" algn="l">
-              <a:spcBef>
-                <a:spcPts val="0"/>
-              </a:spcBef>
-              <a:spcAft>
-                <a:spcPts val="0"/>
-              </a:spcAft>
-              <a:buNone/>
-            </a:pPr>
-            <a:r>
-              <a:rPr lang="es-419" sz="1100">
-                <a:solidFill>
-                  <a:schemeClr val="dk2"/>
-                </a:solidFill>
-              </a:rPr>
-              <a:t>2012</a:t>
-            </a:r>
-            <a:endParaRPr sz="1100">
-              <a:solidFill>
-                <a:schemeClr val="dk2"/>
-              </a:solidFill>
-            </a:endParaRPr>
-          </a:p>
-        </p:txBody>
-      </p:sp>
-      <p:sp>
-        <p:nvSpPr>
-          <p:cNvPr id="79" name="Google Shape;79;p15"/>
-          <p:cNvSpPr txBox="1"/>
-          <p:nvPr/>
-        </p:nvSpPr>
-        <p:spPr>
-          <a:xfrm>
-            <a:off x="1370694" y="185978"/>
-            <a:ext cx="806100" cy="369300"/>
-          </a:xfrm>
-          <a:prstGeom prst="rect">
-            <a:avLst/>
-          </a:prstGeom>
-          <a:noFill/>
-          <a:ln>
-            <a:noFill/>
-          </a:ln>
-        </p:spPr>
-        <p:txBody>
-          <a:bodyPr anchorCtr="0" anchor="t" bIns="91425" lIns="91425" spcFirstLastPara="1" rIns="91425" wrap="square" tIns="91425">
-            <a:spAutoFit/>
-          </a:bodyPr>
-          <a:lstStyle/>
-          <a:p>
-            <a:pPr indent="0" lvl="0" marL="0" rtl="0" algn="l">
-              <a:spcBef>
-                <a:spcPts val="0"/>
-              </a:spcBef>
-              <a:spcAft>
-                <a:spcPts val="0"/>
-              </a:spcAft>
-              <a:buNone/>
-            </a:pPr>
-            <a:r>
-              <a:rPr lang="es-419" sz="1200">
-                <a:solidFill>
-                  <a:schemeClr val="dk2"/>
-                </a:solidFill>
-              </a:rPr>
-              <a:t>Library</a:t>
-            </a:r>
-            <a:endParaRPr sz="1200">
-              <a:solidFill>
-                <a:schemeClr val="dk2"/>
-              </a:solidFill>
-            </a:endParaRPr>
-          </a:p>
-        </p:txBody>
-      </p:sp>
-      <p:sp>
-        <p:nvSpPr>
-          <p:cNvPr id="80" name="Google Shape;80;p15"/>
-          <p:cNvSpPr txBox="1"/>
-          <p:nvPr/>
-        </p:nvSpPr>
-        <p:spPr>
-          <a:xfrm>
-            <a:off x="561071" y="1510800"/>
-            <a:ext cx="540900" cy="354000"/>
-          </a:xfrm>
-          <a:prstGeom prst="rect">
-            <a:avLst/>
-          </a:prstGeom>
-          <a:solidFill>
-            <a:srgbClr val="BCD9E5"/>
-          </a:solidFill>
-          <a:ln>
-            <a:noFill/>
-          </a:ln>
-        </p:spPr>
-        <p:txBody>
-          <a:bodyPr anchorCtr="0" anchor="t" bIns="91425" lIns="91425" spcFirstLastPara="1" rIns="91425" wrap="square" tIns="91425">
-            <a:spAutoFit/>
-          </a:bodyPr>
-          <a:lstStyle/>
-          <a:p>
-            <a:pPr indent="0" lvl="0" marL="0" rtl="0" algn="l">
-              <a:spcBef>
-                <a:spcPts val="0"/>
-              </a:spcBef>
-              <a:spcAft>
-                <a:spcPts val="0"/>
-              </a:spcAft>
-              <a:buNone/>
-            </a:pPr>
-            <a:r>
-              <a:rPr lang="es-419" sz="1100">
-                <a:solidFill>
-                  <a:schemeClr val="dk2"/>
-                </a:solidFill>
-              </a:rPr>
-              <a:t>1047</a:t>
-            </a:r>
-            <a:endParaRPr sz="1100">
-              <a:solidFill>
-                <a:schemeClr val="dk2"/>
-              </a:solidFill>
-            </a:endParaRPr>
-          </a:p>
-        </p:txBody>
-      </p:sp>
-      <p:sp>
-        <p:nvSpPr>
-          <p:cNvPr id="81" name="Google Shape;81;p15"/>
-          <p:cNvSpPr txBox="1"/>
-          <p:nvPr/>
-        </p:nvSpPr>
-        <p:spPr>
-          <a:xfrm>
-            <a:off x="1414623" y="1510788"/>
-            <a:ext cx="645000" cy="354000"/>
-          </a:xfrm>
-          <a:prstGeom prst="rect">
-            <a:avLst/>
-          </a:prstGeom>
-          <a:solidFill>
-            <a:srgbClr val="B3D9DD"/>
-          </a:solidFill>
-          <a:ln>
-            <a:noFill/>
-          </a:ln>
-        </p:spPr>
-        <p:txBody>
-          <a:bodyPr anchorCtr="0" anchor="t" bIns="91425" lIns="91425" spcFirstLastPara="1" rIns="91425" wrap="square" tIns="91425">
-            <a:spAutoFit/>
-          </a:bodyPr>
-          <a:lstStyle/>
-          <a:p>
-            <a:pPr indent="0" lvl="0" marL="0" rtl="0" algn="l">
-              <a:spcBef>
-                <a:spcPts val="0"/>
-              </a:spcBef>
-              <a:spcAft>
-                <a:spcPts val="0"/>
-              </a:spcAft>
-              <a:buNone/>
-            </a:pPr>
-            <a:r>
-              <a:rPr lang="es-419" sz="1100">
-                <a:solidFill>
-                  <a:schemeClr val="dk2"/>
-                </a:solidFill>
-              </a:rPr>
-              <a:t>18292</a:t>
-            </a:r>
-            <a:endParaRPr sz="1100">
-              <a:solidFill>
-                <a:schemeClr val="dk2"/>
-              </a:solidFill>
-            </a:endParaRPr>
-          </a:p>
-        </p:txBody>
-      </p:sp>
-      <p:sp>
-        <p:nvSpPr>
-          <p:cNvPr id="82" name="Google Shape;82;p15"/>
-          <p:cNvSpPr txBox="1"/>
-          <p:nvPr/>
-        </p:nvSpPr>
-        <p:spPr>
-          <a:xfrm>
-            <a:off x="2326403" y="1510788"/>
-            <a:ext cx="645000" cy="354000"/>
-          </a:xfrm>
-          <a:prstGeom prst="rect">
-            <a:avLst/>
-          </a:prstGeom>
-          <a:solidFill>
-            <a:srgbClr val="CDE8E8"/>
-          </a:solidFill>
-          <a:ln>
-            <a:noFill/>
-          </a:ln>
-        </p:spPr>
-        <p:txBody>
-          <a:bodyPr anchorCtr="0" anchor="t" bIns="91425" lIns="91425" spcFirstLastPara="1" rIns="91425" wrap="square" tIns="91425">
-            <a:spAutoFit/>
-          </a:bodyPr>
-          <a:lstStyle/>
-          <a:p>
-            <a:pPr indent="0" lvl="0" marL="0" rtl="0" algn="l">
-              <a:spcBef>
-                <a:spcPts val="0"/>
-              </a:spcBef>
-              <a:spcAft>
-                <a:spcPts val="0"/>
-              </a:spcAft>
-              <a:buNone/>
-            </a:pPr>
-            <a:r>
-              <a:rPr lang="es-419" sz="1100">
-                <a:solidFill>
-                  <a:schemeClr val="dk2"/>
-                </a:solidFill>
-              </a:rPr>
-              <a:t>2560</a:t>
-            </a:r>
-            <a:endParaRPr sz="1100">
-              <a:solidFill>
-                <a:schemeClr val="dk2"/>
-              </a:solidFill>
-            </a:endParaRPr>
-          </a:p>
-        </p:txBody>
-      </p:sp>
-      <p:sp>
-        <p:nvSpPr>
-          <p:cNvPr id="83" name="Google Shape;83;p15"/>
-          <p:cNvSpPr txBox="1"/>
-          <p:nvPr/>
-        </p:nvSpPr>
-        <p:spPr>
-          <a:xfrm>
-            <a:off x="247452" y="1107025"/>
-            <a:ext cx="1150200" cy="554100"/>
-          </a:xfrm>
-          <a:prstGeom prst="rect">
-            <a:avLst/>
-          </a:prstGeom>
-          <a:noFill/>
-          <a:ln>
-            <a:noFill/>
-          </a:ln>
-        </p:spPr>
-        <p:txBody>
-          <a:bodyPr anchorCtr="0" anchor="t" bIns="91425" lIns="91425" spcFirstLastPara="1" rIns="91425" wrap="square" tIns="91425">
-            <a:spAutoFit/>
-          </a:bodyPr>
-          <a:lstStyle/>
-          <a:p>
-            <a:pPr indent="0" lvl="0" marL="0" rtl="0" algn="ctr">
-              <a:spcBef>
-                <a:spcPts val="0"/>
-              </a:spcBef>
-              <a:spcAft>
-                <a:spcPts val="0"/>
-              </a:spcAft>
-              <a:buNone/>
-            </a:pPr>
-            <a:r>
-              <a:rPr lang="es-419" sz="1200">
-                <a:solidFill>
-                  <a:schemeClr val="dk2"/>
-                </a:solidFill>
-              </a:rPr>
-              <a:t>MPRA </a:t>
-            </a:r>
-            <a:r>
-              <a:rPr lang="es-419" sz="1200">
-                <a:solidFill>
-                  <a:schemeClr val="dk2"/>
-                </a:solidFill>
-              </a:rPr>
-              <a:t>transcripción</a:t>
-            </a:r>
-            <a:endParaRPr sz="1200">
-              <a:solidFill>
-                <a:schemeClr val="dk2"/>
-              </a:solidFill>
-            </a:endParaRPr>
-          </a:p>
-        </p:txBody>
-      </p:sp>
-      <p:sp>
-        <p:nvSpPr>
-          <p:cNvPr id="84" name="Google Shape;84;p15"/>
-          <p:cNvSpPr txBox="1"/>
-          <p:nvPr/>
-        </p:nvSpPr>
-        <p:spPr>
-          <a:xfrm>
-            <a:off x="2063844" y="1107021"/>
-            <a:ext cx="1071900" cy="554100"/>
-          </a:xfrm>
-          <a:prstGeom prst="rect">
-            <a:avLst/>
-          </a:prstGeom>
-          <a:noFill/>
-          <a:ln>
-            <a:noFill/>
-          </a:ln>
-        </p:spPr>
-        <p:txBody>
-          <a:bodyPr anchorCtr="0" anchor="t" bIns="91425" lIns="91425" spcFirstLastPara="1" rIns="91425" wrap="square" tIns="91425">
-            <a:spAutoFit/>
-          </a:bodyPr>
-          <a:lstStyle/>
-          <a:p>
-            <a:pPr indent="0" lvl="0" marL="0" rtl="0" algn="ctr">
-              <a:spcBef>
-                <a:spcPts val="0"/>
-              </a:spcBef>
-              <a:spcAft>
-                <a:spcPts val="0"/>
-              </a:spcAft>
-              <a:buNone/>
-            </a:pPr>
-            <a:r>
-              <a:rPr lang="es-419" sz="1200">
-                <a:solidFill>
-                  <a:schemeClr val="dk2"/>
-                </a:solidFill>
-              </a:rPr>
-              <a:t>MPRA splicing</a:t>
-            </a:r>
-            <a:endParaRPr sz="1200">
+            <a:endParaRPr sz="875">
               <a:solidFill>
                 <a:schemeClr val="dk2"/>
               </a:solidFill>
@@ -7384,21 +6991,429 @@
       </p:sp>
       <p:grpSp>
         <p:nvGrpSpPr>
-          <p:cNvPr id="85" name="Google Shape;85;p15"/>
+          <p:cNvPr id="77" name="Google Shape;77;p15"/>
           <p:cNvGrpSpPr/>
           <p:nvPr/>
         </p:nvGrpSpPr>
         <p:grpSpPr>
           <a:xfrm>
-            <a:off x="5506445" y="266008"/>
-            <a:ext cx="3568830" cy="2626092"/>
+            <a:off x="62841" y="82223"/>
+            <a:ext cx="2373374" cy="2363371"/>
+            <a:chOff x="86225" y="82225"/>
+            <a:chExt cx="3256551" cy="3242825"/>
+          </a:xfrm>
+        </p:grpSpPr>
+        <p:pic>
+          <p:nvPicPr>
+            <p:cNvPr id="78" name="Google Shape;78;p15"/>
+            <p:cNvPicPr preferRelativeResize="0"/>
+            <p:nvPr/>
+          </p:nvPicPr>
+          <p:blipFill rotWithShape="1">
+            <a:blip r:embed="rId3">
+              <a:alphaModFix/>
+            </a:blip>
+            <a:srcRect b="0" l="744" r="0" t="970"/>
+            <a:stretch/>
+          </p:blipFill>
+          <p:spPr>
+            <a:xfrm>
+              <a:off x="86225" y="82225"/>
+              <a:ext cx="3256551" cy="3242825"/>
+            </a:xfrm>
+            <a:prstGeom prst="rect">
+              <a:avLst/>
+            </a:prstGeom>
+            <a:noFill/>
+            <a:ln>
+              <a:noFill/>
+            </a:ln>
+          </p:spPr>
+        </p:pic>
+        <p:sp>
+          <p:nvSpPr>
+            <p:cNvPr id="79" name="Google Shape;79;p15"/>
+            <p:cNvSpPr txBox="1"/>
+            <p:nvPr/>
+          </p:nvSpPr>
+          <p:spPr>
+            <a:xfrm>
+              <a:off x="1446789" y="374911"/>
+              <a:ext cx="721500" cy="354000"/>
+            </a:xfrm>
+            <a:prstGeom prst="rect">
+              <a:avLst/>
+            </a:prstGeom>
+            <a:solidFill>
+              <a:srgbClr val="EFF6FB"/>
+            </a:solidFill>
+            <a:ln>
+              <a:noFill/>
+            </a:ln>
+          </p:spPr>
+          <p:txBody>
+            <a:bodyPr anchorCtr="0" anchor="t" bIns="66625" lIns="66625" spcFirstLastPara="1" rIns="66625" wrap="square" tIns="66625">
+              <a:spAutoFit/>
+            </a:bodyPr>
+            <a:lstStyle/>
+            <a:p>
+              <a:pPr indent="0" lvl="0" marL="0" rtl="0" algn="l">
+                <a:spcBef>
+                  <a:spcPts val="0"/>
+                </a:spcBef>
+                <a:spcAft>
+                  <a:spcPts val="0"/>
+                </a:spcAft>
+                <a:buNone/>
+              </a:pPr>
+              <a:r>
+                <a:rPr lang="es-419" sz="802">
+                  <a:solidFill>
+                    <a:schemeClr val="dk2"/>
+                  </a:solidFill>
+                </a:rPr>
+                <a:t>2012</a:t>
+              </a:r>
+              <a:endParaRPr sz="802">
+                <a:solidFill>
+                  <a:schemeClr val="dk2"/>
+                </a:solidFill>
+              </a:endParaRPr>
+            </a:p>
+          </p:txBody>
+        </p:sp>
+        <p:sp>
+          <p:nvSpPr>
+            <p:cNvPr id="80" name="Google Shape;80;p15"/>
+            <p:cNvSpPr txBox="1"/>
+            <p:nvPr/>
+          </p:nvSpPr>
+          <p:spPr>
+            <a:xfrm>
+              <a:off x="1370694" y="185978"/>
+              <a:ext cx="806100" cy="369300"/>
+            </a:xfrm>
+            <a:prstGeom prst="rect">
+              <a:avLst/>
+            </a:prstGeom>
+            <a:noFill/>
+            <a:ln>
+              <a:noFill/>
+            </a:ln>
+          </p:spPr>
+          <p:txBody>
+            <a:bodyPr anchorCtr="0" anchor="t" bIns="66625" lIns="66625" spcFirstLastPara="1" rIns="66625" wrap="square" tIns="66625">
+              <a:spAutoFit/>
+            </a:bodyPr>
+            <a:lstStyle/>
+            <a:p>
+              <a:pPr indent="0" lvl="0" marL="0" rtl="0" algn="l">
+                <a:spcBef>
+                  <a:spcPts val="0"/>
+                </a:spcBef>
+                <a:spcAft>
+                  <a:spcPts val="0"/>
+                </a:spcAft>
+                <a:buNone/>
+              </a:pPr>
+              <a:r>
+                <a:rPr lang="es-419" sz="875">
+                  <a:solidFill>
+                    <a:schemeClr val="dk2"/>
+                  </a:solidFill>
+                </a:rPr>
+                <a:t>Library</a:t>
+              </a:r>
+              <a:endParaRPr sz="875">
+                <a:solidFill>
+                  <a:schemeClr val="dk2"/>
+                </a:solidFill>
+              </a:endParaRPr>
+            </a:p>
+          </p:txBody>
+        </p:sp>
+        <p:sp>
+          <p:nvSpPr>
+            <p:cNvPr id="81" name="Google Shape;81;p15"/>
+            <p:cNvSpPr txBox="1"/>
+            <p:nvPr/>
+          </p:nvSpPr>
+          <p:spPr>
+            <a:xfrm>
+              <a:off x="561071" y="1510800"/>
+              <a:ext cx="540900" cy="354000"/>
+            </a:xfrm>
+            <a:prstGeom prst="rect">
+              <a:avLst/>
+            </a:prstGeom>
+            <a:solidFill>
+              <a:srgbClr val="BCD9E5"/>
+            </a:solidFill>
+            <a:ln>
+              <a:noFill/>
+            </a:ln>
+          </p:spPr>
+          <p:txBody>
+            <a:bodyPr anchorCtr="0" anchor="t" bIns="66625" lIns="66625" spcFirstLastPara="1" rIns="66625" wrap="square" tIns="66625">
+              <a:spAutoFit/>
+            </a:bodyPr>
+            <a:lstStyle/>
+            <a:p>
+              <a:pPr indent="0" lvl="0" marL="0" rtl="0" algn="l">
+                <a:spcBef>
+                  <a:spcPts val="0"/>
+                </a:spcBef>
+                <a:spcAft>
+                  <a:spcPts val="0"/>
+                </a:spcAft>
+                <a:buNone/>
+              </a:pPr>
+              <a:r>
+                <a:rPr lang="es-419" sz="802">
+                  <a:solidFill>
+                    <a:schemeClr val="dk2"/>
+                  </a:solidFill>
+                </a:rPr>
+                <a:t>1047</a:t>
+              </a:r>
+              <a:endParaRPr sz="802">
+                <a:solidFill>
+                  <a:schemeClr val="dk2"/>
+                </a:solidFill>
+              </a:endParaRPr>
+            </a:p>
+          </p:txBody>
+        </p:sp>
+        <p:sp>
+          <p:nvSpPr>
+            <p:cNvPr id="82" name="Google Shape;82;p15"/>
+            <p:cNvSpPr txBox="1"/>
+            <p:nvPr/>
+          </p:nvSpPr>
+          <p:spPr>
+            <a:xfrm>
+              <a:off x="1414623" y="1510788"/>
+              <a:ext cx="645000" cy="354000"/>
+            </a:xfrm>
+            <a:prstGeom prst="rect">
+              <a:avLst/>
+            </a:prstGeom>
+            <a:solidFill>
+              <a:srgbClr val="B3D9DD"/>
+            </a:solidFill>
+            <a:ln>
+              <a:noFill/>
+            </a:ln>
+          </p:spPr>
+          <p:txBody>
+            <a:bodyPr anchorCtr="0" anchor="t" bIns="66625" lIns="66625" spcFirstLastPara="1" rIns="66625" wrap="square" tIns="66625">
+              <a:spAutoFit/>
+            </a:bodyPr>
+            <a:lstStyle/>
+            <a:p>
+              <a:pPr indent="0" lvl="0" marL="0" rtl="0" algn="l">
+                <a:spcBef>
+                  <a:spcPts val="0"/>
+                </a:spcBef>
+                <a:spcAft>
+                  <a:spcPts val="0"/>
+                </a:spcAft>
+                <a:buNone/>
+              </a:pPr>
+              <a:r>
+                <a:rPr lang="es-419" sz="802">
+                  <a:solidFill>
+                    <a:schemeClr val="dk2"/>
+                  </a:solidFill>
+                </a:rPr>
+                <a:t>18292</a:t>
+              </a:r>
+              <a:endParaRPr sz="802">
+                <a:solidFill>
+                  <a:schemeClr val="dk2"/>
+                </a:solidFill>
+              </a:endParaRPr>
+            </a:p>
+          </p:txBody>
+        </p:sp>
+        <p:sp>
+          <p:nvSpPr>
+            <p:cNvPr id="83" name="Google Shape;83;p15"/>
+            <p:cNvSpPr txBox="1"/>
+            <p:nvPr/>
+          </p:nvSpPr>
+          <p:spPr>
+            <a:xfrm>
+              <a:off x="2326403" y="1510788"/>
+              <a:ext cx="645000" cy="354000"/>
+            </a:xfrm>
+            <a:prstGeom prst="rect">
+              <a:avLst/>
+            </a:prstGeom>
+            <a:solidFill>
+              <a:srgbClr val="CDE8E8"/>
+            </a:solidFill>
+            <a:ln>
+              <a:noFill/>
+            </a:ln>
+          </p:spPr>
+          <p:txBody>
+            <a:bodyPr anchorCtr="0" anchor="t" bIns="66625" lIns="66625" spcFirstLastPara="1" rIns="66625" wrap="square" tIns="66625">
+              <a:spAutoFit/>
+            </a:bodyPr>
+            <a:lstStyle/>
+            <a:p>
+              <a:pPr indent="0" lvl="0" marL="0" rtl="0" algn="l">
+                <a:spcBef>
+                  <a:spcPts val="0"/>
+                </a:spcBef>
+                <a:spcAft>
+                  <a:spcPts val="0"/>
+                </a:spcAft>
+                <a:buNone/>
+              </a:pPr>
+              <a:r>
+                <a:rPr lang="es-419" sz="802">
+                  <a:solidFill>
+                    <a:schemeClr val="dk2"/>
+                  </a:solidFill>
+                </a:rPr>
+                <a:t>2560</a:t>
+              </a:r>
+              <a:endParaRPr sz="802">
+                <a:solidFill>
+                  <a:schemeClr val="dk2"/>
+                </a:solidFill>
+              </a:endParaRPr>
+            </a:p>
+          </p:txBody>
+        </p:sp>
+        <p:sp>
+          <p:nvSpPr>
+            <p:cNvPr id="84" name="Google Shape;84;p15"/>
+            <p:cNvSpPr txBox="1"/>
+            <p:nvPr/>
+          </p:nvSpPr>
+          <p:spPr>
+            <a:xfrm>
+              <a:off x="247452" y="1107025"/>
+              <a:ext cx="1150200" cy="554100"/>
+            </a:xfrm>
+            <a:prstGeom prst="rect">
+              <a:avLst/>
+            </a:prstGeom>
+            <a:noFill/>
+            <a:ln>
+              <a:noFill/>
+            </a:ln>
+          </p:spPr>
+          <p:txBody>
+            <a:bodyPr anchorCtr="0" anchor="t" bIns="66625" lIns="66625" spcFirstLastPara="1" rIns="66625" wrap="square" tIns="66625">
+              <a:spAutoFit/>
+            </a:bodyPr>
+            <a:lstStyle/>
+            <a:p>
+              <a:pPr indent="0" lvl="0" marL="0" rtl="0" algn="ctr">
+                <a:spcBef>
+                  <a:spcPts val="0"/>
+                </a:spcBef>
+                <a:spcAft>
+                  <a:spcPts val="0"/>
+                </a:spcAft>
+                <a:buNone/>
+              </a:pPr>
+              <a:r>
+                <a:rPr lang="es-419" sz="875">
+                  <a:solidFill>
+                    <a:schemeClr val="dk2"/>
+                  </a:solidFill>
+                </a:rPr>
+                <a:t>MPRA </a:t>
+              </a:r>
+              <a:r>
+                <a:rPr lang="es-419" sz="875">
+                  <a:solidFill>
+                    <a:schemeClr val="dk2"/>
+                  </a:solidFill>
+                </a:rPr>
+                <a:t>transcripción</a:t>
+              </a:r>
+              <a:endParaRPr sz="875">
+                <a:solidFill>
+                  <a:schemeClr val="dk2"/>
+                </a:solidFill>
+              </a:endParaRPr>
+            </a:p>
+          </p:txBody>
+        </p:sp>
+        <p:sp>
+          <p:nvSpPr>
+            <p:cNvPr id="85" name="Google Shape;85;p15"/>
+            <p:cNvSpPr txBox="1"/>
+            <p:nvPr/>
+          </p:nvSpPr>
+          <p:spPr>
+            <a:xfrm>
+              <a:off x="2063844" y="1107021"/>
+              <a:ext cx="1071900" cy="554100"/>
+            </a:xfrm>
+            <a:prstGeom prst="rect">
+              <a:avLst/>
+            </a:prstGeom>
+            <a:noFill/>
+            <a:ln>
+              <a:noFill/>
+            </a:ln>
+          </p:spPr>
+          <p:txBody>
+            <a:bodyPr anchorCtr="0" anchor="t" bIns="66625" lIns="66625" spcFirstLastPara="1" rIns="66625" wrap="square" tIns="66625">
+              <a:spAutoFit/>
+            </a:bodyPr>
+            <a:lstStyle/>
+            <a:p>
+              <a:pPr indent="0" lvl="0" marL="0" rtl="0" algn="ctr">
+                <a:spcBef>
+                  <a:spcPts val="0"/>
+                </a:spcBef>
+                <a:spcAft>
+                  <a:spcPts val="0"/>
+                </a:spcAft>
+                <a:buNone/>
+              </a:pPr>
+              <a:r>
+                <a:rPr lang="es-419" sz="875">
+                  <a:solidFill>
+                    <a:schemeClr val="dk2"/>
+                  </a:solidFill>
+                </a:rPr>
+                <a:t>MPRA splicing</a:t>
+              </a:r>
+              <a:endParaRPr sz="875">
+                <a:solidFill>
+                  <a:schemeClr val="dk2"/>
+                </a:solidFill>
+              </a:endParaRPr>
+            </a:p>
+          </p:txBody>
+        </p:sp>
+      </p:grpSp>
+      <p:grpSp>
+        <p:nvGrpSpPr>
+          <p:cNvPr id="86" name="Google Shape;86;p15"/>
+          <p:cNvGrpSpPr/>
+          <p:nvPr/>
+        </p:nvGrpSpPr>
+        <p:grpSpPr>
+          <a:xfrm>
+            <a:off x="4013097" y="216164"/>
+            <a:ext cx="2600964" cy="1913895"/>
             <a:chOff x="5506445" y="266008"/>
             <a:chExt cx="3568830" cy="2626092"/>
           </a:xfrm>
         </p:grpSpPr>
         <p:grpSp>
           <p:nvGrpSpPr>
-            <p:cNvPr id="86" name="Google Shape;86;p15"/>
+            <p:cNvPr id="87" name="Google Shape;87;p15"/>
             <p:cNvGrpSpPr/>
             <p:nvPr/>
           </p:nvGrpSpPr>
@@ -7412,7 +7427,7 @@
           </p:grpSpPr>
           <p:pic>
             <p:nvPicPr>
-              <p:cNvPr id="87" name="Google Shape;87;p15" title="gc_bias_bars.jpg"/>
+              <p:cNvPr id="88" name="Google Shape;88;p15" title="gc_bias_bars.jpg"/>
               <p:cNvPicPr preferRelativeResize="0"/>
               <p:nvPr/>
             </p:nvPicPr>
@@ -7440,7 +7455,7 @@
           </p:pic>
           <p:sp>
             <p:nvSpPr>
-              <p:cNvPr id="88" name="Google Shape;88;p15"/>
+              <p:cNvPr id="89" name="Google Shape;89;p15"/>
               <p:cNvSpPr txBox="1"/>
               <p:nvPr/>
             </p:nvSpPr>
@@ -7458,7 +7473,7 @@
               </a:ln>
             </p:spPr>
             <p:txBody>
-              <a:bodyPr anchorCtr="0" anchor="t" bIns="91425" lIns="91425" spcFirstLastPara="1" rIns="91425" wrap="square" tIns="91425">
+              <a:bodyPr anchorCtr="0" anchor="t" bIns="66625" lIns="66625" spcFirstLastPara="1" rIns="66625" wrap="square" tIns="66625">
                 <a:spAutoFit/>
               </a:bodyPr>
               <a:lstStyle/>
@@ -7473,14 +7488,14 @@
                   <a:buNone/>
                 </a:pPr>
                 <a:r>
-                  <a:rPr lang="es-419" sz="900">
+                  <a:rPr lang="es-419" sz="656">
                     <a:solidFill>
                       <a:schemeClr val="dk2"/>
                     </a:solidFill>
                   </a:rPr>
                   <a:t>Distribución uniforme</a:t>
                 </a:r>
-                <a:endParaRPr sz="900">
+                <a:endParaRPr sz="656">
                   <a:solidFill>
                     <a:schemeClr val="dk2"/>
                   </a:solidFill>
@@ -7490,7 +7505,7 @@
           </p:sp>
           <p:sp>
             <p:nvSpPr>
-              <p:cNvPr id="89" name="Google Shape;89;p15"/>
+              <p:cNvPr id="90" name="Google Shape;90;p15"/>
               <p:cNvSpPr txBox="1"/>
               <p:nvPr/>
             </p:nvSpPr>
@@ -7508,7 +7523,7 @@
               </a:ln>
             </p:spPr>
             <p:txBody>
-              <a:bodyPr anchorCtr="0" anchor="t" bIns="91425" lIns="91425" spcFirstLastPara="1" rIns="91425" wrap="square" tIns="91425">
+              <a:bodyPr anchorCtr="0" anchor="t" bIns="66625" lIns="66625" spcFirstLastPara="1" rIns="66625" wrap="square" tIns="66625">
                 <a:spAutoFit/>
               </a:bodyPr>
               <a:lstStyle/>
@@ -7523,14 +7538,14 @@
                   <a:buNone/>
                 </a:pPr>
                 <a:r>
-                  <a:rPr lang="es-419" sz="900">
+                  <a:rPr lang="es-419" sz="656">
                     <a:solidFill>
                       <a:schemeClr val="dk2"/>
                     </a:solidFill>
                   </a:rPr>
                   <a:t>Distribución observada</a:t>
                 </a:r>
-                <a:endParaRPr sz="900">
+                <a:endParaRPr sz="656">
                   <a:solidFill>
                     <a:schemeClr val="dk2"/>
                   </a:solidFill>
@@ -7541,7 +7556,7 @@
         </p:grpSp>
         <p:sp>
           <p:nvSpPr>
-            <p:cNvPr id="90" name="Google Shape;90;p15"/>
+            <p:cNvPr id="91" name="Google Shape;91;p15"/>
             <p:cNvSpPr/>
             <p:nvPr/>
           </p:nvSpPr>
@@ -7556,7 +7571,7 @@
             <a:solidFill>
               <a:srgbClr val="ACDAD6"/>
             </a:solidFill>
-            <a:ln cap="flat" cmpd="sng" w="9525">
+            <a:ln cap="flat" cmpd="sng" w="6950">
               <a:solidFill>
                 <a:schemeClr val="dk2"/>
               </a:solidFill>
@@ -7567,7 +7582,7 @@
             </a:ln>
           </p:spPr>
           <p:txBody>
-            <a:bodyPr anchorCtr="0" anchor="ctr" bIns="91425" lIns="91425" spcFirstLastPara="1" rIns="91425" wrap="square" tIns="91425">
+            <a:bodyPr anchorCtr="0" anchor="ctr" bIns="66625" lIns="66625" spcFirstLastPara="1" rIns="66625" wrap="square" tIns="66625">
               <a:noAutofit/>
             </a:bodyPr>
             <a:lstStyle/>
@@ -7584,13 +7599,13 @@
               <a:r>
                 <a:t/>
               </a:r>
-              <a:endParaRPr/>
+              <a:endParaRPr sz="1020"/>
             </a:p>
           </p:txBody>
         </p:sp>
         <p:sp>
           <p:nvSpPr>
-            <p:cNvPr id="91" name="Google Shape;91;p15"/>
+            <p:cNvPr id="92" name="Google Shape;92;p15"/>
             <p:cNvSpPr/>
             <p:nvPr/>
           </p:nvSpPr>
@@ -7605,7 +7620,7 @@
             <a:solidFill>
               <a:srgbClr val="98C5D5"/>
             </a:solidFill>
-            <a:ln cap="flat" cmpd="sng" w="9525">
+            <a:ln cap="flat" cmpd="sng" w="6950">
               <a:solidFill>
                 <a:schemeClr val="dk2"/>
               </a:solidFill>
@@ -7616,7 +7631,7 @@
             </a:ln>
           </p:spPr>
           <p:txBody>
-            <a:bodyPr anchorCtr="0" anchor="ctr" bIns="91425" lIns="91425" spcFirstLastPara="1" rIns="91425" wrap="square" tIns="91425">
+            <a:bodyPr anchorCtr="0" anchor="ctr" bIns="66625" lIns="66625" spcFirstLastPara="1" rIns="66625" wrap="square" tIns="66625">
               <a:noAutofit/>
             </a:bodyPr>
             <a:lstStyle/>
@@ -7633,28 +7648,203 @@
               <a:r>
                 <a:t/>
               </a:r>
-              <a:endParaRPr/>
+              <a:endParaRPr sz="1020"/>
+            </a:p>
+          </p:txBody>
+        </p:sp>
+      </p:grpSp>
+      <p:grpSp>
+        <p:nvGrpSpPr>
+          <p:cNvPr id="93" name="Google Shape;93;p15"/>
+          <p:cNvGrpSpPr/>
+          <p:nvPr/>
+        </p:nvGrpSpPr>
+        <p:grpSpPr>
+          <a:xfrm>
+            <a:off x="2303549" y="141569"/>
+            <a:ext cx="1687746" cy="2175453"/>
+            <a:chOff x="3160742" y="163655"/>
+            <a:chExt cx="2315787" cy="2984979"/>
+          </a:xfrm>
+        </p:grpSpPr>
+        <p:pic>
+          <p:nvPicPr>
+            <p:cNvPr id="94" name="Google Shape;94;p15" title="gc_bias_violin.jpg"/>
+            <p:cNvPicPr preferRelativeResize="0"/>
+            <p:nvPr/>
+          </p:nvPicPr>
+          <p:blipFill rotWithShape="1">
+            <a:blip r:embed="rId5">
+              <a:alphaModFix/>
+            </a:blip>
+            <a:srcRect b="11708" l="0" r="0" t="0"/>
+            <a:stretch/>
+          </p:blipFill>
+          <p:spPr>
+            <a:xfrm>
+              <a:off x="3438900" y="163655"/>
+              <a:ext cx="1858876" cy="2461777"/>
+            </a:xfrm>
+            <a:prstGeom prst="rect">
+              <a:avLst/>
+            </a:prstGeom>
+            <a:noFill/>
+            <a:ln>
+              <a:noFill/>
+            </a:ln>
+          </p:spPr>
+        </p:pic>
+        <p:sp>
+          <p:nvSpPr>
+            <p:cNvPr id="95" name="Google Shape;95;p15"/>
+            <p:cNvSpPr txBox="1"/>
+            <p:nvPr/>
+          </p:nvSpPr>
+          <p:spPr>
+            <a:xfrm>
+              <a:off x="3160742" y="2609422"/>
+              <a:ext cx="2073000" cy="523200"/>
+            </a:xfrm>
+            <a:prstGeom prst="rect">
+              <a:avLst/>
+            </a:prstGeom>
+            <a:noFill/>
+            <a:ln>
+              <a:noFill/>
+            </a:ln>
+          </p:spPr>
+          <p:txBody>
+            <a:bodyPr anchorCtr="0" anchor="t" bIns="66625" lIns="66625" spcFirstLastPara="1" rIns="66625" wrap="square" tIns="66625">
+              <a:spAutoFit/>
+            </a:bodyPr>
+            <a:lstStyle/>
+            <a:p>
+              <a:pPr indent="0" lvl="0" marL="0" rtl="0" algn="ctr">
+                <a:spcBef>
+                  <a:spcPts val="0"/>
+                </a:spcBef>
+                <a:spcAft>
+                  <a:spcPts val="0"/>
+                </a:spcAft>
+                <a:buNone/>
+              </a:pPr>
+              <a:r>
+                <a:rPr lang="es-419" sz="802">
+                  <a:solidFill>
+                    <a:schemeClr val="dk2"/>
+                  </a:solidFill>
+                </a:rPr>
+                <a:t>Promotores </a:t>
+              </a:r>
+              <a:endParaRPr sz="802">
+                <a:solidFill>
+                  <a:schemeClr val="dk2"/>
+                </a:solidFill>
+              </a:endParaRPr>
+            </a:p>
+            <a:p>
+              <a:pPr indent="0" lvl="0" marL="0" rtl="0" algn="ctr">
+                <a:spcBef>
+                  <a:spcPts val="0"/>
+                </a:spcBef>
+                <a:spcAft>
+                  <a:spcPts val="0"/>
+                </a:spcAft>
+                <a:buNone/>
+              </a:pPr>
+              <a:r>
+                <a:rPr lang="es-419" sz="802">
+                  <a:solidFill>
+                    <a:schemeClr val="dk2"/>
+                  </a:solidFill>
+                </a:rPr>
+                <a:t>no detectado</a:t>
+              </a:r>
+              <a:endParaRPr sz="802">
+                <a:solidFill>
+                  <a:schemeClr val="dk2"/>
+                </a:solidFill>
+              </a:endParaRPr>
+            </a:p>
+          </p:txBody>
+        </p:sp>
+        <p:sp>
+          <p:nvSpPr>
+            <p:cNvPr id="96" name="Google Shape;96;p15"/>
+            <p:cNvSpPr txBox="1"/>
+            <p:nvPr/>
+          </p:nvSpPr>
+          <p:spPr>
+            <a:xfrm>
+              <a:off x="4548029" y="2625434"/>
+              <a:ext cx="928500" cy="523200"/>
+            </a:xfrm>
+            <a:prstGeom prst="rect">
+              <a:avLst/>
+            </a:prstGeom>
+            <a:noFill/>
+            <a:ln>
+              <a:noFill/>
+            </a:ln>
+          </p:spPr>
+          <p:txBody>
+            <a:bodyPr anchorCtr="0" anchor="t" bIns="66625" lIns="66625" spcFirstLastPara="1" rIns="66625" wrap="square" tIns="66625">
+              <a:spAutoFit/>
+            </a:bodyPr>
+            <a:lstStyle/>
+            <a:p>
+              <a:pPr indent="0" lvl="0" marL="0" rtl="0" algn="ctr">
+                <a:spcBef>
+                  <a:spcPts val="0"/>
+                </a:spcBef>
+                <a:spcAft>
+                  <a:spcPts val="0"/>
+                </a:spcAft>
+                <a:buNone/>
+              </a:pPr>
+              <a:r>
+                <a:rPr lang="es-419" sz="802">
+                  <a:solidFill>
+                    <a:schemeClr val="dk2"/>
+                  </a:solidFill>
+                </a:rPr>
+                <a:t>Promotores d</a:t>
+              </a:r>
+              <a:r>
+                <a:rPr lang="es-419" sz="802">
+                  <a:solidFill>
+                    <a:schemeClr val="dk2"/>
+                  </a:solidFill>
+                </a:rPr>
+                <a:t>etectados</a:t>
+              </a:r>
+              <a:endParaRPr sz="802">
+                <a:solidFill>
+                  <a:schemeClr val="dk2"/>
+                </a:solidFill>
+              </a:endParaRPr>
             </a:p>
           </p:txBody>
         </p:sp>
       </p:grpSp>
       <p:pic>
         <p:nvPicPr>
-          <p:cNvPr id="92" name="Google Shape;92;p15" title="gc_bias_violin.jpg"/>
+          <p:cNvPr id="97" name="Google Shape;97;p15" title="g4_retencion_por_gc.jpg"/>
           <p:cNvPicPr preferRelativeResize="0"/>
           <p:nvPr/>
         </p:nvPicPr>
-        <p:blipFill rotWithShape="1">
-          <a:blip r:embed="rId5">
+        <p:blipFill>
+          <a:blip r:embed="rId6">
             <a:alphaModFix/>
           </a:blip>
-          <a:srcRect b="11708" l="0" r="0" t="0"/>
-          <a:stretch/>
+          <a:stretch>
+            <a:fillRect/>
+          </a:stretch>
         </p:blipFill>
         <p:spPr>
           <a:xfrm>
-            <a:off x="3438900" y="163655"/>
-            <a:ext cx="1858876" cy="2461777"/>
+            <a:off x="4655476" y="2445601"/>
+            <a:ext cx="4137446" cy="2545499"/>
           </a:xfrm>
           <a:prstGeom prst="rect">
             <a:avLst/>
@@ -7667,14 +7857,14 @@
       </p:pic>
       <p:sp>
         <p:nvSpPr>
-          <p:cNvPr id="93" name="Google Shape;93;p15"/>
+          <p:cNvPr id="98" name="Google Shape;98;p15"/>
           <p:cNvSpPr txBox="1"/>
           <p:nvPr/>
         </p:nvSpPr>
         <p:spPr>
           <a:xfrm>
-            <a:off x="3160742" y="2609422"/>
-            <a:ext cx="2073000" cy="523200"/>
+            <a:off x="1366125" y="4014950"/>
+            <a:ext cx="3000000" cy="1046700"/>
           </a:xfrm>
           <a:prstGeom prst="rect">
             <a:avLst/>
@@ -7690,7 +7880,7 @@
           </a:bodyPr>
           <a:lstStyle/>
           <a:p>
-            <a:pPr indent="0" lvl="0" marL="0" rtl="0" algn="ctr">
+            <a:pPr indent="0" lvl="0" marL="0" rtl="0" algn="l">
               <a:spcBef>
                 <a:spcPts val="0"/>
               </a:spcBef>
@@ -7700,100 +7890,78 @@
               <a:buNone/>
             </a:pPr>
             <a:r>
-              <a:rPr lang="es-419" sz="1100">
-                <a:solidFill>
-                  <a:schemeClr val="dk2"/>
+              <a:rPr lang="es-419" sz="700">
+                <a:solidFill>
+                  <a:schemeClr val="dk1"/>
                 </a:solidFill>
               </a:rPr>
-              <a:t>Promotores </a:t>
-            </a:r>
-            <a:endParaRPr sz="1100">
-              <a:solidFill>
-                <a:schemeClr val="dk2"/>
-              </a:solidFill>
-            </a:endParaRPr>
-          </a:p>
-          <a:p>
-            <a:pPr indent="0" lvl="0" marL="0" rtl="0" algn="ctr">
-              <a:spcBef>
-                <a:spcPts val="0"/>
-              </a:spcBef>
-              <a:spcAft>
-                <a:spcPts val="0"/>
-              </a:spcAft>
-              <a:buNone/>
-            </a:pPr>
-            <a:r>
-              <a:rPr lang="es-419" sz="1100">
-                <a:solidFill>
-                  <a:schemeClr val="dk2"/>
-                </a:solidFill>
-              </a:rPr>
-              <a:t>no detectado</a:t>
-            </a:r>
-            <a:endParaRPr sz="1100">
-              <a:solidFill>
-                <a:schemeClr val="dk2"/>
-              </a:solidFill>
-            </a:endParaRPr>
-          </a:p>
-        </p:txBody>
-      </p:sp>
-      <p:sp>
-        <p:nvSpPr>
-          <p:cNvPr id="94" name="Google Shape;94;p15"/>
-          <p:cNvSpPr txBox="1"/>
-          <p:nvPr/>
-        </p:nvSpPr>
-        <p:spPr>
-          <a:xfrm>
-            <a:off x="4548029" y="2625434"/>
-            <a:ext cx="928500" cy="523200"/>
-          </a:xfrm>
-          <a:prstGeom prst="rect">
-            <a:avLst/>
-          </a:prstGeom>
-          <a:noFill/>
-          <a:ln>
-            <a:noFill/>
-          </a:ln>
-        </p:spPr>
-        <p:txBody>
-          <a:bodyPr anchorCtr="0" anchor="t" bIns="91425" lIns="91425" spcFirstLastPara="1" rIns="91425" wrap="square" tIns="91425">
-            <a:spAutoFit/>
-          </a:bodyPr>
-          <a:lstStyle/>
-          <a:p>
-            <a:pPr indent="0" lvl="0" marL="0" rtl="0" algn="ctr">
-              <a:spcBef>
-                <a:spcPts val="0"/>
-              </a:spcBef>
-              <a:spcAft>
-                <a:spcPts val="0"/>
-              </a:spcAft>
-              <a:buNone/>
-            </a:pPr>
-            <a:r>
-              <a:rPr lang="es-419" sz="1100">
-                <a:solidFill>
-                  <a:schemeClr val="dk2"/>
-                </a:solidFill>
-              </a:rPr>
-              <a:t>Promotores d</a:t>
+              <a:t>(D) Porcentaje de los promotores de la </a:t>
             </a:r>
             <a:r>
-              <a:rPr lang="es-419" sz="1100">
-                <a:solidFill>
-                  <a:schemeClr val="dk2"/>
+              <a:rPr i="1" lang="es-419" sz="700">
+                <a:solidFill>
+                  <a:schemeClr val="dk1"/>
                 </a:solidFill>
               </a:rPr>
-              <a:t>etectados</a:t>
+              <a:t>library</a:t>
             </a:r>
-            <a:endParaRPr sz="1100">
-              <a:solidFill>
-                <a:schemeClr val="dk2"/>
-              </a:solidFill>
-            </a:endParaRPr>
+            <a:r>
+              <a:rPr lang="es-419" sz="700">
+                <a:solidFill>
+                  <a:schemeClr val="dk1"/>
+                </a:solidFill>
+              </a:rPr>
+              <a:t> que se recupera en cada etapa del ensayo (</a:t>
+            </a:r>
+            <a:r>
+              <a:rPr i="1" lang="es-419" sz="700">
+                <a:solidFill>
+                  <a:schemeClr val="dk1"/>
+                </a:solidFill>
+              </a:rPr>
+              <a:t>pool</a:t>
+            </a:r>
+            <a:r>
+              <a:rPr lang="es-419" sz="700">
+                <a:solidFill>
+                  <a:schemeClr val="dk1"/>
+                </a:solidFill>
+              </a:rPr>
+              <a:t> previo al </a:t>
+            </a:r>
+            <a:r>
+              <a:rPr i="1" lang="es-419" sz="700">
+                <a:solidFill>
+                  <a:schemeClr val="dk1"/>
+                </a:solidFill>
+              </a:rPr>
+              <a:t>sorting </a:t>
+            </a:r>
+            <a:r>
+              <a:rPr lang="es-419" sz="700">
+                <a:solidFill>
+                  <a:schemeClr val="dk1"/>
+                </a:solidFill>
+              </a:rPr>
+              <a:t>en el MPRA de splicing, detección en el </a:t>
+            </a:r>
+            <a:r>
+              <a:rPr i="1" lang="es-419" sz="700">
+                <a:solidFill>
+                  <a:schemeClr val="dk1"/>
+                </a:solidFill>
+              </a:rPr>
+              <a:t>sorting</a:t>
+            </a:r>
+            <a:r>
+              <a:rPr lang="es-419" sz="700">
+                <a:solidFill>
+                  <a:schemeClr val="dk1"/>
+                </a:solidFill>
+              </a:rPr>
+              <a:t> y alta confianza) según el contenido de G+C del fragmento (intervalos de 0,05), para promotores sin G4 (gris), con G4 solo en la hebra codificante (rojo) o solo en la hebra molde (azul). Línea continua: réplica 1; línea discontinua: réplica 2. El tamaño del punto indica el número de promotores en el intervalo; se muestran los intervalos con al menos 20 promotores de cada grupo. </a:t>
+            </a:r>
+            <a:endParaRPr sz="1000"/>
           </a:p>
         </p:txBody>
       </p:sp>
@@ -7810,7 +7978,7 @@
   <p:cSld>
     <p:spTree>
       <p:nvGrpSpPr>
-        <p:cNvPr id="98" name="Shape 98"/>
+        <p:cNvPr id="102" name="Shape 102"/>
         <p:cNvGrpSpPr/>
         <p:nvPr/>
       </p:nvGrpSpPr>
@@ -7824,7 +7992,7 @@
       </p:grpSpPr>
       <p:pic>
         <p:nvPicPr>
-          <p:cNvPr id="99" name="Google Shape;99;p16"/>
+          <p:cNvPr id="103" name="Google Shape;103;p16"/>
           <p:cNvPicPr preferRelativeResize="0"/>
           <p:nvPr/>
         </p:nvPicPr>
@@ -7852,7 +8020,7 @@
       </p:pic>
       <p:sp>
         <p:nvSpPr>
-          <p:cNvPr id="100" name="Google Shape;100;p16"/>
+          <p:cNvPr id="104" name="Google Shape;104;p16"/>
           <p:cNvSpPr txBox="1"/>
           <p:nvPr/>
         </p:nvSpPr>
@@ -8004,7 +8172,7 @@
   <p:cSld>
     <p:spTree>
       <p:nvGrpSpPr>
-        <p:cNvPr id="104" name="Shape 104"/>
+        <p:cNvPr id="108" name="Shape 108"/>
         <p:cNvGrpSpPr/>
         <p:nvPr/>
       </p:nvGrpSpPr>
@@ -8018,7 +8186,7 @@
       </p:grpSpPr>
       <p:sp>
         <p:nvSpPr>
-          <p:cNvPr id="105" name="Google Shape;105;p17"/>
+          <p:cNvPr id="109" name="Google Shape;109;p17"/>
           <p:cNvSpPr txBox="1"/>
           <p:nvPr/>
         </p:nvSpPr>
@@ -8124,7 +8292,7 @@
       </p:sp>
       <p:pic>
         <p:nvPicPr>
-          <p:cNvPr id="106" name="Google Shape;106;p17" title="histograma_gates_KIAA0753.jpg"/>
+          <p:cNvPr id="110" name="Google Shape;110;p17" title="histograma_gates_KIAA0753.jpg"/>
           <p:cNvPicPr preferRelativeResize="0"/>
           <p:nvPr/>
         </p:nvPicPr>
@@ -8163,7 +8331,7 @@
   <p:cSld>
     <p:spTree>
       <p:nvGrpSpPr>
-        <p:cNvPr id="110" name="Shape 110"/>
+        <p:cNvPr id="114" name="Shape 114"/>
         <p:cNvGrpSpPr/>
         <p:nvPr/>
       </p:nvGrpSpPr>
@@ -8177,7 +8345,7 @@
       </p:grpSpPr>
       <p:pic>
         <p:nvPicPr>
-          <p:cNvPr id="111" name="Google Shape;111;p18" title="extra_densidad_individual.jpg"/>
+          <p:cNvPr id="115" name="Google Shape;115;p18" title="extra_densidad_individual.jpg"/>
           <p:cNvPicPr preferRelativeResize="0"/>
           <p:nvPr/>
         </p:nvPicPr>
@@ -8205,7 +8373,7 @@
       </p:pic>
       <p:sp>
         <p:nvSpPr>
-          <p:cNvPr id="112" name="Google Shape;112;p18"/>
+          <p:cNvPr id="116" name="Google Shape;116;p18"/>
           <p:cNvSpPr txBox="1"/>
           <p:nvPr/>
         </p:nvSpPr>
@@ -8326,7 +8494,7 @@
   <p:cSld>
     <p:spTree>
       <p:nvGrpSpPr>
-        <p:cNvPr id="116" name="Shape 116"/>
+        <p:cNvPr id="120" name="Shape 120"/>
         <p:cNvGrpSpPr/>
         <p:nvPr/>
       </p:nvGrpSpPr>
@@ -8340,7 +8508,7 @@
       </p:grpSpPr>
       <p:pic>
         <p:nvPicPr>
-          <p:cNvPr id="117" name="Google Shape;117;p19"/>
+          <p:cNvPr id="121" name="Google Shape;121;p19"/>
           <p:cNvPicPr preferRelativeResize="0"/>
           <p:nvPr/>
         </p:nvPicPr>
@@ -8368,7 +8536,7 @@
       </p:pic>
       <p:pic>
         <p:nvPicPr>
-          <p:cNvPr id="118" name="Google Shape;118;p19"/>
+          <p:cNvPr id="122" name="Google Shape;122;p19"/>
           <p:cNvPicPr preferRelativeResize="0"/>
           <p:nvPr/>
         </p:nvPicPr>
@@ -8396,7 +8564,7 @@
       </p:pic>
       <p:sp>
         <p:nvSpPr>
-          <p:cNvPr id="119" name="Google Shape;119;p19"/>
+          <p:cNvPr id="123" name="Google Shape;123;p19"/>
           <p:cNvSpPr txBox="1"/>
           <p:nvPr/>
         </p:nvSpPr>
@@ -8502,7 +8670,7 @@
       </p:sp>
       <p:pic>
         <p:nvPicPr>
-          <p:cNvPr id="120" name="Google Shape;120;p19" title="panel_b_histograma_gates_ejemplo.jpg"/>
+          <p:cNvPr id="124" name="Google Shape;124;p19" title="panel_b_histograma_gates_ejemplo.jpg"/>
           <p:cNvPicPr preferRelativeResize="0"/>
           <p:nvPr/>
         </p:nvPicPr>
@@ -8541,7 +8709,7 @@
   <p:cSld>
     <p:spTree>
       <p:nvGrpSpPr>
-        <p:cNvPr id="124" name="Shape 124"/>
+        <p:cNvPr id="128" name="Shape 128"/>
         <p:cNvGrpSpPr/>
         <p:nvPr/>
       </p:nvGrpSpPr>
@@ -8555,7 +8723,7 @@
       </p:grpSpPr>
       <p:grpSp>
         <p:nvGrpSpPr>
-          <p:cNvPr id="125" name="Google Shape;125;p20"/>
+          <p:cNvPr id="129" name="Google Shape;129;p20"/>
           <p:cNvGrpSpPr/>
           <p:nvPr/>
         </p:nvGrpSpPr>
@@ -8569,7 +8737,7 @@
         </p:grpSpPr>
         <p:pic>
           <p:nvPicPr>
-            <p:cNvPr id="126" name="Google Shape;126;p20"/>
+            <p:cNvPr id="130" name="Google Shape;130;p20"/>
             <p:cNvPicPr preferRelativeResize="0"/>
             <p:nvPr/>
           </p:nvPicPr>
@@ -8596,7 +8764,7 @@
         </p:pic>
         <p:sp>
           <p:nvSpPr>
-            <p:cNvPr id="127" name="Google Shape;127;p20"/>
+            <p:cNvPr id="131" name="Google Shape;131;p20"/>
             <p:cNvSpPr txBox="1"/>
             <p:nvPr/>
           </p:nvSpPr>
@@ -8648,7 +8816,7 @@
         </p:sp>
         <p:sp>
           <p:nvSpPr>
-            <p:cNvPr id="128" name="Google Shape;128;p20"/>
+            <p:cNvPr id="132" name="Google Shape;132;p20"/>
             <p:cNvSpPr txBox="1"/>
             <p:nvPr/>
           </p:nvSpPr>
@@ -8698,7 +8866,7 @@
         </p:sp>
         <p:sp>
           <p:nvSpPr>
-            <p:cNvPr id="129" name="Google Shape;129;p20"/>
+            <p:cNvPr id="133" name="Google Shape;133;p20"/>
             <p:cNvSpPr txBox="1"/>
             <p:nvPr/>
           </p:nvSpPr>
@@ -8748,7 +8916,7 @@
         </p:sp>
         <p:sp>
           <p:nvSpPr>
-            <p:cNvPr id="130" name="Google Shape;130;p20"/>
+            <p:cNvPr id="134" name="Google Shape;134;p20"/>
             <p:cNvSpPr txBox="1"/>
             <p:nvPr/>
           </p:nvSpPr>
@@ -8798,7 +8966,7 @@
         </p:sp>
         <p:sp>
           <p:nvSpPr>
-            <p:cNvPr id="131" name="Google Shape;131;p20"/>
+            <p:cNvPr id="135" name="Google Shape;135;p20"/>
             <p:cNvSpPr txBox="1"/>
             <p:nvPr/>
           </p:nvSpPr>
@@ -8850,7 +9018,7 @@
         </p:sp>
         <p:sp>
           <p:nvSpPr>
-            <p:cNvPr id="132" name="Google Shape;132;p20"/>
+            <p:cNvPr id="136" name="Google Shape;136;p20"/>
             <p:cNvSpPr txBox="1"/>
             <p:nvPr/>
           </p:nvSpPr>
@@ -8902,7 +9070,7 @@
         </p:sp>
         <p:sp>
           <p:nvSpPr>
-            <p:cNvPr id="133" name="Google Shape;133;p20"/>
+            <p:cNvPr id="137" name="Google Shape;137;p20"/>
             <p:cNvSpPr txBox="1"/>
             <p:nvPr/>
           </p:nvSpPr>
@@ -8960,7 +9128,7 @@
       </p:grpSp>
       <p:sp>
         <p:nvSpPr>
-          <p:cNvPr id="134" name="Google Shape;134;p20"/>
+          <p:cNvPr id="138" name="Google Shape;138;p20"/>
           <p:cNvSpPr txBox="1"/>
           <p:nvPr/>
         </p:nvSpPr>
@@ -9137,7 +9305,7 @@
       </p:sp>
       <p:grpSp>
         <p:nvGrpSpPr>
-          <p:cNvPr id="135" name="Google Shape;135;p20"/>
+          <p:cNvPr id="139" name="Google Shape;139;p20"/>
           <p:cNvGrpSpPr/>
           <p:nvPr/>
         </p:nvGrpSpPr>
@@ -9151,7 +9319,7 @@
         </p:grpSpPr>
         <p:pic>
           <p:nvPicPr>
-            <p:cNvPr id="136" name="Google Shape;136;p20" title="mean_replicates_prefilter.jpg"/>
+            <p:cNvPr id="140" name="Google Shape;140;p20" title="mean_replicates_prefilter.jpg"/>
             <p:cNvPicPr preferRelativeResize="0"/>
             <p:nvPr/>
           </p:nvPicPr>
@@ -9178,7 +9346,7 @@
         </p:pic>
         <p:pic>
           <p:nvPicPr>
-            <p:cNvPr id="137" name="Google Shape;137;p20" title="mean_replicates_prefilter.jpg"/>
+            <p:cNvPr id="141" name="Google Shape;141;p20" title="mean_replicates_prefilter.jpg"/>
             <p:cNvPicPr preferRelativeResize="0"/>
             <p:nvPr/>
           </p:nvPicPr>
@@ -9205,7 +9373,7 @@
         </p:pic>
         <p:pic>
           <p:nvPicPr>
-            <p:cNvPr id="138" name="Google Shape;138;p20" title="mean_replicates_prefilter.jpg"/>
+            <p:cNvPr id="142" name="Google Shape;142;p20" title="mean_replicates_prefilter.jpg"/>
             <p:cNvPicPr preferRelativeResize="0"/>
             <p:nvPr/>
           </p:nvPicPr>
@@ -9233,7 +9401,7 @@
       </p:grpSp>
       <p:pic>
         <p:nvPicPr>
-          <p:cNvPr id="139" name="Google Shape;139;p20" title="mean_replicates_postfilter.jpg"/>
+          <p:cNvPr id="143" name="Google Shape;143;p20" title="mean_replicates_postfilter.jpg"/>
           <p:cNvPicPr preferRelativeResize="0"/>
           <p:nvPr/>
         </p:nvPicPr>
@@ -9261,7 +9429,7 @@
       </p:pic>
       <p:pic>
         <p:nvPicPr>
-          <p:cNvPr id="140" name="Google Shape;140;p20" title="panel_d_var_replicates.jpg"/>
+          <p:cNvPr id="144" name="Google Shape;144;p20" title="panel_d_var_replicates.jpg"/>
           <p:cNvPicPr preferRelativeResize="0"/>
           <p:nvPr/>
         </p:nvPicPr>

</xml_diff>

<commit_message>
docs: resync figure numbering from Drive decks (2026-10-21)
Changed decks: Fig MyM, Fig R1, Fig R2, Fig R3.
No slug number changes (no folders renamed).

mapping_figuras.csv:
- metrica_ruido, ruido_cgi, ruido_composicion: leyenda_lista no -> si
  (legends now present in Fig R3 deck)
- remap_tf_noise_gsea -> revisar: its slide in Fig R3 is an empty placeholder
- chipatlas_histonas -> revisar: Fig R3 now has only 6 slides, none with its images

Co-Authored-By: Claude Opus 5.5 <noreply@anthropic.com>
</commit_message>
<xml_diff>
--- a/docs/Fig R1.pptx
+++ b/docs/Fig R1.pptx
@@ -905,7 +905,7 @@
   <p:cSld>
     <p:spTree>
       <p:nvGrpSpPr>
-        <p:cNvPr id="72" name="Shape 72"/>
+        <p:cNvPr id="70" name="Shape 70"/>
         <p:cNvGrpSpPr/>
         <p:nvPr/>
       </p:nvGrpSpPr>
@@ -919,7 +919,7 @@
       </p:grpSpPr>
       <p:sp>
         <p:nvSpPr>
-          <p:cNvPr id="73" name="Google Shape;73;g3d678bf7346_0_8:notes"/>
+          <p:cNvPr id="71" name="Google Shape;71;g3d678bf7346_0_8:notes"/>
           <p:cNvSpPr/>
           <p:nvPr>
             <p:ph idx="2" type="sldImg"/>
@@ -954,7 +954,7 @@
       </p:sp>
       <p:sp>
         <p:nvSpPr>
-          <p:cNvPr id="74" name="Google Shape;74;g3d678bf7346_0_8:notes"/>
+          <p:cNvPr id="72" name="Google Shape;72;g3d678bf7346_0_8:notes"/>
           <p:cNvSpPr txBox="1"/>
           <p:nvPr>
             <p:ph idx="1" type="body"/>
@@ -1004,7 +1004,7 @@
   <p:cSld>
     <p:spTree>
       <p:nvGrpSpPr>
-        <p:cNvPr id="99" name="Shape 99"/>
+        <p:cNvPr id="97" name="Shape 97"/>
         <p:cNvGrpSpPr/>
         <p:nvPr/>
       </p:nvGrpSpPr>
@@ -1018,7 +1018,7 @@
       </p:grpSpPr>
       <p:sp>
         <p:nvSpPr>
-          <p:cNvPr id="100" name="Google Shape;100;g396169342f1_0_0:notes"/>
+          <p:cNvPr id="98" name="Google Shape;98;g396169342f1_0_0:notes"/>
           <p:cNvSpPr/>
           <p:nvPr>
             <p:ph idx="2" type="sldImg"/>
@@ -1053,7 +1053,7 @@
       </p:sp>
       <p:sp>
         <p:nvSpPr>
-          <p:cNvPr id="101" name="Google Shape;101;g396169342f1_0_0:notes"/>
+          <p:cNvPr id="99" name="Google Shape;99;g396169342f1_0_0:notes"/>
           <p:cNvSpPr txBox="1"/>
           <p:nvPr>
             <p:ph idx="1" type="body"/>
@@ -1103,7 +1103,7 @@
   <p:cSld>
     <p:spTree>
       <p:nvGrpSpPr>
-        <p:cNvPr id="105" name="Shape 105"/>
+        <p:cNvPr id="103" name="Shape 103"/>
         <p:cNvGrpSpPr/>
         <p:nvPr/>
       </p:nvGrpSpPr>
@@ -1117,7 +1117,7 @@
       </p:grpSpPr>
       <p:sp>
         <p:nvSpPr>
-          <p:cNvPr id="106" name="Google Shape;106;g3f5e045cd8f_0_8:notes"/>
+          <p:cNvPr id="104" name="Google Shape;104;g3f5e045cd8f_0_8:notes"/>
           <p:cNvSpPr/>
           <p:nvPr>
             <p:ph idx="2" type="sldImg"/>
@@ -1152,7 +1152,7 @@
       </p:sp>
       <p:sp>
         <p:nvSpPr>
-          <p:cNvPr id="107" name="Google Shape;107;g3f5e045cd8f_0_8:notes"/>
+          <p:cNvPr id="105" name="Google Shape;105;g3f5e045cd8f_0_8:notes"/>
           <p:cNvSpPr txBox="1"/>
           <p:nvPr>
             <p:ph idx="1" type="body"/>
@@ -1202,7 +1202,7 @@
   <p:cSld>
     <p:spTree>
       <p:nvGrpSpPr>
-        <p:cNvPr id="111" name="Shape 111"/>
+        <p:cNvPr id="109" name="Shape 109"/>
         <p:cNvGrpSpPr/>
         <p:nvPr/>
       </p:nvGrpSpPr>
@@ -1216,7 +1216,7 @@
       </p:grpSpPr>
       <p:sp>
         <p:nvSpPr>
-          <p:cNvPr id="112" name="Google Shape;112;g3f5e045cd8f_0_2:notes"/>
+          <p:cNvPr id="110" name="Google Shape;110;g3f5e045cd8f_0_2:notes"/>
           <p:cNvSpPr/>
           <p:nvPr>
             <p:ph idx="2" type="sldImg"/>
@@ -1251,7 +1251,7 @@
       </p:sp>
       <p:sp>
         <p:nvSpPr>
-          <p:cNvPr id="113" name="Google Shape;113;g3f5e045cd8f_0_2:notes"/>
+          <p:cNvPr id="111" name="Google Shape;111;g3f5e045cd8f_0_2:notes"/>
           <p:cNvSpPr txBox="1"/>
           <p:nvPr>
             <p:ph idx="1" type="body"/>
@@ -1301,7 +1301,7 @@
   <p:cSld>
     <p:spTree>
       <p:nvGrpSpPr>
-        <p:cNvPr id="117" name="Shape 117"/>
+        <p:cNvPr id="115" name="Shape 115"/>
         <p:cNvGrpSpPr/>
         <p:nvPr/>
       </p:nvGrpSpPr>
@@ -1315,7 +1315,7 @@
       </p:grpSpPr>
       <p:sp>
         <p:nvSpPr>
-          <p:cNvPr id="118" name="Google Shape;118;g3d678bf7346_0_23:notes"/>
+          <p:cNvPr id="116" name="Google Shape;116;g3d678bf7346_0_23:notes"/>
           <p:cNvSpPr/>
           <p:nvPr>
             <p:ph idx="2" type="sldImg"/>
@@ -1350,7 +1350,7 @@
       </p:sp>
       <p:sp>
         <p:nvSpPr>
-          <p:cNvPr id="119" name="Google Shape;119;g3d678bf7346_0_23:notes"/>
+          <p:cNvPr id="117" name="Google Shape;117;g3d678bf7346_0_23:notes"/>
           <p:cNvSpPr txBox="1"/>
           <p:nvPr>
             <p:ph idx="1" type="body"/>
@@ -1400,7 +1400,7 @@
   <p:cSld>
     <p:spTree>
       <p:nvGrpSpPr>
-        <p:cNvPr id="125" name="Shape 125"/>
+        <p:cNvPr id="123" name="Shape 123"/>
         <p:cNvGrpSpPr/>
         <p:nvPr/>
       </p:nvGrpSpPr>
@@ -1414,7 +1414,7 @@
       </p:grpSpPr>
       <p:sp>
         <p:nvSpPr>
-          <p:cNvPr id="126" name="Google Shape;126;g3d678bf7346_0_17:notes"/>
+          <p:cNvPr id="124" name="Google Shape;124;g3d678bf7346_0_17:notes"/>
           <p:cNvSpPr/>
           <p:nvPr>
             <p:ph idx="2" type="sldImg"/>
@@ -1449,7 +1449,7 @@
       </p:sp>
       <p:sp>
         <p:nvSpPr>
-          <p:cNvPr id="127" name="Google Shape;127;g3d678bf7346_0_17:notes"/>
+          <p:cNvPr id="125" name="Google Shape;125;g3d678bf7346_0_17:notes"/>
           <p:cNvSpPr txBox="1"/>
           <p:nvPr>
             <p:ph idx="1" type="body"/>
@@ -6298,87 +6298,9 @@
           <a:chExt cx="0" cy="0"/>
         </a:xfrm>
       </p:grpSpPr>
-      <p:pic>
-        <p:nvPicPr>
-          <p:cNvPr id="60" name="Google Shape;60;p14" title="n_per_rep.jpg"/>
-          <p:cNvPicPr preferRelativeResize="0"/>
-          <p:nvPr/>
-        </p:nvPicPr>
-        <p:blipFill>
-          <a:blip r:embed="rId3">
-            <a:alphaModFix/>
-          </a:blip>
-          <a:stretch>
-            <a:fillRect/>
-          </a:stretch>
-        </p:blipFill>
-        <p:spPr>
-          <a:xfrm>
-            <a:off x="5728773" y="2660399"/>
-            <a:ext cx="2973952" cy="2230476"/>
-          </a:xfrm>
-          <a:prstGeom prst="rect">
-            <a:avLst/>
-          </a:prstGeom>
-          <a:noFill/>
-          <a:ln>
-            <a:noFill/>
-          </a:ln>
-        </p:spPr>
-      </p:pic>
       <p:sp>
         <p:nvSpPr>
-          <p:cNvPr id="61" name="Google Shape;61;p14"/>
-          <p:cNvSpPr txBox="1"/>
-          <p:nvPr/>
-        </p:nvSpPr>
-        <p:spPr>
-          <a:xfrm>
-            <a:off x="3087175" y="4033700"/>
-            <a:ext cx="3532200" cy="461700"/>
-          </a:xfrm>
-          <a:prstGeom prst="rect">
-            <a:avLst/>
-          </a:prstGeom>
-          <a:noFill/>
-          <a:ln>
-            <a:noFill/>
-          </a:ln>
-        </p:spPr>
-        <p:txBody>
-          <a:bodyPr anchorCtr="0" anchor="t" bIns="91425" lIns="91425" spcFirstLastPara="1" rIns="91425" wrap="square" tIns="91425">
-            <a:spAutoFit/>
-          </a:bodyPr>
-          <a:lstStyle/>
-          <a:p>
-            <a:pPr indent="0" lvl="0" marL="0" rtl="0" algn="l">
-              <a:spcBef>
-                <a:spcPts val="0"/>
-              </a:spcBef>
-              <a:spcAft>
-                <a:spcPts val="0"/>
-              </a:spcAft>
-              <a:buNone/>
-            </a:pPr>
-            <a:r>
-              <a:rPr lang="es-419" sz="1800">
-                <a:solidFill>
-                  <a:schemeClr val="dk2"/>
-                </a:solidFill>
-              </a:rPr>
-              <a:t>opcion B de grafico</a:t>
-            </a:r>
-            <a:endParaRPr sz="1800">
-              <a:solidFill>
-                <a:schemeClr val="dk2"/>
-              </a:solidFill>
-            </a:endParaRPr>
-          </a:p>
-        </p:txBody>
-      </p:sp>
-      <p:sp>
-        <p:nvSpPr>
-          <p:cNvPr id="62" name="Google Shape;62;p14"/>
+          <p:cNvPr id="60" name="Google Shape;60;p14"/>
           <p:cNvSpPr txBox="1"/>
           <p:nvPr/>
         </p:nvSpPr>
@@ -6484,7 +6406,7 @@
       </p:sp>
       <p:grpSp>
         <p:nvGrpSpPr>
-          <p:cNvPr id="63" name="Google Shape;63;p14"/>
+          <p:cNvPr id="61" name="Google Shape;61;p14"/>
           <p:cNvGrpSpPr/>
           <p:nvPr/>
         </p:nvGrpSpPr>
@@ -6498,12 +6420,12 @@
         </p:grpSpPr>
         <p:pic>
           <p:nvPicPr>
-            <p:cNvPr id="64" name="Google Shape;64;p14"/>
+            <p:cNvPr id="62" name="Google Shape;62;p14"/>
             <p:cNvPicPr preferRelativeResize="0"/>
             <p:nvPr/>
           </p:nvPicPr>
           <p:blipFill rotWithShape="1">
-            <a:blip r:embed="rId4">
+            <a:blip r:embed="rId3">
               <a:alphaModFix/>
             </a:blip>
             <a:srcRect b="0" l="744" r="0" t="970"/>
@@ -6525,7 +6447,7 @@
         </p:pic>
         <p:sp>
           <p:nvSpPr>
-            <p:cNvPr id="65" name="Google Shape;65;p14"/>
+            <p:cNvPr id="63" name="Google Shape;63;p14"/>
             <p:cNvSpPr txBox="1"/>
             <p:nvPr/>
           </p:nvSpPr>
@@ -6577,7 +6499,7 @@
         </p:sp>
         <p:sp>
           <p:nvSpPr>
-            <p:cNvPr id="66" name="Google Shape;66;p14"/>
+            <p:cNvPr id="64" name="Google Shape;64;p14"/>
             <p:cNvSpPr txBox="1"/>
             <p:nvPr/>
           </p:nvSpPr>
@@ -6627,7 +6549,7 @@
         </p:sp>
         <p:sp>
           <p:nvSpPr>
-            <p:cNvPr id="67" name="Google Shape;67;p14"/>
+            <p:cNvPr id="65" name="Google Shape;65;p14"/>
             <p:cNvSpPr txBox="1"/>
             <p:nvPr/>
           </p:nvSpPr>
@@ -6677,7 +6599,7 @@
         </p:sp>
         <p:sp>
           <p:nvSpPr>
-            <p:cNvPr id="68" name="Google Shape;68;p14"/>
+            <p:cNvPr id="66" name="Google Shape;66;p14"/>
             <p:cNvSpPr txBox="1"/>
             <p:nvPr/>
           </p:nvSpPr>
@@ -6727,7 +6649,7 @@
         </p:sp>
         <p:sp>
           <p:nvSpPr>
-            <p:cNvPr id="69" name="Google Shape;69;p14"/>
+            <p:cNvPr id="67" name="Google Shape;67;p14"/>
             <p:cNvSpPr txBox="1"/>
             <p:nvPr/>
           </p:nvSpPr>
@@ -6779,7 +6701,7 @@
         </p:sp>
         <p:sp>
           <p:nvSpPr>
-            <p:cNvPr id="70" name="Google Shape;70;p14"/>
+            <p:cNvPr id="68" name="Google Shape;68;p14"/>
             <p:cNvSpPr txBox="1"/>
             <p:nvPr/>
           </p:nvSpPr>
@@ -6831,7 +6753,7 @@
         </p:sp>
         <p:sp>
           <p:nvSpPr>
-            <p:cNvPr id="71" name="Google Shape;71;p14"/>
+            <p:cNvPr id="69" name="Google Shape;69;p14"/>
             <p:cNvSpPr txBox="1"/>
             <p:nvPr/>
           </p:nvSpPr>
@@ -6895,7 +6817,7 @@
   <p:cSld>
     <p:spTree>
       <p:nvGrpSpPr>
-        <p:cNvPr id="75" name="Shape 75"/>
+        <p:cNvPr id="73" name="Shape 73"/>
         <p:cNvGrpSpPr/>
         <p:nvPr/>
       </p:nvGrpSpPr>
@@ -6909,7 +6831,7 @@
       </p:grpSpPr>
       <p:sp>
         <p:nvSpPr>
-          <p:cNvPr id="76" name="Google Shape;76;p15"/>
+          <p:cNvPr id="74" name="Google Shape;74;p15"/>
           <p:cNvSpPr txBox="1"/>
           <p:nvPr/>
         </p:nvSpPr>
@@ -6991,7 +6913,7 @@
       </p:sp>
       <p:grpSp>
         <p:nvGrpSpPr>
-          <p:cNvPr id="77" name="Google Shape;77;p15"/>
+          <p:cNvPr id="75" name="Google Shape;75;p15"/>
           <p:cNvGrpSpPr/>
           <p:nvPr/>
         </p:nvGrpSpPr>
@@ -7005,7 +6927,7 @@
         </p:grpSpPr>
         <p:pic>
           <p:nvPicPr>
-            <p:cNvPr id="78" name="Google Shape;78;p15"/>
+            <p:cNvPr id="76" name="Google Shape;76;p15"/>
             <p:cNvPicPr preferRelativeResize="0"/>
             <p:nvPr/>
           </p:nvPicPr>
@@ -7032,7 +6954,7 @@
         </p:pic>
         <p:sp>
           <p:nvSpPr>
-            <p:cNvPr id="79" name="Google Shape;79;p15"/>
+            <p:cNvPr id="77" name="Google Shape;77;p15"/>
             <p:cNvSpPr txBox="1"/>
             <p:nvPr/>
           </p:nvSpPr>
@@ -7084,7 +7006,7 @@
         </p:sp>
         <p:sp>
           <p:nvSpPr>
-            <p:cNvPr id="80" name="Google Shape;80;p15"/>
+            <p:cNvPr id="78" name="Google Shape;78;p15"/>
             <p:cNvSpPr txBox="1"/>
             <p:nvPr/>
           </p:nvSpPr>
@@ -7134,7 +7056,7 @@
         </p:sp>
         <p:sp>
           <p:nvSpPr>
-            <p:cNvPr id="81" name="Google Shape;81;p15"/>
+            <p:cNvPr id="79" name="Google Shape;79;p15"/>
             <p:cNvSpPr txBox="1"/>
             <p:nvPr/>
           </p:nvSpPr>
@@ -7186,7 +7108,7 @@
         </p:sp>
         <p:sp>
           <p:nvSpPr>
-            <p:cNvPr id="82" name="Google Shape;82;p15"/>
+            <p:cNvPr id="80" name="Google Shape;80;p15"/>
             <p:cNvSpPr txBox="1"/>
             <p:nvPr/>
           </p:nvSpPr>
@@ -7238,7 +7160,7 @@
         </p:sp>
         <p:sp>
           <p:nvSpPr>
-            <p:cNvPr id="83" name="Google Shape;83;p15"/>
+            <p:cNvPr id="81" name="Google Shape;81;p15"/>
             <p:cNvSpPr txBox="1"/>
             <p:nvPr/>
           </p:nvSpPr>
@@ -7290,7 +7212,7 @@
         </p:sp>
         <p:sp>
           <p:nvSpPr>
-            <p:cNvPr id="84" name="Google Shape;84;p15"/>
+            <p:cNvPr id="82" name="Google Shape;82;p15"/>
             <p:cNvSpPr txBox="1"/>
             <p:nvPr/>
           </p:nvSpPr>
@@ -7348,7 +7270,7 @@
         </p:sp>
         <p:sp>
           <p:nvSpPr>
-            <p:cNvPr id="85" name="Google Shape;85;p15"/>
+            <p:cNvPr id="83" name="Google Shape;83;p15"/>
             <p:cNvSpPr txBox="1"/>
             <p:nvPr/>
           </p:nvSpPr>
@@ -7399,7 +7321,7 @@
       </p:grpSp>
       <p:grpSp>
         <p:nvGrpSpPr>
-          <p:cNvPr id="86" name="Google Shape;86;p15"/>
+          <p:cNvPr id="84" name="Google Shape;84;p15"/>
           <p:cNvGrpSpPr/>
           <p:nvPr/>
         </p:nvGrpSpPr>
@@ -7413,7 +7335,7 @@
         </p:grpSpPr>
         <p:grpSp>
           <p:nvGrpSpPr>
-            <p:cNvPr id="87" name="Google Shape;87;p15"/>
+            <p:cNvPr id="85" name="Google Shape;85;p15"/>
             <p:cNvGrpSpPr/>
             <p:nvPr/>
           </p:nvGrpSpPr>
@@ -7427,7 +7349,7 @@
           </p:grpSpPr>
           <p:pic>
             <p:nvPicPr>
-              <p:cNvPr id="88" name="Google Shape;88;p15" title="gc_bias_bars.jpg"/>
+              <p:cNvPr id="86" name="Google Shape;86;p15" title="gc_bias_bars.jpg"/>
               <p:cNvPicPr preferRelativeResize="0"/>
               <p:nvPr/>
             </p:nvPicPr>
@@ -7455,7 +7377,7 @@
           </p:pic>
           <p:sp>
             <p:nvSpPr>
-              <p:cNvPr id="89" name="Google Shape;89;p15"/>
+              <p:cNvPr id="87" name="Google Shape;87;p15"/>
               <p:cNvSpPr txBox="1"/>
               <p:nvPr/>
             </p:nvSpPr>
@@ -7505,7 +7427,7 @@
           </p:sp>
           <p:sp>
             <p:nvSpPr>
-              <p:cNvPr id="90" name="Google Shape;90;p15"/>
+              <p:cNvPr id="88" name="Google Shape;88;p15"/>
               <p:cNvSpPr txBox="1"/>
               <p:nvPr/>
             </p:nvSpPr>
@@ -7556,7 +7478,7 @@
         </p:grpSp>
         <p:sp>
           <p:nvSpPr>
-            <p:cNvPr id="91" name="Google Shape;91;p15"/>
+            <p:cNvPr id="89" name="Google Shape;89;p15"/>
             <p:cNvSpPr/>
             <p:nvPr/>
           </p:nvSpPr>
@@ -7605,7 +7527,7 @@
         </p:sp>
         <p:sp>
           <p:nvSpPr>
-            <p:cNvPr id="92" name="Google Shape;92;p15"/>
+            <p:cNvPr id="90" name="Google Shape;90;p15"/>
             <p:cNvSpPr/>
             <p:nvPr/>
           </p:nvSpPr>
@@ -7655,7 +7577,7 @@
       </p:grpSp>
       <p:grpSp>
         <p:nvGrpSpPr>
-          <p:cNvPr id="93" name="Google Shape;93;p15"/>
+          <p:cNvPr id="91" name="Google Shape;91;p15"/>
           <p:cNvGrpSpPr/>
           <p:nvPr/>
         </p:nvGrpSpPr>
@@ -7669,7 +7591,7 @@
         </p:grpSpPr>
         <p:pic>
           <p:nvPicPr>
-            <p:cNvPr id="94" name="Google Shape;94;p15" title="gc_bias_violin.jpg"/>
+            <p:cNvPr id="92" name="Google Shape;92;p15" title="gc_bias_violin.jpg"/>
             <p:cNvPicPr preferRelativeResize="0"/>
             <p:nvPr/>
           </p:nvPicPr>
@@ -7696,7 +7618,7 @@
         </p:pic>
         <p:sp>
           <p:nvSpPr>
-            <p:cNvPr id="95" name="Google Shape;95;p15"/>
+            <p:cNvPr id="93" name="Google Shape;93;p15"/>
             <p:cNvSpPr txBox="1"/>
             <p:nvPr/>
           </p:nvSpPr>
@@ -7770,7 +7692,7 @@
         </p:sp>
         <p:sp>
           <p:nvSpPr>
-            <p:cNvPr id="96" name="Google Shape;96;p15"/>
+            <p:cNvPr id="94" name="Google Shape;94;p15"/>
             <p:cNvSpPr txBox="1"/>
             <p:nvPr/>
           </p:nvSpPr>
@@ -7829,7 +7751,7 @@
       </p:grpSp>
       <p:pic>
         <p:nvPicPr>
-          <p:cNvPr id="97" name="Google Shape;97;p15" title="g4_retencion_por_gc.jpg"/>
+          <p:cNvPr id="95" name="Google Shape;95;p15" title="g4_retencion_por_gc.jpg"/>
           <p:cNvPicPr preferRelativeResize="0"/>
           <p:nvPr/>
         </p:nvPicPr>
@@ -7857,7 +7779,7 @@
       </p:pic>
       <p:sp>
         <p:nvSpPr>
-          <p:cNvPr id="98" name="Google Shape;98;p15"/>
+          <p:cNvPr id="96" name="Google Shape;96;p15"/>
           <p:cNvSpPr txBox="1"/>
           <p:nvPr/>
         </p:nvSpPr>
@@ -7978,7 +7900,7 @@
   <p:cSld>
     <p:spTree>
       <p:nvGrpSpPr>
-        <p:cNvPr id="102" name="Shape 102"/>
+        <p:cNvPr id="100" name="Shape 100"/>
         <p:cNvGrpSpPr/>
         <p:nvPr/>
       </p:nvGrpSpPr>
@@ -7992,7 +7914,7 @@
       </p:grpSpPr>
       <p:pic>
         <p:nvPicPr>
-          <p:cNvPr id="103" name="Google Shape;103;p16"/>
+          <p:cNvPr id="101" name="Google Shape;101;p16"/>
           <p:cNvPicPr preferRelativeResize="0"/>
           <p:nvPr/>
         </p:nvPicPr>
@@ -8020,7 +7942,7 @@
       </p:pic>
       <p:sp>
         <p:nvSpPr>
-          <p:cNvPr id="104" name="Google Shape;104;p16"/>
+          <p:cNvPr id="102" name="Google Shape;102;p16"/>
           <p:cNvSpPr txBox="1"/>
           <p:nvPr/>
         </p:nvSpPr>
@@ -8172,7 +8094,7 @@
   <p:cSld>
     <p:spTree>
       <p:nvGrpSpPr>
-        <p:cNvPr id="108" name="Shape 108"/>
+        <p:cNvPr id="106" name="Shape 106"/>
         <p:cNvGrpSpPr/>
         <p:nvPr/>
       </p:nvGrpSpPr>
@@ -8186,7 +8108,7 @@
       </p:grpSpPr>
       <p:sp>
         <p:nvSpPr>
-          <p:cNvPr id="109" name="Google Shape;109;p17"/>
+          <p:cNvPr id="107" name="Google Shape;107;p17"/>
           <p:cNvSpPr txBox="1"/>
           <p:nvPr/>
         </p:nvSpPr>
@@ -8292,7 +8214,7 @@
       </p:sp>
       <p:pic>
         <p:nvPicPr>
-          <p:cNvPr id="110" name="Google Shape;110;p17" title="histograma_gates_KIAA0753.jpg"/>
+          <p:cNvPr id="108" name="Google Shape;108;p17" title="histograma_gates_KIAA0753.jpg"/>
           <p:cNvPicPr preferRelativeResize="0"/>
           <p:nvPr/>
         </p:nvPicPr>
@@ -8331,7 +8253,7 @@
   <p:cSld>
     <p:spTree>
       <p:nvGrpSpPr>
-        <p:cNvPr id="114" name="Shape 114"/>
+        <p:cNvPr id="112" name="Shape 112"/>
         <p:cNvGrpSpPr/>
         <p:nvPr/>
       </p:nvGrpSpPr>
@@ -8345,7 +8267,7 @@
       </p:grpSpPr>
       <p:pic>
         <p:nvPicPr>
-          <p:cNvPr id="115" name="Google Shape;115;p18" title="extra_densidad_individual.jpg"/>
+          <p:cNvPr id="113" name="Google Shape;113;p18" title="extra_densidad_individual.jpg"/>
           <p:cNvPicPr preferRelativeResize="0"/>
           <p:nvPr/>
         </p:nvPicPr>
@@ -8373,7 +8295,7 @@
       </p:pic>
       <p:sp>
         <p:nvSpPr>
-          <p:cNvPr id="116" name="Google Shape;116;p18"/>
+          <p:cNvPr id="114" name="Google Shape;114;p18"/>
           <p:cNvSpPr txBox="1"/>
           <p:nvPr/>
         </p:nvSpPr>
@@ -8494,7 +8416,7 @@
   <p:cSld>
     <p:spTree>
       <p:nvGrpSpPr>
-        <p:cNvPr id="120" name="Shape 120"/>
+        <p:cNvPr id="118" name="Shape 118"/>
         <p:cNvGrpSpPr/>
         <p:nvPr/>
       </p:nvGrpSpPr>
@@ -8508,7 +8430,7 @@
       </p:grpSpPr>
       <p:pic>
         <p:nvPicPr>
-          <p:cNvPr id="121" name="Google Shape;121;p19"/>
+          <p:cNvPr id="119" name="Google Shape;119;p19"/>
           <p:cNvPicPr preferRelativeResize="0"/>
           <p:nvPr/>
         </p:nvPicPr>
@@ -8536,7 +8458,7 @@
       </p:pic>
       <p:pic>
         <p:nvPicPr>
-          <p:cNvPr id="122" name="Google Shape;122;p19"/>
+          <p:cNvPr id="120" name="Google Shape;120;p19"/>
           <p:cNvPicPr preferRelativeResize="0"/>
           <p:nvPr/>
         </p:nvPicPr>
@@ -8564,7 +8486,7 @@
       </p:pic>
       <p:sp>
         <p:nvSpPr>
-          <p:cNvPr id="123" name="Google Shape;123;p19"/>
+          <p:cNvPr id="121" name="Google Shape;121;p19"/>
           <p:cNvSpPr txBox="1"/>
           <p:nvPr/>
         </p:nvSpPr>
@@ -8670,7 +8592,7 @@
       </p:sp>
       <p:pic>
         <p:nvPicPr>
-          <p:cNvPr id="124" name="Google Shape;124;p19" title="panel_b_histograma_gates_ejemplo.jpg"/>
+          <p:cNvPr id="122" name="Google Shape;122;p19" title="panel_b_histograma_gates_ejemplo.jpg"/>
           <p:cNvPicPr preferRelativeResize="0"/>
           <p:nvPr/>
         </p:nvPicPr>
@@ -8709,7 +8631,7 @@
   <p:cSld>
     <p:spTree>
       <p:nvGrpSpPr>
-        <p:cNvPr id="128" name="Shape 128"/>
+        <p:cNvPr id="126" name="Shape 126"/>
         <p:cNvGrpSpPr/>
         <p:nvPr/>
       </p:nvGrpSpPr>
@@ -8723,7 +8645,7 @@
       </p:grpSpPr>
       <p:grpSp>
         <p:nvGrpSpPr>
-          <p:cNvPr id="129" name="Google Shape;129;p20"/>
+          <p:cNvPr id="127" name="Google Shape;127;p20"/>
           <p:cNvGrpSpPr/>
           <p:nvPr/>
         </p:nvGrpSpPr>
@@ -8737,7 +8659,7 @@
         </p:grpSpPr>
         <p:pic>
           <p:nvPicPr>
-            <p:cNvPr id="130" name="Google Shape;130;p20"/>
+            <p:cNvPr id="128" name="Google Shape;128;p20"/>
             <p:cNvPicPr preferRelativeResize="0"/>
             <p:nvPr/>
           </p:nvPicPr>
@@ -8764,7 +8686,7 @@
         </p:pic>
         <p:sp>
           <p:nvSpPr>
-            <p:cNvPr id="131" name="Google Shape;131;p20"/>
+            <p:cNvPr id="129" name="Google Shape;129;p20"/>
             <p:cNvSpPr txBox="1"/>
             <p:nvPr/>
           </p:nvSpPr>
@@ -8816,7 +8738,7 @@
         </p:sp>
         <p:sp>
           <p:nvSpPr>
-            <p:cNvPr id="132" name="Google Shape;132;p20"/>
+            <p:cNvPr id="130" name="Google Shape;130;p20"/>
             <p:cNvSpPr txBox="1"/>
             <p:nvPr/>
           </p:nvSpPr>
@@ -8866,7 +8788,7 @@
         </p:sp>
         <p:sp>
           <p:nvSpPr>
-            <p:cNvPr id="133" name="Google Shape;133;p20"/>
+            <p:cNvPr id="131" name="Google Shape;131;p20"/>
             <p:cNvSpPr txBox="1"/>
             <p:nvPr/>
           </p:nvSpPr>
@@ -8916,7 +8838,7 @@
         </p:sp>
         <p:sp>
           <p:nvSpPr>
-            <p:cNvPr id="134" name="Google Shape;134;p20"/>
+            <p:cNvPr id="132" name="Google Shape;132;p20"/>
             <p:cNvSpPr txBox="1"/>
             <p:nvPr/>
           </p:nvSpPr>
@@ -8966,7 +8888,7 @@
         </p:sp>
         <p:sp>
           <p:nvSpPr>
-            <p:cNvPr id="135" name="Google Shape;135;p20"/>
+            <p:cNvPr id="133" name="Google Shape;133;p20"/>
             <p:cNvSpPr txBox="1"/>
             <p:nvPr/>
           </p:nvSpPr>
@@ -9018,7 +8940,7 @@
         </p:sp>
         <p:sp>
           <p:nvSpPr>
-            <p:cNvPr id="136" name="Google Shape;136;p20"/>
+            <p:cNvPr id="134" name="Google Shape;134;p20"/>
             <p:cNvSpPr txBox="1"/>
             <p:nvPr/>
           </p:nvSpPr>
@@ -9070,7 +8992,7 @@
         </p:sp>
         <p:sp>
           <p:nvSpPr>
-            <p:cNvPr id="137" name="Google Shape;137;p20"/>
+            <p:cNvPr id="135" name="Google Shape;135;p20"/>
             <p:cNvSpPr txBox="1"/>
             <p:nvPr/>
           </p:nvSpPr>
@@ -9128,7 +9050,7 @@
       </p:grpSp>
       <p:sp>
         <p:nvSpPr>
-          <p:cNvPr id="138" name="Google Shape;138;p20"/>
+          <p:cNvPr id="136" name="Google Shape;136;p20"/>
           <p:cNvSpPr txBox="1"/>
           <p:nvPr/>
         </p:nvSpPr>
@@ -9305,7 +9227,7 @@
       </p:sp>
       <p:grpSp>
         <p:nvGrpSpPr>
-          <p:cNvPr id="139" name="Google Shape;139;p20"/>
+          <p:cNvPr id="137" name="Google Shape;137;p20"/>
           <p:cNvGrpSpPr/>
           <p:nvPr/>
         </p:nvGrpSpPr>
@@ -9319,7 +9241,7 @@
         </p:grpSpPr>
         <p:pic>
           <p:nvPicPr>
-            <p:cNvPr id="140" name="Google Shape;140;p20" title="mean_replicates_prefilter.jpg"/>
+            <p:cNvPr id="138" name="Google Shape;138;p20" title="mean_replicates_prefilter.jpg"/>
             <p:cNvPicPr preferRelativeResize="0"/>
             <p:nvPr/>
           </p:nvPicPr>
@@ -9346,7 +9268,7 @@
         </p:pic>
         <p:pic>
           <p:nvPicPr>
-            <p:cNvPr id="141" name="Google Shape;141;p20" title="mean_replicates_prefilter.jpg"/>
+            <p:cNvPr id="139" name="Google Shape;139;p20" title="mean_replicates_prefilter.jpg"/>
             <p:cNvPicPr preferRelativeResize="0"/>
             <p:nvPr/>
           </p:nvPicPr>
@@ -9373,7 +9295,7 @@
         </p:pic>
         <p:pic>
           <p:nvPicPr>
-            <p:cNvPr id="142" name="Google Shape;142;p20" title="mean_replicates_prefilter.jpg"/>
+            <p:cNvPr id="140" name="Google Shape;140;p20" title="mean_replicates_prefilter.jpg"/>
             <p:cNvPicPr preferRelativeResize="0"/>
             <p:nvPr/>
           </p:nvPicPr>
@@ -9401,7 +9323,7 @@
       </p:grpSp>
       <p:pic>
         <p:nvPicPr>
-          <p:cNvPr id="143" name="Google Shape;143;p20" title="mean_replicates_postfilter.jpg"/>
+          <p:cNvPr id="141" name="Google Shape;141;p20" title="mean_replicates_postfilter.jpg"/>
           <p:cNvPicPr preferRelativeResize="0"/>
           <p:nvPr/>
         </p:nvPicPr>
@@ -9429,7 +9351,7 @@
       </p:pic>
       <p:pic>
         <p:nvPicPr>
-          <p:cNvPr id="144" name="Google Shape;144;p20" title="panel_d_var_replicates.jpg"/>
+          <p:cNvPr id="142" name="Google Shape;142;p20" title="panel_d_var_replicates.jpg"/>
           <p:cNvPicPr preferRelativeResize="0"/>
           <p:nvPr/>
         </p:nvPicPr>

</xml_diff>

<commit_message>
docs: resync figure numbering from Drive decks (2026-10-28)
Decks con cambios de contenido: Fig MyM, Fig R1, Fig R2, Fig R3.
Sin cambios de numeracion: cada slide sigue correspondiendo al mismo slug en docs/mapping_figuras.csv.

Co-Authored-By: Claude Opus 5.5 <noreply@anthropic.com>
</commit_message>
<xml_diff>
--- a/docs/Fig R1.pptx
+++ b/docs/Fig R1.pptx
@@ -16,7 +16,6 @@
     <p:sldId id="261" r:id="rId11"/>
     <p:sldId id="262" r:id="rId12"/>
     <p:sldId id="263" r:id="rId13"/>
-    <p:sldId id="264" r:id="rId14"/>
   </p:sldIdLst>
   <p:sldSz cy="5143500" cx="9144000"/>
   <p:notesSz cx="6858000" cy="9144000"/>
@@ -1406,7 +1405,7 @@
       </p:grpSpPr>
       <p:sp>
         <p:nvSpPr>
-          <p:cNvPr id="88" name="Google Shape;88;g3f5e045cd8f_0_2:notes"/>
+          <p:cNvPr id="88" name="Google Shape;88;g3d678bf7346_0_23:notes"/>
           <p:cNvSpPr/>
           <p:nvPr>
             <p:ph idx="2" type="sldImg"/>
@@ -1441,106 +1440,7 @@
       </p:sp>
       <p:sp>
         <p:nvSpPr>
-          <p:cNvPr id="89" name="Google Shape;89;g3f5e045cd8f_0_2:notes"/>
-          <p:cNvSpPr txBox="1"/>
-          <p:nvPr>
-            <p:ph idx="1" type="body"/>
-          </p:nvPr>
-        </p:nvSpPr>
-        <p:spPr>
-          <a:xfrm>
-            <a:off x="685800" y="4343400"/>
-            <a:ext cx="5486400" cy="4114800"/>
-          </a:xfrm>
-          <a:prstGeom prst="rect">
-            <a:avLst/>
-          </a:prstGeom>
-        </p:spPr>
-        <p:txBody>
-          <a:bodyPr anchorCtr="0" anchor="t" bIns="91425" lIns="91425" spcFirstLastPara="1" rIns="91425" wrap="square" tIns="91425">
-            <a:noAutofit/>
-          </a:bodyPr>
-          <a:lstStyle/>
-          <a:p>
-            <a:pPr indent="0" lvl="0" marL="0" rtl="0" algn="l">
-              <a:spcBef>
-                <a:spcPts val="0"/>
-              </a:spcBef>
-              <a:spcAft>
-                <a:spcPts val="0"/>
-              </a:spcAft>
-              <a:buNone/>
-            </a:pPr>
-            <a:r>
-              <a:t/>
-            </a:r>
-            <a:endParaRPr/>
-          </a:p>
-        </p:txBody>
-      </p:sp>
-    </p:spTree>
-  </p:cSld>
-  <p:clrMapOvr>
-    <a:masterClrMapping/>
-  </p:clrMapOvr>
-</p:notes>
-</file>
-
-<file path=ppt/notesSlides/notesSlide9.xml><?xml version="1.0" encoding="utf-8"?>
-<p:notes xmlns:a="http://schemas.openxmlformats.org/drawingml/2006/main" xmlns:r="http://schemas.openxmlformats.org/officeDocument/2006/relationships" xmlns:mc="http://schemas.openxmlformats.org/markup-compatibility/2006" xmlns:mv="urn:schemas-microsoft-com:mac:vml" xmlns:p="http://schemas.openxmlformats.org/presentationml/2006/main" xmlns:c="http://schemas.openxmlformats.org/drawingml/2006/chart" xmlns:dgm="http://schemas.openxmlformats.org/drawingml/2006/diagram" xmlns:o="urn:schemas-microsoft-com:office:office" xmlns:v="urn:schemas-microsoft-com:vml" xmlns:pvml="urn:schemas-microsoft-com:office:powerpoint" xmlns:com="http://schemas.openxmlformats.org/drawingml/2006/compatibility" xmlns:p14="http://schemas.microsoft.com/office/powerpoint/2010/main" xmlns:p15="http://schemas.microsoft.com/office/powerpoint/2012/main" xmlns:ahyp="http://schemas.microsoft.com/office/drawing/2018/hyperlinkcolor" showMasterPhAnim="0" showMasterSp="0">
-  <p:cSld>
-    <p:spTree>
-      <p:nvGrpSpPr>
-        <p:cNvPr id="92" name="Shape 92"/>
-        <p:cNvGrpSpPr/>
-        <p:nvPr/>
-      </p:nvGrpSpPr>
-      <p:grpSpPr>
-        <a:xfrm>
-          <a:off x="0" y="0"/>
-          <a:ext cx="0" cy="0"/>
-          <a:chOff x="0" y="0"/>
-          <a:chExt cx="0" cy="0"/>
-        </a:xfrm>
-      </p:grpSpPr>
-      <p:sp>
-        <p:nvSpPr>
-          <p:cNvPr id="93" name="Google Shape;93;g3d678bf7346_0_23:notes"/>
-          <p:cNvSpPr/>
-          <p:nvPr>
-            <p:ph idx="2" type="sldImg"/>
-          </p:nvPr>
-        </p:nvSpPr>
-        <p:spPr>
-          <a:xfrm>
-            <a:off x="381300" y="685800"/>
-            <a:ext cx="6096000" cy="3429000"/>
-          </a:xfrm>
-          <a:custGeom>
-            <a:rect b="b" l="l" r="r" t="t"/>
-            <a:pathLst>
-              <a:path extrusionOk="0" h="120000" w="120000">
-                <a:moveTo>
-                  <a:pt x="0" y="0"/>
-                </a:moveTo>
-                <a:lnTo>
-                  <a:pt x="120000" y="0"/>
-                </a:lnTo>
-                <a:lnTo>
-                  <a:pt x="120000" y="120000"/>
-                </a:lnTo>
-                <a:lnTo>
-                  <a:pt x="0" y="120000"/>
-                </a:lnTo>
-                <a:close/>
-              </a:path>
-            </a:pathLst>
-          </a:custGeom>
-        </p:spPr>
-      </p:sp>
-      <p:sp>
-        <p:nvSpPr>
-          <p:cNvPr id="94" name="Google Shape;94;g3d678bf7346_0_23:notes"/>
+          <p:cNvPr id="89" name="Google Shape;89;g3d678bf7346_0_23:notes"/>
           <p:cNvSpPr txBox="1"/>
           <p:nvPr>
             <p:ph idx="1" type="body"/>
@@ -6680,60 +6580,7 @@
       </p:grpSpPr>
       <p:pic>
         <p:nvPicPr>
-          <p:cNvPr id="91" name="Google Shape;91;p20" title="densidad_individual_promotores.jpg"/>
-          <p:cNvPicPr preferRelativeResize="0"/>
-          <p:nvPr/>
-        </p:nvPicPr>
-        <p:blipFill>
-          <a:blip r:embed="rId3">
-            <a:alphaModFix/>
-          </a:blip>
-          <a:stretch>
-            <a:fillRect/>
-          </a:stretch>
-        </p:blipFill>
-        <p:spPr>
-          <a:xfrm>
-            <a:off x="1382025" y="136325"/>
-            <a:ext cx="4761933" cy="3571450"/>
-          </a:xfrm>
-          <a:prstGeom prst="rect">
-            <a:avLst/>
-          </a:prstGeom>
-          <a:noFill/>
-          <a:ln>
-            <a:noFill/>
-          </a:ln>
-        </p:spPr>
-      </p:pic>
-    </p:spTree>
-  </p:cSld>
-  <p:clrMapOvr>
-    <a:masterClrMapping/>
-  </p:clrMapOvr>
-</p:sld>
-</file>
-
-<file path=ppt/slides/slide9.xml><?xml version="1.0" encoding="utf-8"?>
-<p:sld xmlns:a="http://schemas.openxmlformats.org/drawingml/2006/main" xmlns:r="http://schemas.openxmlformats.org/officeDocument/2006/relationships" xmlns:mc="http://schemas.openxmlformats.org/markup-compatibility/2006" xmlns:mv="urn:schemas-microsoft-com:mac:vml" xmlns:p="http://schemas.openxmlformats.org/presentationml/2006/main" xmlns:c="http://schemas.openxmlformats.org/drawingml/2006/chart" xmlns:dgm="http://schemas.openxmlformats.org/drawingml/2006/diagram" xmlns:o="urn:schemas-microsoft-com:office:office" xmlns:v="urn:schemas-microsoft-com:vml" xmlns:pvml="urn:schemas-microsoft-com:office:powerpoint" xmlns:com="http://schemas.openxmlformats.org/drawingml/2006/compatibility" xmlns:p14="http://schemas.microsoft.com/office/powerpoint/2010/main" xmlns:p15="http://schemas.microsoft.com/office/powerpoint/2012/main" xmlns:ahyp="http://schemas.microsoft.com/office/drawing/2018/hyperlinkcolor">
-  <p:cSld>
-    <p:spTree>
-      <p:nvGrpSpPr>
-        <p:cNvPr id="95" name="Shape 95"/>
-        <p:cNvGrpSpPr/>
-        <p:nvPr/>
-      </p:nvGrpSpPr>
-      <p:grpSpPr>
-        <a:xfrm>
-          <a:off x="0" y="0"/>
-          <a:ext cx="0" cy="0"/>
-          <a:chOff x="0" y="0"/>
-          <a:chExt cx="0" cy="0"/>
-        </a:xfrm>
-      </p:grpSpPr>
-      <p:pic>
-        <p:nvPicPr>
-          <p:cNvPr id="96" name="Google Shape;96;p21"/>
+          <p:cNvPr id="91" name="Google Shape;91;p20"/>
           <p:cNvPicPr preferRelativeResize="0"/>
           <p:nvPr/>
         </p:nvPicPr>
@@ -6761,7 +6608,7 @@
       </p:pic>
       <p:pic>
         <p:nvPicPr>
-          <p:cNvPr id="97" name="Google Shape;97;p21"/>
+          <p:cNvPr id="92" name="Google Shape;92;p20"/>
           <p:cNvPicPr preferRelativeResize="0"/>
           <p:nvPr/>
         </p:nvPicPr>
@@ -6789,7 +6636,7 @@
       </p:pic>
       <p:sp>
         <p:nvSpPr>
-          <p:cNvPr id="98" name="Google Shape;98;p21"/>
+          <p:cNvPr id="93" name="Google Shape;93;p20"/>
           <p:cNvSpPr txBox="1"/>
           <p:nvPr/>
         </p:nvSpPr>
@@ -6895,7 +6742,7 @@
       </p:sp>
       <p:pic>
         <p:nvPicPr>
-          <p:cNvPr id="99" name="Google Shape;99;p21" title="panel_b_histograma_gates_ejemplo.jpg"/>
+          <p:cNvPr id="94" name="Google Shape;94;p20" title="panel_b_histograma_gates_ejemplo.jpg"/>
           <p:cNvPicPr preferRelativeResize="0"/>
           <p:nvPr/>
         </p:nvPicPr>

</xml_diff>